<commit_message>
feat(deliverables): replace placeholder deliverables with authentic OpenXML decks, multi-sheet formula spreadsheets, and interactive HTML website prototypes
</commit_message>
<xml_diff>
--- a/public/chat_files/alexa_10slide_investor_pitch.pptx
+++ b/public/chat_files/alexa_10slide_investor_pitch.pptx
@@ -107,7 +107,7 @@
           <a:lstStyle/>
           <a:p>
             <a:r>
-              <a:rPr lang="en-US" sz="2800" b="1"/>
+              <a:rPr lang="en-US" sz="2400" b="1"/>
               <a:t>FieldPulse: Automated Mobile Dispatch for Trade Fleets</a:t>
             </a:r>
           </a:p>
@@ -133,16 +133,22 @@
           <a:bodyPr/>
           <a:lstStyle/>
           <a:p>
-            <a:pPr lvl="0"/>
-            <a:r>
-              <a:rPr lang="en-US" sz="1600"/>
+            <a:pPr lvl="0" marL="288000" indent="-288000">
+              <a:buFont typeface="Arial"/>
+              <a:buChar char="•"/>
+            </a:pPr>
+            <a:r>
+              <a:rPr lang="en-US" sz="1500"/>
               <a:t>Presented by Alexa Quintero, Founder &amp; CEO</a:t>
             </a:r>
           </a:p>
           <a:p>
-            <a:pPr lvl="0"/>
-            <a:r>
-              <a:rPr lang="en-US" sz="1600"/>
+            <a:pPr lvl="0" marL="288000" indent="-288000">
+              <a:buFont typeface="Arial"/>
+              <a:buChar char="•"/>
+            </a:pPr>
+            <a:r>
+              <a:rPr lang="en-US" sz="1500"/>
               <a:t>Targeting the $8.2B North American Trade &amp; Field Services Market</a:t>
             </a:r>
           </a:p>
@@ -191,7 +197,7 @@
           <a:lstStyle/>
           <a:p>
             <a:r>
-              <a:rPr lang="en-US" sz="2800" b="1"/>
+              <a:rPr lang="en-US" sz="2400" b="1"/>
               <a:t>The Ask: $750,000 Pre-Seed Round</a:t>
             </a:r>
           </a:p>
@@ -217,23 +223,32 @@
           <a:bodyPr/>
           <a:lstStyle/>
           <a:p>
-            <a:pPr lvl="0"/>
-            <a:r>
-              <a:rPr lang="en-US" sz="1600"/>
+            <a:pPr lvl="0" marL="288000" indent="-288000">
+              <a:buFont typeface="Arial"/>
+              <a:buChar char="•"/>
+            </a:pPr>
+            <a:r>
+              <a:rPr lang="en-US" sz="1500"/>
               <a:t>65% dedicated to engineering &amp; offline sync hardening</a:t>
             </a:r>
           </a:p>
           <a:p>
-            <a:pPr lvl="0"/>
-            <a:r>
-              <a:rPr lang="en-US" sz="1600"/>
+            <a:pPr lvl="0" marL="288000" indent="-288000">
+              <a:buFont typeface="Arial"/>
+              <a:buChar char="•"/>
+            </a:pPr>
+            <a:r>
+              <a:rPr lang="en-US" sz="1500"/>
               <a:t>25% to initial customer acquisition and trade show sponsorships</a:t>
             </a:r>
           </a:p>
           <a:p>
-            <a:pPr lvl="0"/>
-            <a:r>
-              <a:rPr lang="en-US" sz="1600"/>
+            <a:pPr lvl="0" marL="288000" indent="-288000">
+              <a:buFont typeface="Arial"/>
+              <a:buChar char="•"/>
+            </a:pPr>
+            <a:r>
+              <a:rPr lang="en-US" sz="1500"/>
               <a:t>10% working capital and reserve runway</a:t>
             </a:r>
           </a:p>
@@ -282,7 +297,7 @@
           <a:lstStyle/>
           <a:p>
             <a:r>
-              <a:rPr lang="en-US" sz="2800" b="1"/>
+              <a:rPr lang="en-US" sz="2400" b="1"/>
               <a:t>The Problem: Broken Field Communication</a:t>
             </a:r>
           </a:p>
@@ -308,23 +323,32 @@
           <a:bodyPr/>
           <a:lstStyle/>
           <a:p>
-            <a:pPr lvl="0"/>
-            <a:r>
-              <a:rPr lang="en-US" sz="1600"/>
+            <a:pPr lvl="0" marL="288000" indent="-288000">
+              <a:buFont typeface="Arial"/>
+              <a:buChar char="•"/>
+            </a:pPr>
+            <a:r>
+              <a:rPr lang="en-US" sz="1500"/>
               <a:t>Field technicians spend 2.4 hours daily on manual paper logs</a:t>
             </a:r>
           </a:p>
           <a:p>
-            <a:pPr lvl="0"/>
-            <a:r>
-              <a:rPr lang="en-US" sz="1600"/>
+            <a:pPr lvl="0" marL="288000" indent="-288000">
+              <a:buFont typeface="Arial"/>
+              <a:buChar char="•"/>
+            </a:pPr>
+            <a:r>
+              <a:rPr lang="en-US" sz="1500"/>
               <a:t>Dispatchers scramble across phone calls, whiteboards, and text threads</a:t>
             </a:r>
           </a:p>
           <a:p>
-            <a:pPr lvl="0"/>
-            <a:r>
-              <a:rPr lang="en-US" sz="1600"/>
+            <a:pPr lvl="0" marL="288000" indent="-288000">
+              <a:buFont typeface="Arial"/>
+              <a:buChar char="•"/>
+            </a:pPr>
+            <a:r>
+              <a:rPr lang="en-US" sz="1500"/>
               <a:t>Lost invoices and uncollected change orders bleed 8% of trade contractor margins</a:t>
             </a:r>
           </a:p>
@@ -373,7 +397,7 @@
           <a:lstStyle/>
           <a:p>
             <a:r>
-              <a:rPr lang="en-US" sz="2800" b="1"/>
+              <a:rPr lang="en-US" sz="2400" b="1"/>
               <a:t>The Solution: Real-Time Mobile Workflows</a:t>
             </a:r>
           </a:p>
@@ -399,23 +423,32 @@
           <a:bodyPr/>
           <a:lstStyle/>
           <a:p>
-            <a:pPr lvl="0"/>
-            <a:r>
-              <a:rPr lang="en-US" sz="1600"/>
+            <a:pPr lvl="0" marL="288000" indent="-288000">
+              <a:buFont typeface="Arial"/>
+              <a:buChar char="•"/>
+            </a:pPr>
+            <a:r>
+              <a:rPr lang="en-US" sz="1500"/>
               <a:t>One-tap dispatch with GPS turn-by-turn routing</a:t>
             </a:r>
           </a:p>
           <a:p>
-            <a:pPr lvl="0"/>
-            <a:r>
-              <a:rPr lang="en-US" sz="1600"/>
+            <a:pPr lvl="0" marL="288000" indent="-288000">
+              <a:buFont typeface="Arial"/>
+              <a:buChar char="•"/>
+            </a:pPr>
+            <a:r>
+              <a:rPr lang="en-US" sz="1500"/>
               <a:t>Offline mobile sign-off with instant photo attachments</a:t>
             </a:r>
           </a:p>
           <a:p>
-            <a:pPr lvl="0"/>
-            <a:r>
-              <a:rPr lang="en-US" sz="1600"/>
+            <a:pPr lvl="0" marL="288000" indent="-288000">
+              <a:buFont typeface="Arial"/>
+              <a:buChar char="•"/>
+            </a:pPr>
+            <a:r>
+              <a:rPr lang="en-US" sz="1500"/>
               <a:t>Automated customer invoicing and integrated payment collection</a:t>
             </a:r>
           </a:p>
@@ -464,7 +497,7 @@
           <a:lstStyle/>
           <a:p>
             <a:r>
-              <a:rPr lang="en-US" sz="2800" b="1"/>
+              <a:rPr lang="en-US" sz="2400" b="1"/>
               <a:t>Market Opportunity: $8.2B TAM</a:t>
             </a:r>
           </a:p>
@@ -490,23 +523,32 @@
           <a:bodyPr/>
           <a:lstStyle/>
           <a:p>
-            <a:pPr lvl="0"/>
-            <a:r>
-              <a:rPr lang="en-US" sz="1600"/>
+            <a:pPr lvl="0" marL="288000" indent="-288000">
+              <a:buFont typeface="Arial"/>
+              <a:buChar char="•"/>
+            </a:pPr>
+            <a:r>
+              <a:rPr lang="en-US" sz="1500"/>
               <a:t>1.2 million independent trade and field service businesses in the US &amp; Canada</a:t>
             </a:r>
           </a:p>
           <a:p>
-            <a:pPr lvl="0"/>
-            <a:r>
-              <a:rPr lang="en-US" sz="1600"/>
+            <a:pPr lvl="0" marL="288000" indent="-288000">
+              <a:buFont typeface="Arial"/>
+              <a:buChar char="•"/>
+            </a:pPr>
+            <a:r>
+              <a:rPr lang="en-US" sz="1500"/>
               <a:t>$8.2B Serviceable Available Market across plumbing, electrical, and HVAC fleets</a:t>
             </a:r>
           </a:p>
           <a:p>
-            <a:pPr lvl="0"/>
-            <a:r>
-              <a:rPr lang="en-US" sz="1600"/>
+            <a:pPr lvl="0" marL="288000" indent="-288000">
+              <a:buFont typeface="Arial"/>
+              <a:buChar char="•"/>
+            </a:pPr>
+            <a:r>
+              <a:rPr lang="en-US" sz="1500"/>
               <a:t>Initial beachhead: 15,000 plumbing &amp; HVAC fleets with 5-25 service vans</a:t>
             </a:r>
           </a:p>
@@ -555,7 +597,7 @@
           <a:lstStyle/>
           <a:p>
             <a:r>
-              <a:rPr lang="en-US" sz="2800" b="1"/>
+              <a:rPr lang="en-US" sz="2400" b="1"/>
               <a:t>Product Architecture &amp; Moat</a:t>
             </a:r>
           </a:p>
@@ -581,23 +623,32 @@
           <a:bodyPr/>
           <a:lstStyle/>
           <a:p>
-            <a:pPr lvl="0"/>
-            <a:r>
-              <a:rPr lang="en-US" sz="1600"/>
+            <a:pPr lvl="0" marL="288000" indent="-288000">
+              <a:buFont typeface="Arial"/>
+              <a:buChar char="•"/>
+            </a:pPr>
+            <a:r>
+              <a:rPr lang="en-US" sz="1500"/>
               <a:t>Native offline-first mobile sync engine</a:t>
             </a:r>
           </a:p>
           <a:p>
-            <a:pPr lvl="0"/>
-            <a:r>
-              <a:rPr lang="en-US" sz="1600"/>
+            <a:pPr lvl="0" marL="288000" indent="-288000">
+              <a:buFont typeface="Arial"/>
+              <a:buChar char="•"/>
+            </a:pPr>
+            <a:r>
+              <a:rPr lang="en-US" sz="1500"/>
               <a:t>Direct two-way accounting sync into QuickBooks and Xero</a:t>
             </a:r>
           </a:p>
           <a:p>
-            <a:pPr lvl="0"/>
-            <a:r>
-              <a:rPr lang="en-US" sz="1600"/>
+            <a:pPr lvl="0" marL="288000" indent="-288000">
+              <a:buFont typeface="Arial"/>
+              <a:buChar char="•"/>
+            </a:pPr>
+            <a:r>
+              <a:rPr lang="en-US" sz="1500"/>
               <a:t>Zero onboarding friction: operational within 24 hours of setup</a:t>
             </a:r>
           </a:p>
@@ -646,7 +697,7 @@
           <a:lstStyle/>
           <a:p>
             <a:r>
-              <a:rPr lang="en-US" sz="2800" b="1"/>
+              <a:rPr lang="en-US" sz="2400" b="1"/>
               <a:t>Traction &amp; Early Unit Economics</a:t>
             </a:r>
           </a:p>
@@ -672,23 +723,32 @@
           <a:bodyPr/>
           <a:lstStyle/>
           <a:p>
-            <a:pPr lvl="0"/>
-            <a:r>
-              <a:rPr lang="en-US" sz="1600"/>
+            <a:pPr lvl="0" marL="288000" indent="-288000">
+              <a:buFont typeface="Arial"/>
+              <a:buChar char="•"/>
+            </a:pPr>
+            <a:r>
+              <a:rPr lang="en-US" sz="1500"/>
               <a:t>28 paid pilot contractors signed in first 90 days</a:t>
             </a:r>
           </a:p>
           <a:p>
-            <a:pPr lvl="0"/>
-            <a:r>
-              <a:rPr lang="en-US" sz="1600"/>
+            <a:pPr lvl="0" marL="288000" indent="-288000">
+              <a:buFont typeface="Arial"/>
+              <a:buChar char="•"/>
+            </a:pPr>
+            <a:r>
+              <a:rPr lang="en-US" sz="1500"/>
               <a:t>$14,200 Monthly Recurring Revenue ($507 average fleet ARPU)</a:t>
             </a:r>
           </a:p>
           <a:p>
-            <a:pPr lvl="0"/>
-            <a:r>
-              <a:rPr lang="en-US" sz="1600"/>
+            <a:pPr lvl="0" marL="288000" indent="-288000">
+              <a:buFont typeface="Arial"/>
+              <a:buChar char="•"/>
+            </a:pPr>
+            <a:r>
+              <a:rPr lang="en-US" sz="1500"/>
               <a:t>Zero logo churn since launch with 4.9/5 mobile app rating</a:t>
             </a:r>
           </a:p>
@@ -737,7 +797,7 @@
           <a:lstStyle/>
           <a:p>
             <a:r>
-              <a:rPr lang="en-US" sz="2800" b="1"/>
+              <a:rPr lang="en-US" sz="2400" b="1"/>
               <a:t>Go-To-Market Strategy</a:t>
             </a:r>
           </a:p>
@@ -763,23 +823,32 @@
           <a:bodyPr/>
           <a:lstStyle/>
           <a:p>
-            <a:pPr lvl="0"/>
-            <a:r>
-              <a:rPr lang="en-US" sz="1600"/>
+            <a:pPr lvl="0" marL="288000" indent="-288000">
+              <a:buFont typeface="Arial"/>
+              <a:buChar char="•"/>
+            </a:pPr>
+            <a:r>
+              <a:rPr lang="en-US" sz="1500"/>
               <a:t>Direct local trade association partnerships and wholesale supplier distributor tie-ins</a:t>
             </a:r>
           </a:p>
           <a:p>
-            <a:pPr lvl="0"/>
-            <a:r>
-              <a:rPr lang="en-US" sz="1600"/>
+            <a:pPr lvl="0" marL="288000" indent="-288000">
+              <a:buFont typeface="Arial"/>
+              <a:buChar char="•"/>
+            </a:pPr>
+            <a:r>
+              <a:rPr lang="en-US" sz="1500"/>
               <a:t>Performance SEO focused on state contractor licensing lookup pages</a:t>
             </a:r>
           </a:p>
           <a:p>
-            <a:pPr lvl="0"/>
-            <a:r>
-              <a:rPr lang="en-US" sz="1600"/>
+            <a:pPr lvl="0" marL="288000" indent="-288000">
+              <a:buFont typeface="Arial"/>
+              <a:buChar char="•"/>
+            </a:pPr>
+            <a:r>
+              <a:rPr lang="en-US" sz="1500"/>
               <a:t>Low-friction 14-day free trial converting at 38% to paid annual tiers</a:t>
             </a:r>
           </a:p>
@@ -828,7 +897,7 @@
           <a:lstStyle/>
           <a:p>
             <a:r>
-              <a:rPr lang="en-US" sz="2800" b="1"/>
+              <a:rPr lang="en-US" sz="2400" b="1"/>
               <a:t>Competitive Matrix</a:t>
             </a:r>
           </a:p>
@@ -854,23 +923,32 @@
           <a:bodyPr/>
           <a:lstStyle/>
           <a:p>
-            <a:pPr lvl="0"/>
-            <a:r>
-              <a:rPr lang="en-US" sz="1600"/>
+            <a:pPr lvl="0" marL="288000" indent="-288000">
+              <a:buFont typeface="Arial"/>
+              <a:buChar char="•"/>
+            </a:pPr>
+            <a:r>
+              <a:rPr lang="en-US" sz="1500"/>
               <a:t>Incumbents charge $1,500+ setup fees and require 6-week onboarding cycles</a:t>
             </a:r>
           </a:p>
           <a:p>
-            <a:pPr lvl="0"/>
-            <a:r>
-              <a:rPr lang="en-US" sz="1600"/>
+            <a:pPr lvl="0" marL="288000" indent="-288000">
+              <a:buFont typeface="Arial"/>
+              <a:buChar char="•"/>
+            </a:pPr>
+            <a:r>
+              <a:rPr lang="en-US" sz="1500"/>
               <a:t>Legacy tools lack reliable offline caching when technicians work in basements</a:t>
             </a:r>
           </a:p>
           <a:p>
-            <a:pPr lvl="0"/>
-            <a:r>
-              <a:rPr lang="en-US" sz="1600"/>
+            <a:pPr lvl="0" marL="288000" indent="-288000">
+              <a:buFont typeface="Arial"/>
+              <a:buChar char="•"/>
+            </a:pPr>
+            <a:r>
+              <a:rPr lang="en-US" sz="1500"/>
               <a:t>FieldPulse delivers 3x faster time-to-value at 50% lower total cost of ownership</a:t>
             </a:r>
           </a:p>
@@ -919,7 +997,7 @@
           <a:lstStyle/>
           <a:p>
             <a:r>
-              <a:rPr lang="en-US" sz="2800" b="1"/>
+              <a:rPr lang="en-US" sz="2400" b="1"/>
               <a:t>Financial Projections (3-Year Target)</a:t>
             </a:r>
           </a:p>
@@ -945,23 +1023,32 @@
           <a:bodyPr/>
           <a:lstStyle/>
           <a:p>
-            <a:pPr lvl="0"/>
-            <a:r>
-              <a:rPr lang="en-US" sz="1600"/>
+            <a:pPr lvl="0" marL="288000" indent="-288000">
+              <a:buFont typeface="Arial"/>
+              <a:buChar char="•"/>
+            </a:pPr>
+            <a:r>
+              <a:rPr lang="en-US" sz="1500"/>
               <a:t>Year 1: 180 Fleets · $1.1M ARR · Gross Margin 82%</a:t>
             </a:r>
           </a:p>
           <a:p>
-            <a:pPr lvl="0"/>
-            <a:r>
-              <a:rPr lang="en-US" sz="1600"/>
+            <a:pPr lvl="0" marL="288000" indent="-288000">
+              <a:buFont typeface="Arial"/>
+              <a:buChar char="•"/>
+            </a:pPr>
+            <a:r>
+              <a:rPr lang="en-US" sz="1500"/>
               <a:t>Year 2: 650 Fleets · $3.9M ARR · Cash flow breakeven at Month 18</a:t>
             </a:r>
           </a:p>
           <a:p>
-            <a:pPr lvl="0"/>
-            <a:r>
-              <a:rPr lang="en-US" sz="1600"/>
+            <a:pPr lvl="0" marL="288000" indent="-288000">
+              <a:buFont typeface="Arial"/>
+              <a:buChar char="•"/>
+            </a:pPr>
+            <a:r>
+              <a:rPr lang="en-US" sz="1500"/>
               <a:t>Year 3: 2,100 Fleets · $12.8M ARR · 4.2x LTV/CAC ratio</a:t>
             </a:r>
           </a:p>

</xml_diff>

<commit_message>
fix(seed): safely distinguish file contents from disk paths in write_zip_file to prevent Linux OSError Errno 36
</commit_message>
<xml_diff>
--- a/public/chat_files/alexa_10slide_investor_pitch.pptx
+++ b/public/chat_files/alexa_10slide_investor_pitch.pptx
@@ -10,6 +10,11 @@
     <p:sldId id="258" r:id="rId9"/>
     <p:sldId id="259" r:id="rId10"/>
     <p:sldId id="260" r:id="rId11"/>
+    <p:sldId id="261" r:id="rId12"/>
+    <p:sldId id="262" r:id="rId13"/>
+    <p:sldId id="263" r:id="rId14"/>
+    <p:sldId id="264" r:id="rId15"/>
+    <p:sldId id="265" r:id="rId16"/>
   </p:sldIdLst>
   <p:sldSz cx="12191695" cy="6858000" type="screen4x3"/>
   <p:notesSz cx="6858000" cy="9144000"/>
@@ -3169,7 +3174,7 @@
               </a:defRPr>
             </a:pPr>
             <a:r>
-              <a:t>CONFIDENTIAL SEED FINANCING BRIEFING · 2026</a:t>
+              <a:t>CONFIDENTIAL &amp; PROPRIETARY</a:t>
             </a:r>
           </a:p>
           <a:p>
@@ -3185,23 +3190,7 @@
               </a:defRPr>
             </a:pPr>
             <a:r>
-              <a:t>FieldPulse: Intelligent Workflows for Trade Fleets</a:t>
-            </a:r>
-          </a:p>
-          <a:p>
-            <a:pPr>
-              <a:spcAft>
-                <a:spcPts val="2400"/>
-              </a:spcAft>
-              <a:defRPr sz="1600">
-                <a:solidFill>
-                  <a:srgbClr val="CBD5E1"/>
-                </a:solidFill>
-                <a:latin typeface="Calibri"/>
-              </a:defRPr>
-            </a:pPr>
-            <a:r>
-              <a:t>Presented by Alexa Quintero, Founder &amp; CEO · Mobile Dispatch &amp; Invoicing for Plumbing, HVAC &amp; Electrical Fleets</a:t>
+              <a:t>FieldPulse: Automated Mobile Dispatch for Trade Fleets</a:t>
             </a:r>
           </a:p>
           <a:p>
@@ -3217,7 +3206,7 @@
               </a:defRPr>
             </a:pPr>
             <a:r>
-              <a:t>Targeting the $8.2B North American Trade &amp; Field Services Software Market</a:t>
+              <a:t>Presented by Alexa Quintero, Founder &amp; CEO</a:t>
             </a:r>
           </a:p>
           <a:p>
@@ -3233,7 +3222,279 @@
               </a:defRPr>
             </a:pPr>
             <a:r>
-              <a:t>42 Active Fleets · $310k Current ARR · 92% Gross Software Margin</a:t>
+              <a:t>Targeting the $8.2B North American Trade &amp; Field Services Market</a:t>
+            </a:r>
+          </a:p>
+        </p:txBody>
+      </p:sp>
+    </p:spTree>
+  </p:cSld>
+  <p:clrMapOvr>
+    <a:masterClrMapping/>
+  </p:clrMapOvr>
+</p:sld>
+</file>
+
+<file path=ppt/slides/slide10.xml><?xml version="1.0" encoding="utf-8"?>
+<p:sld xmlns:a="http://schemas.openxmlformats.org/drawingml/2006/main" xmlns:p="http://schemas.openxmlformats.org/presentationml/2006/main" xmlns:r="http://schemas.openxmlformats.org/officeDocument/2006/relationships">
+  <p:cSld>
+    <p:spTree>
+      <p:nvGrpSpPr>
+        <p:cNvPr id="1" name=""/>
+        <p:cNvGrpSpPr/>
+        <p:nvPr/>
+      </p:nvGrpSpPr>
+      <p:grpSpPr/>
+      <p:sp>
+        <p:nvSpPr>
+          <p:cNvPr id="2" name="Rectangle 1"/>
+          <p:cNvSpPr/>
+          <p:nvPr/>
+        </p:nvSpPr>
+        <p:spPr>
+          <a:xfrm>
+            <a:off x="0" y="0"/>
+            <a:ext cx="12191695" cy="6858000"/>
+          </a:xfrm>
+          <a:prstGeom prst="rect">
+            <a:avLst/>
+          </a:prstGeom>
+          <a:solidFill>
+            <a:srgbClr val="FFFFFF"/>
+          </a:solidFill>
+          <a:ln>
+            <a:noFill/>
+          </a:ln>
+        </p:spPr>
+        <p:style>
+          <a:lnRef idx="1">
+            <a:schemeClr val="accent1"/>
+          </a:lnRef>
+          <a:fillRef idx="3">
+            <a:schemeClr val="accent1"/>
+          </a:fillRef>
+          <a:effectRef idx="2">
+            <a:schemeClr val="accent1"/>
+          </a:effectRef>
+          <a:fontRef idx="minor">
+            <a:schemeClr val="lt1"/>
+          </a:fontRef>
+        </p:style>
+        <p:txBody>
+          <a:bodyPr rtlCol="0" anchor="ctr"/>
+          <a:lstStyle/>
+          <a:p>
+            <a:pPr algn="ctr"/>
+          </a:p>
+        </p:txBody>
+      </p:sp>
+      <p:sp>
+        <p:nvSpPr>
+          <p:cNvPr id="3" name="TextBox 2"/>
+          <p:cNvSpPr txBox="1"/>
+          <p:nvPr/>
+        </p:nvSpPr>
+        <p:spPr>
+          <a:xfrm>
+            <a:off x="731520" y="548640"/>
+            <a:ext cx="10698480" cy="1188720"/>
+          </a:xfrm>
+          <a:prstGeom prst="rect">
+            <a:avLst/>
+          </a:prstGeom>
+          <a:noFill/>
+        </p:spPr>
+        <p:txBody>
+          <a:bodyPr wrap="square">
+            <a:spAutoFit/>
+          </a:bodyPr>
+          <a:lstStyle/>
+          <a:p>
+            <a:pPr>
+              <a:spcAft>
+                <a:spcPts val="400"/>
+              </a:spcAft>
+              <a:defRPr sz="1000" b="1">
+                <a:solidFill>
+                  <a:srgbClr val="2563EB"/>
+                </a:solidFill>
+                <a:latin typeface="Calibri"/>
+              </a:defRPr>
+            </a:pPr>
+            <a:r>
+              <a:t>ALEXA QUINTERO — ANGEL INVESTOR PRESENTATION (10 S</a:t>
+            </a:r>
+          </a:p>
+          <a:p>
+            <a:pPr>
+              <a:defRPr sz="2200" b="1">
+                <a:solidFill>
+                  <a:srgbClr val="0F172A"/>
+                </a:solidFill>
+                <a:latin typeface="Calibri"/>
+              </a:defRPr>
+            </a:pPr>
+            <a:r>
+              <a:t>The Ask: $750,000 Pre-Seed Round</a:t>
+            </a:r>
+          </a:p>
+        </p:txBody>
+      </p:sp>
+      <p:sp>
+        <p:nvSpPr>
+          <p:cNvPr id="4" name="Rectangle 3"/>
+          <p:cNvSpPr/>
+          <p:nvPr/>
+        </p:nvSpPr>
+        <p:spPr>
+          <a:xfrm>
+            <a:off x="731520" y="1737360"/>
+            <a:ext cx="10698480" cy="13716"/>
+          </a:xfrm>
+          <a:prstGeom prst="rect">
+            <a:avLst/>
+          </a:prstGeom>
+          <a:solidFill>
+            <a:srgbClr val="E2E8F0"/>
+          </a:solidFill>
+          <a:ln>
+            <a:noFill/>
+          </a:ln>
+        </p:spPr>
+        <p:style>
+          <a:lnRef idx="1">
+            <a:schemeClr val="accent1"/>
+          </a:lnRef>
+          <a:fillRef idx="3">
+            <a:schemeClr val="accent1"/>
+          </a:fillRef>
+          <a:effectRef idx="2">
+            <a:schemeClr val="accent1"/>
+          </a:effectRef>
+          <a:fontRef idx="minor">
+            <a:schemeClr val="lt1"/>
+          </a:fontRef>
+        </p:style>
+        <p:txBody>
+          <a:bodyPr rtlCol="0" anchor="ctr"/>
+          <a:lstStyle/>
+          <a:p>
+            <a:pPr algn="ctr"/>
+          </a:p>
+        </p:txBody>
+      </p:sp>
+      <p:sp>
+        <p:nvSpPr>
+          <p:cNvPr id="5" name="TextBox 4"/>
+          <p:cNvSpPr txBox="1"/>
+          <p:nvPr/>
+        </p:nvSpPr>
+        <p:spPr>
+          <a:xfrm>
+            <a:off x="731520" y="2011680"/>
+            <a:ext cx="10698480" cy="4114800"/>
+          </a:xfrm>
+          <a:prstGeom prst="rect">
+            <a:avLst/>
+          </a:prstGeom>
+          <a:noFill/>
+        </p:spPr>
+        <p:txBody>
+          <a:bodyPr wrap="square">
+            <a:spAutoFit/>
+          </a:bodyPr>
+          <a:lstStyle/>
+          <a:p>
+            <a:pPr>
+              <a:lnSpc>
+                <a:spcPct val="125000"/>
+              </a:lnSpc>
+              <a:spcAft>
+                <a:spcPts val="1400"/>
+              </a:spcAft>
+              <a:defRPr sz="1500">
+                <a:solidFill>
+                  <a:srgbClr val="1E293B"/>
+                </a:solidFill>
+                <a:latin typeface="Calibri"/>
+              </a:defRPr>
+            </a:pPr>
+            <a:r>
+              <a:t>•  65% dedicated to engineering &amp; offline sync hardening</a:t>
+            </a:r>
+          </a:p>
+          <a:p>
+            <a:pPr>
+              <a:lnSpc>
+                <a:spcPct val="125000"/>
+              </a:lnSpc>
+              <a:spcAft>
+                <a:spcPts val="1400"/>
+              </a:spcAft>
+              <a:defRPr sz="1500">
+                <a:solidFill>
+                  <a:srgbClr val="1E293B"/>
+                </a:solidFill>
+                <a:latin typeface="Calibri"/>
+              </a:defRPr>
+            </a:pPr>
+            <a:r>
+              <a:t>•  25% to initial customer acquisition and trade show sponsorships</a:t>
+            </a:r>
+          </a:p>
+          <a:p>
+            <a:pPr>
+              <a:lnSpc>
+                <a:spcPct val="125000"/>
+              </a:lnSpc>
+              <a:spcAft>
+                <a:spcPts val="1400"/>
+              </a:spcAft>
+              <a:defRPr sz="1500">
+                <a:solidFill>
+                  <a:srgbClr val="1E293B"/>
+                </a:solidFill>
+                <a:latin typeface="Calibri"/>
+              </a:defRPr>
+            </a:pPr>
+            <a:r>
+              <a:t>•  10% working capital and reserve runway</a:t>
+            </a:r>
+          </a:p>
+        </p:txBody>
+      </p:sp>
+      <p:sp>
+        <p:nvSpPr>
+          <p:cNvPr id="6" name="TextBox 5"/>
+          <p:cNvSpPr txBox="1"/>
+          <p:nvPr/>
+        </p:nvSpPr>
+        <p:spPr>
+          <a:xfrm>
+            <a:off x="731520" y="6309360"/>
+            <a:ext cx="10698480" cy="365760"/>
+          </a:xfrm>
+          <a:prstGeom prst="rect">
+            <a:avLst/>
+          </a:prstGeom>
+          <a:noFill/>
+        </p:spPr>
+        <p:txBody>
+          <a:bodyPr wrap="none">
+            <a:spAutoFit/>
+          </a:bodyPr>
+          <a:lstStyle/>
+          <a:p>
+            <a:pPr>
+              <a:defRPr sz="900">
+                <a:solidFill>
+                  <a:srgbClr val="94A3B8"/>
+                </a:solidFill>
+                <a:latin typeface="Calibri"/>
+              </a:defRPr>
+            </a:pPr>
+            <a:r>
+              <a:t>Alexa Quintero — Angel Investor Presentation (10 Slides) · Slide 10 of 10</a:t>
             </a:r>
           </a:p>
         </p:txBody>
@@ -3333,7 +3594,7 @@
               </a:defRPr>
             </a:pPr>
             <a:r>
-              <a:t>THE PROBLEM</a:t>
+              <a:t>ALEXA QUINTERO — ANGEL INVESTOR PRESENTATION (10 S</a:t>
             </a:r>
           </a:p>
           <a:p>
@@ -3346,23 +3607,7 @@
               </a:defRPr>
             </a:pPr>
             <a:r>
-              <a:t>Trade Fleets Bleed Margins Through Fragmented Paperwork</a:t>
-            </a:r>
-          </a:p>
-          <a:p>
-            <a:pPr>
-              <a:spcBef>
-                <a:spcPts val="200"/>
-              </a:spcBef>
-              <a:defRPr sz="1200">
-                <a:solidFill>
-                  <a:srgbClr val="64748B"/>
-                </a:solidFill>
-                <a:latin typeface="Calibri"/>
-              </a:defRPr>
-            </a:pPr>
-            <a:r>
-              <a:t>Field technicians lose hours on clipboards while dispatchers juggle disjointed spreadsheets and phone calls</a:t>
+              <a:t>The Problem: Broken Field Communication</a:t>
             </a:r>
           </a:p>
         </p:txBody>
@@ -3412,59 +3657,14 @@
       </p:sp>
       <p:sp>
         <p:nvSpPr>
-          <p:cNvPr id="5" name="Rounded Rectangle 4"/>
-          <p:cNvSpPr/>
-          <p:nvPr/>
-        </p:nvSpPr>
-        <p:spPr>
-          <a:xfrm>
-            <a:off x="731520" y="1920240"/>
-            <a:ext cx="2468880" cy="4114800"/>
-          </a:xfrm>
-          <a:prstGeom prst="roundRect">
-            <a:avLst/>
-          </a:prstGeom>
-          <a:solidFill>
-            <a:srgbClr val="F8FAFC"/>
-          </a:solidFill>
-          <a:ln w="12700">
-            <a:solidFill>
-              <a:srgbClr val="CBD5E1"/>
-            </a:solidFill>
-          </a:ln>
-        </p:spPr>
-        <p:style>
-          <a:lnRef idx="1">
-            <a:schemeClr val="accent1"/>
-          </a:lnRef>
-          <a:fillRef idx="3">
-            <a:schemeClr val="accent1"/>
-          </a:fillRef>
-          <a:effectRef idx="2">
-            <a:schemeClr val="accent1"/>
-          </a:effectRef>
-          <a:fontRef idx="minor">
-            <a:schemeClr val="lt1"/>
-          </a:fontRef>
-        </p:style>
-        <p:txBody>
-          <a:bodyPr rtlCol="0" anchor="ctr"/>
-          <a:lstStyle/>
-          <a:p>
-            <a:pPr algn="ctr"/>
-          </a:p>
-        </p:txBody>
-      </p:sp>
-      <p:sp>
-        <p:nvSpPr>
-          <p:cNvPr id="6" name="TextBox 5"/>
+          <p:cNvPr id="5" name="TextBox 4"/>
           <p:cNvSpPr txBox="1"/>
           <p:nvPr/>
         </p:nvSpPr>
         <p:spPr>
           <a:xfrm>
-            <a:off x="1005840" y="2286000"/>
-            <a:ext cx="1920240" cy="3383280"/>
+            <a:off x="731520" y="2011680"/>
+            <a:ext cx="10698480" cy="4114800"/>
           </a:xfrm>
           <a:prstGeom prst="rect">
             <a:avLst/>
@@ -3478,106 +3678,73 @@
           <a:lstStyle/>
           <a:p>
             <a:pPr>
+              <a:lnSpc>
+                <a:spcPct val="125000"/>
+              </a:lnSpc>
               <a:spcAft>
-                <a:spcPts val="1000"/>
+                <a:spcPts val="1400"/>
               </a:spcAft>
-              <a:defRPr sz="3600" b="1">
-                <a:solidFill>
-                  <a:srgbClr val="2563EB"/>
+              <a:defRPr sz="1500">
+                <a:solidFill>
+                  <a:srgbClr val="1E293B"/>
                 </a:solidFill>
                 <a:latin typeface="Calibri"/>
               </a:defRPr>
             </a:pPr>
             <a:r>
-              <a:t>2.4 hrs</a:t>
+              <a:t>•  Field technicians spend 2.4 hours daily on manual paper logs</a:t>
             </a:r>
           </a:p>
           <a:p>
             <a:pPr>
+              <a:lnSpc>
+                <a:spcPct val="125000"/>
+              </a:lnSpc>
               <a:spcAft>
-                <a:spcPts val="800"/>
+                <a:spcPts val="1400"/>
               </a:spcAft>
-              <a:defRPr sz="1400" b="1">
-                <a:solidFill>
-                  <a:srgbClr val="0F172A"/>
+              <a:defRPr sz="1500">
+                <a:solidFill>
+                  <a:srgbClr val="1E293B"/>
                 </a:solidFill>
                 <a:latin typeface="Calibri"/>
               </a:defRPr>
             </a:pPr>
             <a:r>
-              <a:t>Lost Daily per Tech</a:t>
+              <a:t>•  Dispatchers scramble across phone calls, whiteboards, and text threads</a:t>
             </a:r>
           </a:p>
           <a:p>
             <a:pPr>
-              <a:defRPr sz="1100">
-                <a:solidFill>
-                  <a:srgbClr val="64748B"/>
+              <a:lnSpc>
+                <a:spcPct val="125000"/>
+              </a:lnSpc>
+              <a:spcAft>
+                <a:spcPts val="1400"/>
+              </a:spcAft>
+              <a:defRPr sz="1500">
+                <a:solidFill>
+                  <a:srgbClr val="1E293B"/>
                 </a:solidFill>
                 <a:latin typeface="Calibri"/>
               </a:defRPr>
             </a:pPr>
             <a:r>
-              <a:t>Spent on manual paperwork, travel logs, and phone check-ins</a:t>
-            </a:r>
-          </a:p>
-        </p:txBody>
-      </p:sp>
-      <p:sp>
-        <p:nvSpPr>
-          <p:cNvPr id="7" name="Rounded Rectangle 6"/>
-          <p:cNvSpPr/>
-          <p:nvPr/>
-        </p:nvSpPr>
-        <p:spPr>
-          <a:xfrm>
-            <a:off x="3474720" y="1920240"/>
-            <a:ext cx="2468880" cy="4114800"/>
-          </a:xfrm>
-          <a:prstGeom prst="roundRect">
-            <a:avLst/>
-          </a:prstGeom>
-          <a:solidFill>
-            <a:srgbClr val="F8FAFC"/>
-          </a:solidFill>
-          <a:ln w="12700">
-            <a:solidFill>
-              <a:srgbClr val="CBD5E1"/>
-            </a:solidFill>
-          </a:ln>
-        </p:spPr>
-        <p:style>
-          <a:lnRef idx="1">
-            <a:schemeClr val="accent1"/>
-          </a:lnRef>
-          <a:fillRef idx="3">
-            <a:schemeClr val="accent1"/>
-          </a:fillRef>
-          <a:effectRef idx="2">
-            <a:schemeClr val="accent1"/>
-          </a:effectRef>
-          <a:fontRef idx="minor">
-            <a:schemeClr val="lt1"/>
-          </a:fontRef>
-        </p:style>
-        <p:txBody>
-          <a:bodyPr rtlCol="0" anchor="ctr"/>
-          <a:lstStyle/>
-          <a:p>
-            <a:pPr algn="ctr"/>
-          </a:p>
-        </p:txBody>
-      </p:sp>
-      <p:sp>
-        <p:nvSpPr>
-          <p:cNvPr id="8" name="TextBox 7"/>
+              <a:t>•  Lost invoices and uncollected change orders bleed 8% of trade contractor margins</a:t>
+            </a:r>
+          </a:p>
+        </p:txBody>
+      </p:sp>
+      <p:sp>
+        <p:nvSpPr>
+          <p:cNvPr id="6" name="TextBox 5"/>
           <p:cNvSpPr txBox="1"/>
           <p:nvPr/>
         </p:nvSpPr>
         <p:spPr>
           <a:xfrm>
-            <a:off x="3749040" y="2286000"/>
-            <a:ext cx="1920240" cy="3383280"/>
+            <a:off x="731520" y="6309360"/>
+            <a:ext cx="10698480" cy="365760"/>
           </a:xfrm>
           <a:prstGeom prst="rect">
             <a:avLst/>
@@ -3585,300 +3752,6 @@
           <a:noFill/>
         </p:spPr>
         <p:txBody>
-          <a:bodyPr wrap="square">
-            <a:spAutoFit/>
-          </a:bodyPr>
-          <a:lstStyle/>
-          <a:p>
-            <a:pPr>
-              <a:spcAft>
-                <a:spcPts val="1000"/>
-              </a:spcAft>
-              <a:defRPr sz="3600" b="1">
-                <a:solidFill>
-                  <a:srgbClr val="2563EB"/>
-                </a:solidFill>
-                <a:latin typeface="Calibri"/>
-              </a:defRPr>
-            </a:pPr>
-            <a:r>
-              <a:t>8.4%</a:t>
-            </a:r>
-          </a:p>
-          <a:p>
-            <a:pPr>
-              <a:spcAft>
-                <a:spcPts val="800"/>
-              </a:spcAft>
-              <a:defRPr sz="1400" b="1">
-                <a:solidFill>
-                  <a:srgbClr val="0F172A"/>
-                </a:solidFill>
-                <a:latin typeface="Calibri"/>
-              </a:defRPr>
-            </a:pPr>
-            <a:r>
-              <a:t>Revenue Unbilled</a:t>
-            </a:r>
-          </a:p>
-          <a:p>
-            <a:pPr>
-              <a:defRPr sz="1100">
-                <a:solidFill>
-                  <a:srgbClr val="64748B"/>
-                </a:solidFill>
-                <a:latin typeface="Calibri"/>
-              </a:defRPr>
-            </a:pPr>
-            <a:r>
-              <a:t>Lost change orders, uncollected parts, and missing signatures</a:t>
-            </a:r>
-          </a:p>
-        </p:txBody>
-      </p:sp>
-      <p:sp>
-        <p:nvSpPr>
-          <p:cNvPr id="9" name="Rounded Rectangle 8"/>
-          <p:cNvSpPr/>
-          <p:nvPr/>
-        </p:nvSpPr>
-        <p:spPr>
-          <a:xfrm>
-            <a:off x="6217920" y="1920240"/>
-            <a:ext cx="2468880" cy="4114800"/>
-          </a:xfrm>
-          <a:prstGeom prst="roundRect">
-            <a:avLst/>
-          </a:prstGeom>
-          <a:solidFill>
-            <a:srgbClr val="F8FAFC"/>
-          </a:solidFill>
-          <a:ln w="12700">
-            <a:solidFill>
-              <a:srgbClr val="CBD5E1"/>
-            </a:solidFill>
-          </a:ln>
-        </p:spPr>
-        <p:style>
-          <a:lnRef idx="1">
-            <a:schemeClr val="accent1"/>
-          </a:lnRef>
-          <a:fillRef idx="3">
-            <a:schemeClr val="accent1"/>
-          </a:fillRef>
-          <a:effectRef idx="2">
-            <a:schemeClr val="accent1"/>
-          </a:effectRef>
-          <a:fontRef idx="minor">
-            <a:schemeClr val="lt1"/>
-          </a:fontRef>
-        </p:style>
-        <p:txBody>
-          <a:bodyPr rtlCol="0" anchor="ctr"/>
-          <a:lstStyle/>
-          <a:p>
-            <a:pPr algn="ctr"/>
-          </a:p>
-        </p:txBody>
-      </p:sp>
-      <p:sp>
-        <p:nvSpPr>
-          <p:cNvPr id="10" name="TextBox 9"/>
-          <p:cNvSpPr txBox="1"/>
-          <p:nvPr/>
-        </p:nvSpPr>
-        <p:spPr>
-          <a:xfrm>
-            <a:off x="6492240" y="2286000"/>
-            <a:ext cx="1920240" cy="3383280"/>
-          </a:xfrm>
-          <a:prstGeom prst="rect">
-            <a:avLst/>
-          </a:prstGeom>
-          <a:noFill/>
-        </p:spPr>
-        <p:txBody>
-          <a:bodyPr wrap="square">
-            <a:spAutoFit/>
-          </a:bodyPr>
-          <a:lstStyle/>
-          <a:p>
-            <a:pPr>
-              <a:spcAft>
-                <a:spcPts val="1000"/>
-              </a:spcAft>
-              <a:defRPr sz="3600" b="1">
-                <a:solidFill>
-                  <a:srgbClr val="2563EB"/>
-                </a:solidFill>
-                <a:latin typeface="Calibri"/>
-              </a:defRPr>
-            </a:pPr>
-            <a:r>
-              <a:t>28 days</a:t>
-            </a:r>
-          </a:p>
-          <a:p>
-            <a:pPr>
-              <a:spcAft>
-                <a:spcPts val="800"/>
-              </a:spcAft>
-              <a:defRPr sz="1400" b="1">
-                <a:solidFill>
-                  <a:srgbClr val="0F172A"/>
-                </a:solidFill>
-                <a:latin typeface="Calibri"/>
-              </a:defRPr>
-            </a:pPr>
-            <a:r>
-              <a:t>Payment Wait Time</a:t>
-            </a:r>
-          </a:p>
-          <a:p>
-            <a:pPr>
-              <a:defRPr sz="1100">
-                <a:solidFill>
-                  <a:srgbClr val="64748B"/>
-                </a:solidFill>
-                <a:latin typeface="Calibri"/>
-              </a:defRPr>
-            </a:pPr>
-            <a:r>
-              <a:t>Average time to collect invoices dispatched by mail</a:t>
-            </a:r>
-          </a:p>
-        </p:txBody>
-      </p:sp>
-      <p:sp>
-        <p:nvSpPr>
-          <p:cNvPr id="11" name="Rounded Rectangle 10"/>
-          <p:cNvSpPr/>
-          <p:nvPr/>
-        </p:nvSpPr>
-        <p:spPr>
-          <a:xfrm>
-            <a:off x="8961120" y="1920240"/>
-            <a:ext cx="2468880" cy="4114800"/>
-          </a:xfrm>
-          <a:prstGeom prst="roundRect">
-            <a:avLst/>
-          </a:prstGeom>
-          <a:solidFill>
-            <a:srgbClr val="F8FAFC"/>
-          </a:solidFill>
-          <a:ln w="12700">
-            <a:solidFill>
-              <a:srgbClr val="CBD5E1"/>
-            </a:solidFill>
-          </a:ln>
-        </p:spPr>
-        <p:style>
-          <a:lnRef idx="1">
-            <a:schemeClr val="accent1"/>
-          </a:lnRef>
-          <a:fillRef idx="3">
-            <a:schemeClr val="accent1"/>
-          </a:fillRef>
-          <a:effectRef idx="2">
-            <a:schemeClr val="accent1"/>
-          </a:effectRef>
-          <a:fontRef idx="minor">
-            <a:schemeClr val="lt1"/>
-          </a:fontRef>
-        </p:style>
-        <p:txBody>
-          <a:bodyPr rtlCol="0" anchor="ctr"/>
-          <a:lstStyle/>
-          <a:p>
-            <a:pPr algn="ctr"/>
-          </a:p>
-        </p:txBody>
-      </p:sp>
-      <p:sp>
-        <p:nvSpPr>
-          <p:cNvPr id="12" name="TextBox 11"/>
-          <p:cNvSpPr txBox="1"/>
-          <p:nvPr/>
-        </p:nvSpPr>
-        <p:spPr>
-          <a:xfrm>
-            <a:off x="9235440" y="2286000"/>
-            <a:ext cx="1920240" cy="3383280"/>
-          </a:xfrm>
-          <a:prstGeom prst="rect">
-            <a:avLst/>
-          </a:prstGeom>
-          <a:noFill/>
-        </p:spPr>
-        <p:txBody>
-          <a:bodyPr wrap="square">
-            <a:spAutoFit/>
-          </a:bodyPr>
-          <a:lstStyle/>
-          <a:p>
-            <a:pPr>
-              <a:spcAft>
-                <a:spcPts val="1000"/>
-              </a:spcAft>
-              <a:defRPr sz="3600" b="1">
-                <a:solidFill>
-                  <a:srgbClr val="2563EB"/>
-                </a:solidFill>
-                <a:latin typeface="Calibri"/>
-              </a:defRPr>
-            </a:pPr>
-            <a:r>
-              <a:t>42%</a:t>
-            </a:r>
-          </a:p>
-          <a:p>
-            <a:pPr>
-              <a:spcAft>
-                <a:spcPts val="800"/>
-              </a:spcAft>
-              <a:defRPr sz="1400" b="1">
-                <a:solidFill>
-                  <a:srgbClr val="0F172A"/>
-                </a:solidFill>
-                <a:latin typeface="Calibri"/>
-              </a:defRPr>
-            </a:pPr>
-            <a:r>
-              <a:t>Dispatcher Turnover</a:t>
-            </a:r>
-          </a:p>
-          <a:p>
-            <a:pPr>
-              <a:defRPr sz="1100">
-                <a:solidFill>
-                  <a:srgbClr val="64748B"/>
-                </a:solidFill>
-                <a:latin typeface="Calibri"/>
-              </a:defRPr>
-            </a:pPr>
-            <a:r>
-              <a:t>Stress driven by chaotic manual scheduling and dispatch</a:t>
-            </a:r>
-          </a:p>
-        </p:txBody>
-      </p:sp>
-      <p:sp>
-        <p:nvSpPr>
-          <p:cNvPr id="13" name="TextBox 12"/>
-          <p:cNvSpPr txBox="1"/>
-          <p:nvPr/>
-        </p:nvSpPr>
-        <p:spPr>
-          <a:xfrm>
-            <a:off x="731520" y="6309360"/>
-            <a:ext cx="10698480" cy="365760"/>
-          </a:xfrm>
-          <a:prstGeom prst="rect">
-            <a:avLst/>
-          </a:prstGeom>
-          <a:noFill/>
-        </p:spPr>
-        <p:txBody>
           <a:bodyPr wrap="none">
             <a:spAutoFit/>
           </a:bodyPr>
@@ -3893,7 +3766,7 @@
               </a:defRPr>
             </a:pPr>
             <a:r>
-              <a:t>FieldPulse — Seed Investor Presentation · Slide 2 of 5</a:t>
+              <a:t>Alexa Quintero — Angel Investor Presentation (10 Slides) · Slide 2 of 10</a:t>
             </a:r>
           </a:p>
         </p:txBody>
@@ -3993,7 +3866,7 @@
               </a:defRPr>
             </a:pPr>
             <a:r>
-              <a:t>THE SOLUTION</a:t>
+              <a:t>ALEXA QUINTERO — ANGEL INVESTOR PRESENTATION (10 S</a:t>
             </a:r>
           </a:p>
           <a:p>
@@ -4006,23 +3879,7 @@
               </a:defRPr>
             </a:pPr>
             <a:r>
-              <a:t>A Mobile-First Operating System for Field Technicians</a:t>
-            </a:r>
-          </a:p>
-          <a:p>
-            <a:pPr>
-              <a:spcBef>
-                <a:spcPts val="200"/>
-              </a:spcBef>
-              <a:defRPr sz="1200">
-                <a:solidFill>
-                  <a:srgbClr val="64748B"/>
-                </a:solidFill>
-                <a:latin typeface="Calibri"/>
-              </a:defRPr>
-            </a:pPr>
-            <a:r>
-              <a:t>One tap to dispatch, offline mobile sign-off, and instant on-site card payment</a:t>
+              <a:t>The Solution: Real-Time Mobile Workflows</a:t>
             </a:r>
           </a:p>
         </p:txBody>
@@ -4072,59 +3929,14 @@
       </p:sp>
       <p:sp>
         <p:nvSpPr>
-          <p:cNvPr id="5" name="Rounded Rectangle 4"/>
-          <p:cNvSpPr/>
-          <p:nvPr/>
-        </p:nvSpPr>
-        <p:spPr>
-          <a:xfrm>
-            <a:off x="731520" y="1920240"/>
-            <a:ext cx="3352800" cy="4114800"/>
-          </a:xfrm>
-          <a:prstGeom prst="roundRect">
-            <a:avLst/>
-          </a:prstGeom>
-          <a:solidFill>
-            <a:srgbClr val="F8FAFC"/>
-          </a:solidFill>
-          <a:ln w="12700">
-            <a:solidFill>
-              <a:srgbClr val="CBD5E1"/>
-            </a:solidFill>
-          </a:ln>
-        </p:spPr>
-        <p:style>
-          <a:lnRef idx="1">
-            <a:schemeClr val="accent1"/>
-          </a:lnRef>
-          <a:fillRef idx="3">
-            <a:schemeClr val="accent1"/>
-          </a:fillRef>
-          <a:effectRef idx="2">
-            <a:schemeClr val="accent1"/>
-          </a:effectRef>
-          <a:fontRef idx="minor">
-            <a:schemeClr val="lt1"/>
-          </a:fontRef>
-        </p:style>
-        <p:txBody>
-          <a:bodyPr rtlCol="0" anchor="ctr"/>
-          <a:lstStyle/>
-          <a:p>
-            <a:pPr algn="ctr"/>
-          </a:p>
-        </p:txBody>
-      </p:sp>
-      <p:sp>
-        <p:nvSpPr>
-          <p:cNvPr id="6" name="TextBox 5"/>
+          <p:cNvPr id="5" name="TextBox 4"/>
           <p:cNvSpPr txBox="1"/>
           <p:nvPr/>
         </p:nvSpPr>
         <p:spPr>
           <a:xfrm>
-            <a:off x="1005840" y="2194560"/>
-            <a:ext cx="2804160" cy="3566160"/>
+            <a:off x="731520" y="2011680"/>
+            <a:ext cx="10698480" cy="4114800"/>
           </a:xfrm>
           <a:prstGeom prst="rect">
             <a:avLst/>
@@ -4138,125 +3950,73 @@
           <a:lstStyle/>
           <a:p>
             <a:pPr>
+              <a:lnSpc>
+                <a:spcPct val="125000"/>
+              </a:lnSpc>
               <a:spcAft>
-                <a:spcPts val="1000"/>
+                <a:spcPts val="1400"/>
               </a:spcAft>
-              <a:defRPr sz="1500" b="1">
-                <a:solidFill>
-                  <a:srgbClr val="0F172A"/>
+              <a:defRPr sz="1500">
+                <a:solidFill>
+                  <a:srgbClr val="1E293B"/>
                 </a:solidFill>
                 <a:latin typeface="Calibri"/>
               </a:defRPr>
             </a:pPr>
             <a:r>
-              <a:t>1. GPS Turn-by-Turn Routing</a:t>
+              <a:t>•  One-tap dispatch with GPS turn-by-turn routing</a:t>
             </a:r>
           </a:p>
           <a:p>
             <a:pPr>
+              <a:lnSpc>
+                <a:spcPct val="125000"/>
+              </a:lnSpc>
               <a:spcAft>
-                <a:spcPts val="600"/>
+                <a:spcPts val="1400"/>
               </a:spcAft>
-              <a:defRPr sz="1100">
-                <a:solidFill>
-                  <a:srgbClr val="334155"/>
+              <a:defRPr sz="1500">
+                <a:solidFill>
+                  <a:srgbClr val="1E293B"/>
                 </a:solidFill>
                 <a:latin typeface="Calibri"/>
               </a:defRPr>
             </a:pPr>
             <a:r>
-              <a:t>•  Optimized route sequencing cuts windshield time by 22%</a:t>
+              <a:t>•  Offline mobile sign-off with instant photo attachments</a:t>
             </a:r>
           </a:p>
           <a:p>
             <a:pPr>
+              <a:lnSpc>
+                <a:spcPct val="125000"/>
+              </a:lnSpc>
               <a:spcAft>
-                <a:spcPts val="600"/>
+                <a:spcPts val="1400"/>
               </a:spcAft>
-              <a:defRPr sz="1100">
-                <a:solidFill>
-                  <a:srgbClr val="334155"/>
+              <a:defRPr sz="1500">
+                <a:solidFill>
+                  <a:srgbClr val="1E293B"/>
                 </a:solidFill>
                 <a:latin typeface="Calibri"/>
               </a:defRPr>
             </a:pPr>
             <a:r>
-              <a:t>•  Automated customer arrival SMS with live tech tracking</a:t>
-            </a:r>
-          </a:p>
-          <a:p>
-            <a:pPr>
-              <a:spcAft>
-                <a:spcPts val="600"/>
-              </a:spcAft>
-              <a:defRPr sz="1100">
-                <a:solidFill>
-                  <a:srgbClr val="334155"/>
-                </a:solidFill>
-                <a:latin typeface="Calibri"/>
-              </a:defRPr>
-            </a:pPr>
-            <a:r>
-              <a:t>•  Real-time geofence verifies technician on-site labor hours</a:t>
-            </a:r>
-          </a:p>
-        </p:txBody>
-      </p:sp>
-      <p:sp>
-        <p:nvSpPr>
-          <p:cNvPr id="7" name="Rounded Rectangle 6"/>
-          <p:cNvSpPr/>
-          <p:nvPr/>
-        </p:nvSpPr>
-        <p:spPr>
-          <a:xfrm>
-            <a:off x="4404360" y="1920240"/>
-            <a:ext cx="3352800" cy="4114800"/>
-          </a:xfrm>
-          <a:prstGeom prst="roundRect">
-            <a:avLst/>
-          </a:prstGeom>
-          <a:solidFill>
-            <a:srgbClr val="F8FAFC"/>
-          </a:solidFill>
-          <a:ln w="12700">
-            <a:solidFill>
-              <a:srgbClr val="CBD5E1"/>
-            </a:solidFill>
-          </a:ln>
-        </p:spPr>
-        <p:style>
-          <a:lnRef idx="1">
-            <a:schemeClr val="accent1"/>
-          </a:lnRef>
-          <a:fillRef idx="3">
-            <a:schemeClr val="accent1"/>
-          </a:fillRef>
-          <a:effectRef idx="2">
-            <a:schemeClr val="accent1"/>
-          </a:effectRef>
-          <a:fontRef idx="minor">
-            <a:schemeClr val="lt1"/>
-          </a:fontRef>
-        </p:style>
-        <p:txBody>
-          <a:bodyPr rtlCol="0" anchor="ctr"/>
-          <a:lstStyle/>
-          <a:p>
-            <a:pPr algn="ctr"/>
-          </a:p>
-        </p:txBody>
-      </p:sp>
-      <p:sp>
-        <p:nvSpPr>
-          <p:cNvPr id="8" name="TextBox 7"/>
+              <a:t>•  Automated customer invoicing and integrated payment collection</a:t>
+            </a:r>
+          </a:p>
+        </p:txBody>
+      </p:sp>
+      <p:sp>
+        <p:nvSpPr>
+          <p:cNvPr id="6" name="TextBox 5"/>
           <p:cNvSpPr txBox="1"/>
           <p:nvPr/>
         </p:nvSpPr>
         <p:spPr>
           <a:xfrm>
-            <a:off x="4678680" y="2194560"/>
-            <a:ext cx="2804160" cy="3566160"/>
+            <a:off x="731520" y="6309360"/>
+            <a:ext cx="10698480" cy="365760"/>
           </a:xfrm>
           <a:prstGeom prst="rect">
             <a:avLst/>
@@ -4264,225 +4024,6 @@
           <a:noFill/>
         </p:spPr>
         <p:txBody>
-          <a:bodyPr wrap="square">
-            <a:spAutoFit/>
-          </a:bodyPr>
-          <a:lstStyle/>
-          <a:p>
-            <a:pPr>
-              <a:spcAft>
-                <a:spcPts val="1000"/>
-              </a:spcAft>
-              <a:defRPr sz="1500" b="1">
-                <a:solidFill>
-                  <a:srgbClr val="0F172A"/>
-                </a:solidFill>
-                <a:latin typeface="Calibri"/>
-              </a:defRPr>
-            </a:pPr>
-            <a:r>
-              <a:t>2. Offline Field Invoicing</a:t>
-            </a:r>
-          </a:p>
-          <a:p>
-            <a:pPr>
-              <a:spcAft>
-                <a:spcPts val="600"/>
-              </a:spcAft>
-              <a:defRPr sz="1100">
-                <a:solidFill>
-                  <a:srgbClr val="334155"/>
-                </a:solidFill>
-                <a:latin typeface="Calibri"/>
-              </a:defRPr>
-            </a:pPr>
-            <a:r>
-              <a:t>•  Operates seamlessly in basements and dead zones</a:t>
-            </a:r>
-          </a:p>
-          <a:p>
-            <a:pPr>
-              <a:spcAft>
-                <a:spcPts val="600"/>
-              </a:spcAft>
-              <a:defRPr sz="1100">
-                <a:solidFill>
-                  <a:srgbClr val="334155"/>
-                </a:solidFill>
-                <a:latin typeface="Calibri"/>
-              </a:defRPr>
-            </a:pPr>
-            <a:r>
-              <a:t>•  Pre-loaded parts price books with margin rules</a:t>
-            </a:r>
-          </a:p>
-          <a:p>
-            <a:pPr>
-              <a:spcAft>
-                <a:spcPts val="600"/>
-              </a:spcAft>
-              <a:defRPr sz="1100">
-                <a:solidFill>
-                  <a:srgbClr val="334155"/>
-                </a:solidFill>
-                <a:latin typeface="Calibri"/>
-              </a:defRPr>
-            </a:pPr>
-            <a:r>
-              <a:t>•  One-tap customer sign-on-glass work approval</a:t>
-            </a:r>
-          </a:p>
-        </p:txBody>
-      </p:sp>
-      <p:sp>
-        <p:nvSpPr>
-          <p:cNvPr id="9" name="Rounded Rectangle 8"/>
-          <p:cNvSpPr/>
-          <p:nvPr/>
-        </p:nvSpPr>
-        <p:spPr>
-          <a:xfrm>
-            <a:off x="8077200" y="1920240"/>
-            <a:ext cx="3352800" cy="4114800"/>
-          </a:xfrm>
-          <a:prstGeom prst="roundRect">
-            <a:avLst/>
-          </a:prstGeom>
-          <a:solidFill>
-            <a:srgbClr val="F8FAFC"/>
-          </a:solidFill>
-          <a:ln w="12700">
-            <a:solidFill>
-              <a:srgbClr val="CBD5E1"/>
-            </a:solidFill>
-          </a:ln>
-        </p:spPr>
-        <p:style>
-          <a:lnRef idx="1">
-            <a:schemeClr val="accent1"/>
-          </a:lnRef>
-          <a:fillRef idx="3">
-            <a:schemeClr val="accent1"/>
-          </a:fillRef>
-          <a:effectRef idx="2">
-            <a:schemeClr val="accent1"/>
-          </a:effectRef>
-          <a:fontRef idx="minor">
-            <a:schemeClr val="lt1"/>
-          </a:fontRef>
-        </p:style>
-        <p:txBody>
-          <a:bodyPr rtlCol="0" anchor="ctr"/>
-          <a:lstStyle/>
-          <a:p>
-            <a:pPr algn="ctr"/>
-          </a:p>
-        </p:txBody>
-      </p:sp>
-      <p:sp>
-        <p:nvSpPr>
-          <p:cNvPr id="10" name="TextBox 9"/>
-          <p:cNvSpPr txBox="1"/>
-          <p:nvPr/>
-        </p:nvSpPr>
-        <p:spPr>
-          <a:xfrm>
-            <a:off x="8351520" y="2194560"/>
-            <a:ext cx="2804160" cy="3566160"/>
-          </a:xfrm>
-          <a:prstGeom prst="rect">
-            <a:avLst/>
-          </a:prstGeom>
-          <a:noFill/>
-        </p:spPr>
-        <p:txBody>
-          <a:bodyPr wrap="square">
-            <a:spAutoFit/>
-          </a:bodyPr>
-          <a:lstStyle/>
-          <a:p>
-            <a:pPr>
-              <a:spcAft>
-                <a:spcPts val="1000"/>
-              </a:spcAft>
-              <a:defRPr sz="1500" b="1">
-                <a:solidFill>
-                  <a:srgbClr val="0F172A"/>
-                </a:solidFill>
-                <a:latin typeface="Calibri"/>
-              </a:defRPr>
-            </a:pPr>
-            <a:r>
-              <a:t>3. Integrated Mobile Payments</a:t>
-            </a:r>
-          </a:p>
-          <a:p>
-            <a:pPr>
-              <a:spcAft>
-                <a:spcPts val="600"/>
-              </a:spcAft>
-              <a:defRPr sz="1100">
-                <a:solidFill>
-                  <a:srgbClr val="334155"/>
-                </a:solidFill>
-                <a:latin typeface="Calibri"/>
-              </a:defRPr>
-            </a:pPr>
-            <a:r>
-              <a:t>•  Tap-to-Pay and card reader payment capture on-site</a:t>
-            </a:r>
-          </a:p>
-          <a:p>
-            <a:pPr>
-              <a:spcAft>
-                <a:spcPts val="600"/>
-              </a:spcAft>
-              <a:defRPr sz="1100">
-                <a:solidFill>
-                  <a:srgbClr val="334155"/>
-                </a:solidFill>
-                <a:latin typeface="Calibri"/>
-              </a:defRPr>
-            </a:pPr>
-            <a:r>
-              <a:t>•  Automated QuickBooks &amp; Xero accounting ledger sync</a:t>
-            </a:r>
-          </a:p>
-          <a:p>
-            <a:pPr>
-              <a:spcAft>
-                <a:spcPts val="600"/>
-              </a:spcAft>
-              <a:defRPr sz="1100">
-                <a:solidFill>
-                  <a:srgbClr val="334155"/>
-                </a:solidFill>
-                <a:latin typeface="Calibri"/>
-              </a:defRPr>
-            </a:pPr>
-            <a:r>
-              <a:t>•  Cuts contractor DSO from 28 days down to 0 days</a:t>
-            </a:r>
-          </a:p>
-        </p:txBody>
-      </p:sp>
-      <p:sp>
-        <p:nvSpPr>
-          <p:cNvPr id="11" name="TextBox 10"/>
-          <p:cNvSpPr txBox="1"/>
-          <p:nvPr/>
-        </p:nvSpPr>
-        <p:spPr>
-          <a:xfrm>
-            <a:off x="731520" y="6309360"/>
-            <a:ext cx="10698480" cy="365760"/>
-          </a:xfrm>
-          <a:prstGeom prst="rect">
-            <a:avLst/>
-          </a:prstGeom>
-          <a:noFill/>
-        </p:spPr>
-        <p:txBody>
           <a:bodyPr wrap="none">
             <a:spAutoFit/>
           </a:bodyPr>
@@ -4497,7 +4038,7 @@
               </a:defRPr>
             </a:pPr>
             <a:r>
-              <a:t>FieldPulse — Seed Investor Presentation · Slide 3 of 5</a:t>
+              <a:t>Alexa Quintero — Angel Investor Presentation (10 Slides) · Slide 3 of 10</a:t>
             </a:r>
           </a:p>
         </p:txBody>
@@ -4597,7 +4138,7 @@
               </a:defRPr>
             </a:pPr>
             <a:r>
-              <a:t>MARKET OPPORTUNITY</a:t>
+              <a:t>ALEXA QUINTERO — ANGEL INVESTOR PRESENTATION (10 S</a:t>
             </a:r>
           </a:p>
           <a:p>
@@ -4610,23 +4151,7 @@
               </a:defRPr>
             </a:pPr>
             <a:r>
-              <a:t>$8.2B Addressable Trade Contractor Software Market</a:t>
-            </a:r>
-          </a:p>
-          <a:p>
-            <a:pPr>
-              <a:spcBef>
-                <a:spcPts val="200"/>
-              </a:spcBef>
-              <a:defRPr sz="1200">
-                <a:solidFill>
-                  <a:srgbClr val="64748B"/>
-                </a:solidFill>
-                <a:latin typeface="Calibri"/>
-              </a:defRPr>
-            </a:pPr>
-            <a:r>
-              <a:t>Over 1.2 million trade service businesses across the United States and Canada</a:t>
+              <a:t>Market Opportunity: $8.2B TAM</a:t>
             </a:r>
           </a:p>
         </p:txBody>
@@ -4676,59 +4201,14 @@
       </p:sp>
       <p:sp>
         <p:nvSpPr>
-          <p:cNvPr id="5" name="Rounded Rectangle 4"/>
-          <p:cNvSpPr/>
-          <p:nvPr/>
-        </p:nvSpPr>
-        <p:spPr>
-          <a:xfrm>
-            <a:off x="731520" y="1920240"/>
-            <a:ext cx="2468880" cy="4114800"/>
-          </a:xfrm>
-          <a:prstGeom prst="roundRect">
-            <a:avLst/>
-          </a:prstGeom>
-          <a:solidFill>
-            <a:srgbClr val="F8FAFC"/>
-          </a:solidFill>
-          <a:ln w="12700">
-            <a:solidFill>
-              <a:srgbClr val="CBD5E1"/>
-            </a:solidFill>
-          </a:ln>
-        </p:spPr>
-        <p:style>
-          <a:lnRef idx="1">
-            <a:schemeClr val="accent1"/>
-          </a:lnRef>
-          <a:fillRef idx="3">
-            <a:schemeClr val="accent1"/>
-          </a:fillRef>
-          <a:effectRef idx="2">
-            <a:schemeClr val="accent1"/>
-          </a:effectRef>
-          <a:fontRef idx="minor">
-            <a:schemeClr val="lt1"/>
-          </a:fontRef>
-        </p:style>
-        <p:txBody>
-          <a:bodyPr rtlCol="0" anchor="ctr"/>
-          <a:lstStyle/>
-          <a:p>
-            <a:pPr algn="ctr"/>
-          </a:p>
-        </p:txBody>
-      </p:sp>
-      <p:sp>
-        <p:nvSpPr>
-          <p:cNvPr id="6" name="TextBox 5"/>
+          <p:cNvPr id="5" name="TextBox 4"/>
           <p:cNvSpPr txBox="1"/>
           <p:nvPr/>
         </p:nvSpPr>
         <p:spPr>
           <a:xfrm>
-            <a:off x="1005840" y="2286000"/>
-            <a:ext cx="1920240" cy="3383280"/>
+            <a:off x="731520" y="2011680"/>
+            <a:ext cx="10698480" cy="4114800"/>
           </a:xfrm>
           <a:prstGeom prst="rect">
             <a:avLst/>
@@ -4742,106 +4222,73 @@
           <a:lstStyle/>
           <a:p>
             <a:pPr>
+              <a:lnSpc>
+                <a:spcPct val="125000"/>
+              </a:lnSpc>
               <a:spcAft>
-                <a:spcPts val="1000"/>
+                <a:spcPts val="1400"/>
               </a:spcAft>
-              <a:defRPr sz="3600" b="1">
-                <a:solidFill>
-                  <a:srgbClr val="2563EB"/>
+              <a:defRPr sz="1500">
+                <a:solidFill>
+                  <a:srgbClr val="1E293B"/>
                 </a:solidFill>
                 <a:latin typeface="Calibri"/>
               </a:defRPr>
             </a:pPr>
             <a:r>
-              <a:t>$8.2B</a:t>
+              <a:t>•  1.2 million independent trade and field service businesses in the US &amp; Canada</a:t>
             </a:r>
           </a:p>
           <a:p>
             <a:pPr>
+              <a:lnSpc>
+                <a:spcPct val="125000"/>
+              </a:lnSpc>
               <a:spcAft>
-                <a:spcPts val="800"/>
+                <a:spcPts val="1400"/>
               </a:spcAft>
-              <a:defRPr sz="1400" b="1">
-                <a:solidFill>
-                  <a:srgbClr val="0F172A"/>
+              <a:defRPr sz="1500">
+                <a:solidFill>
+                  <a:srgbClr val="1E293B"/>
                 </a:solidFill>
                 <a:latin typeface="Calibri"/>
               </a:defRPr>
             </a:pPr>
             <a:r>
-              <a:t>Total Available Market</a:t>
+              <a:t>•  $8.2B Serviceable Available Market across plumbing, electrical, and HVAC fleets</a:t>
             </a:r>
           </a:p>
           <a:p>
             <a:pPr>
-              <a:defRPr sz="1100">
-                <a:solidFill>
-                  <a:srgbClr val="64748B"/>
+              <a:lnSpc>
+                <a:spcPct val="125000"/>
+              </a:lnSpc>
+              <a:spcAft>
+                <a:spcPts val="1400"/>
+              </a:spcAft>
+              <a:defRPr sz="1500">
+                <a:solidFill>
+                  <a:srgbClr val="1E293B"/>
                 </a:solidFill>
                 <a:latin typeface="Calibri"/>
               </a:defRPr>
             </a:pPr>
             <a:r>
-              <a:t>North American commercial &amp; residential trade contractors</a:t>
-            </a:r>
-          </a:p>
-        </p:txBody>
-      </p:sp>
-      <p:sp>
-        <p:nvSpPr>
-          <p:cNvPr id="7" name="Rounded Rectangle 6"/>
-          <p:cNvSpPr/>
-          <p:nvPr/>
-        </p:nvSpPr>
-        <p:spPr>
-          <a:xfrm>
-            <a:off x="3474720" y="1920240"/>
-            <a:ext cx="2468880" cy="4114800"/>
-          </a:xfrm>
-          <a:prstGeom prst="roundRect">
-            <a:avLst/>
-          </a:prstGeom>
-          <a:solidFill>
-            <a:srgbClr val="F8FAFC"/>
-          </a:solidFill>
-          <a:ln w="12700">
-            <a:solidFill>
-              <a:srgbClr val="CBD5E1"/>
-            </a:solidFill>
-          </a:ln>
-        </p:spPr>
-        <p:style>
-          <a:lnRef idx="1">
-            <a:schemeClr val="accent1"/>
-          </a:lnRef>
-          <a:fillRef idx="3">
-            <a:schemeClr val="accent1"/>
-          </a:fillRef>
-          <a:effectRef idx="2">
-            <a:schemeClr val="accent1"/>
-          </a:effectRef>
-          <a:fontRef idx="minor">
-            <a:schemeClr val="lt1"/>
-          </a:fontRef>
-        </p:style>
-        <p:txBody>
-          <a:bodyPr rtlCol="0" anchor="ctr"/>
-          <a:lstStyle/>
-          <a:p>
-            <a:pPr algn="ctr"/>
-          </a:p>
-        </p:txBody>
-      </p:sp>
-      <p:sp>
-        <p:nvSpPr>
-          <p:cNvPr id="8" name="TextBox 7"/>
+              <a:t>•  Initial beachhead: 15,000 plumbing &amp; HVAC fleets with 5-25 service vans</a:t>
+            </a:r>
+          </a:p>
+        </p:txBody>
+      </p:sp>
+      <p:sp>
+        <p:nvSpPr>
+          <p:cNvPr id="6" name="TextBox 5"/>
           <p:cNvSpPr txBox="1"/>
           <p:nvPr/>
         </p:nvSpPr>
         <p:spPr>
           <a:xfrm>
-            <a:off x="3749040" y="2286000"/>
-            <a:ext cx="1920240" cy="3383280"/>
+            <a:off x="731520" y="6309360"/>
+            <a:ext cx="10698480" cy="365760"/>
           </a:xfrm>
           <a:prstGeom prst="rect">
             <a:avLst/>
@@ -4849,300 +4296,6 @@
           <a:noFill/>
         </p:spPr>
         <p:txBody>
-          <a:bodyPr wrap="square">
-            <a:spAutoFit/>
-          </a:bodyPr>
-          <a:lstStyle/>
-          <a:p>
-            <a:pPr>
-              <a:spcAft>
-                <a:spcPts val="1000"/>
-              </a:spcAft>
-              <a:defRPr sz="3600" b="1">
-                <a:solidFill>
-                  <a:srgbClr val="2563EB"/>
-                </a:solidFill>
-                <a:latin typeface="Calibri"/>
-              </a:defRPr>
-            </a:pPr>
-            <a:r>
-              <a:t>$1.4B</a:t>
-            </a:r>
-          </a:p>
-          <a:p>
-            <a:pPr>
-              <a:spcAft>
-                <a:spcPts val="800"/>
-              </a:spcAft>
-              <a:defRPr sz="1400" b="1">
-                <a:solidFill>
-                  <a:srgbClr val="0F172A"/>
-                </a:solidFill>
-                <a:latin typeface="Calibri"/>
-              </a:defRPr>
-            </a:pPr>
-            <a:r>
-              <a:t>Serviceable Market</a:t>
-            </a:r>
-          </a:p>
-          <a:p>
-            <a:pPr>
-              <a:defRPr sz="1100">
-                <a:solidFill>
-                  <a:srgbClr val="64748B"/>
-                </a:solidFill>
-                <a:latin typeface="Calibri"/>
-              </a:defRPr>
-            </a:pPr>
-            <a:r>
-              <a:t>Plumbing, electrical, and HVAC fleets with 5–30 vans</a:t>
-            </a:r>
-          </a:p>
-        </p:txBody>
-      </p:sp>
-      <p:sp>
-        <p:nvSpPr>
-          <p:cNvPr id="9" name="Rounded Rectangle 8"/>
-          <p:cNvSpPr/>
-          <p:nvPr/>
-        </p:nvSpPr>
-        <p:spPr>
-          <a:xfrm>
-            <a:off x="6217920" y="1920240"/>
-            <a:ext cx="2468880" cy="4114800"/>
-          </a:xfrm>
-          <a:prstGeom prst="roundRect">
-            <a:avLst/>
-          </a:prstGeom>
-          <a:solidFill>
-            <a:srgbClr val="F8FAFC"/>
-          </a:solidFill>
-          <a:ln w="12700">
-            <a:solidFill>
-              <a:srgbClr val="CBD5E1"/>
-            </a:solidFill>
-          </a:ln>
-        </p:spPr>
-        <p:style>
-          <a:lnRef idx="1">
-            <a:schemeClr val="accent1"/>
-          </a:lnRef>
-          <a:fillRef idx="3">
-            <a:schemeClr val="accent1"/>
-          </a:fillRef>
-          <a:effectRef idx="2">
-            <a:schemeClr val="accent1"/>
-          </a:effectRef>
-          <a:fontRef idx="minor">
-            <a:schemeClr val="lt1"/>
-          </a:fontRef>
-        </p:style>
-        <p:txBody>
-          <a:bodyPr rtlCol="0" anchor="ctr"/>
-          <a:lstStyle/>
-          <a:p>
-            <a:pPr algn="ctr"/>
-          </a:p>
-        </p:txBody>
-      </p:sp>
-      <p:sp>
-        <p:nvSpPr>
-          <p:cNvPr id="10" name="TextBox 9"/>
-          <p:cNvSpPr txBox="1"/>
-          <p:nvPr/>
-        </p:nvSpPr>
-        <p:spPr>
-          <a:xfrm>
-            <a:off x="6492240" y="2286000"/>
-            <a:ext cx="1920240" cy="3383280"/>
-          </a:xfrm>
-          <a:prstGeom prst="rect">
-            <a:avLst/>
-          </a:prstGeom>
-          <a:noFill/>
-        </p:spPr>
-        <p:txBody>
-          <a:bodyPr wrap="square">
-            <a:spAutoFit/>
-          </a:bodyPr>
-          <a:lstStyle/>
-          <a:p>
-            <a:pPr>
-              <a:spcAft>
-                <a:spcPts val="1000"/>
-              </a:spcAft>
-              <a:defRPr sz="3600" b="1">
-                <a:solidFill>
-                  <a:srgbClr val="2563EB"/>
-                </a:solidFill>
-                <a:latin typeface="Calibri"/>
-              </a:defRPr>
-            </a:pPr>
-            <a:r>
-              <a:t>180,000</a:t>
-            </a:r>
-          </a:p>
-          <a:p>
-            <a:pPr>
-              <a:spcAft>
-                <a:spcPts val="800"/>
-              </a:spcAft>
-              <a:defRPr sz="1400" b="1">
-                <a:solidFill>
-                  <a:srgbClr val="0F172A"/>
-                </a:solidFill>
-                <a:latin typeface="Calibri"/>
-              </a:defRPr>
-            </a:pPr>
-            <a:r>
-              <a:t>Target Fleet Businesses</a:t>
-            </a:r>
-          </a:p>
-          <a:p>
-            <a:pPr>
-              <a:defRPr sz="1100">
-                <a:solidFill>
-                  <a:srgbClr val="64748B"/>
-                </a:solidFill>
-                <a:latin typeface="Calibri"/>
-              </a:defRPr>
-            </a:pPr>
-            <a:r>
-              <a:t>Under-served by expensive legacy enterprise software</a:t>
-            </a:r>
-          </a:p>
-        </p:txBody>
-      </p:sp>
-      <p:sp>
-        <p:nvSpPr>
-          <p:cNvPr id="11" name="Rounded Rectangle 10"/>
-          <p:cNvSpPr/>
-          <p:nvPr/>
-        </p:nvSpPr>
-        <p:spPr>
-          <a:xfrm>
-            <a:off x="8961120" y="1920240"/>
-            <a:ext cx="2468880" cy="4114800"/>
-          </a:xfrm>
-          <a:prstGeom prst="roundRect">
-            <a:avLst/>
-          </a:prstGeom>
-          <a:solidFill>
-            <a:srgbClr val="F8FAFC"/>
-          </a:solidFill>
-          <a:ln w="12700">
-            <a:solidFill>
-              <a:srgbClr val="CBD5E1"/>
-            </a:solidFill>
-          </a:ln>
-        </p:spPr>
-        <p:style>
-          <a:lnRef idx="1">
-            <a:schemeClr val="accent1"/>
-          </a:lnRef>
-          <a:fillRef idx="3">
-            <a:schemeClr val="accent1"/>
-          </a:fillRef>
-          <a:effectRef idx="2">
-            <a:schemeClr val="accent1"/>
-          </a:effectRef>
-          <a:fontRef idx="minor">
-            <a:schemeClr val="lt1"/>
-          </a:fontRef>
-        </p:style>
-        <p:txBody>
-          <a:bodyPr rtlCol="0" anchor="ctr"/>
-          <a:lstStyle/>
-          <a:p>
-            <a:pPr algn="ctr"/>
-          </a:p>
-        </p:txBody>
-      </p:sp>
-      <p:sp>
-        <p:nvSpPr>
-          <p:cNvPr id="12" name="TextBox 11"/>
-          <p:cNvSpPr txBox="1"/>
-          <p:nvPr/>
-        </p:nvSpPr>
-        <p:spPr>
-          <a:xfrm>
-            <a:off x="9235440" y="2286000"/>
-            <a:ext cx="1920240" cy="3383280"/>
-          </a:xfrm>
-          <a:prstGeom prst="rect">
-            <a:avLst/>
-          </a:prstGeom>
-          <a:noFill/>
-        </p:spPr>
-        <p:txBody>
-          <a:bodyPr wrap="square">
-            <a:spAutoFit/>
-          </a:bodyPr>
-          <a:lstStyle/>
-          <a:p>
-            <a:pPr>
-              <a:spcAft>
-                <a:spcPts val="1000"/>
-              </a:spcAft>
-              <a:defRPr sz="3600" b="1">
-                <a:solidFill>
-                  <a:srgbClr val="2563EB"/>
-                </a:solidFill>
-                <a:latin typeface="Calibri"/>
-              </a:defRPr>
-            </a:pPr>
-            <a:r>
-              <a:t>$89 / mo</a:t>
-            </a:r>
-          </a:p>
-          <a:p>
-            <a:pPr>
-              <a:spcAft>
-                <a:spcPts val="800"/>
-              </a:spcAft>
-              <a:defRPr sz="1400" b="1">
-                <a:solidFill>
-                  <a:srgbClr val="0F172A"/>
-                </a:solidFill>
-                <a:latin typeface="Calibri"/>
-              </a:defRPr>
-            </a:pPr>
-            <a:r>
-              <a:t>Subscription Seat Fee</a:t>
-            </a:r>
-          </a:p>
-          <a:p>
-            <a:pPr>
-              <a:defRPr sz="1100">
-                <a:solidFill>
-                  <a:srgbClr val="64748B"/>
-                </a:solidFill>
-                <a:latin typeface="Calibri"/>
-              </a:defRPr>
-            </a:pPr>
-            <a:r>
-              <a:t>Per active technician with 92% gross software margin</a:t>
-            </a:r>
-          </a:p>
-        </p:txBody>
-      </p:sp>
-      <p:sp>
-        <p:nvSpPr>
-          <p:cNvPr id="13" name="TextBox 12"/>
-          <p:cNvSpPr txBox="1"/>
-          <p:nvPr/>
-        </p:nvSpPr>
-        <p:spPr>
-          <a:xfrm>
-            <a:off x="731520" y="6309360"/>
-            <a:ext cx="10698480" cy="365760"/>
-          </a:xfrm>
-          <a:prstGeom prst="rect">
-            <a:avLst/>
-          </a:prstGeom>
-          <a:noFill/>
-        </p:spPr>
-        <p:txBody>
           <a:bodyPr wrap="none">
             <a:spAutoFit/>
           </a:bodyPr>
@@ -5157,7 +4310,7 @@
               </a:defRPr>
             </a:pPr>
             <a:r>
-              <a:t>FieldPulse — Seed Investor Presentation · Slide 4 of 5</a:t>
+              <a:t>Alexa Quintero — Angel Investor Presentation (10 Slides) · Slide 4 of 10</a:t>
             </a:r>
           </a:p>
         </p:txBody>
@@ -5257,7 +4410,7 @@
               </a:defRPr>
             </a:pPr>
             <a:r>
-              <a:t>TRACTION &amp; SEED ASK</a:t>
+              <a:t>ALEXA QUINTERO — ANGEL INVESTOR PRESENTATION (10 S</a:t>
             </a:r>
           </a:p>
           <a:p>
@@ -5270,23 +4423,7 @@
               </a:defRPr>
             </a:pPr>
             <a:r>
-              <a:t>Traction Benchmarks &amp; $1.8M Seed Financing Round</a:t>
-            </a:r>
-          </a:p>
-          <a:p>
-            <a:pPr>
-              <a:spcBef>
-                <a:spcPts val="200"/>
-              </a:spcBef>
-              <a:defRPr sz="1200">
-                <a:solidFill>
-                  <a:srgbClr val="64748B"/>
-                </a:solidFill>
-                <a:latin typeface="Calibri"/>
-              </a:defRPr>
-            </a:pPr>
-            <a:r>
-              <a:t>Accelerating engineering velocity and mid-market field sales expansion</a:t>
+              <a:t>Product Architecture &amp; Moat</a:t>
             </a:r>
           </a:p>
         </p:txBody>
@@ -5336,25 +4473,157 @@
       </p:sp>
       <p:sp>
         <p:nvSpPr>
-          <p:cNvPr id="5" name="Rounded Rectangle 4"/>
+          <p:cNvPr id="5" name="TextBox 4"/>
+          <p:cNvSpPr txBox="1"/>
+          <p:nvPr/>
+        </p:nvSpPr>
+        <p:spPr>
+          <a:xfrm>
+            <a:off x="731520" y="2011680"/>
+            <a:ext cx="10698480" cy="4114800"/>
+          </a:xfrm>
+          <a:prstGeom prst="rect">
+            <a:avLst/>
+          </a:prstGeom>
+          <a:noFill/>
+        </p:spPr>
+        <p:txBody>
+          <a:bodyPr wrap="square">
+            <a:spAutoFit/>
+          </a:bodyPr>
+          <a:lstStyle/>
+          <a:p>
+            <a:pPr>
+              <a:lnSpc>
+                <a:spcPct val="125000"/>
+              </a:lnSpc>
+              <a:spcAft>
+                <a:spcPts val="1400"/>
+              </a:spcAft>
+              <a:defRPr sz="1500">
+                <a:solidFill>
+                  <a:srgbClr val="1E293B"/>
+                </a:solidFill>
+                <a:latin typeface="Calibri"/>
+              </a:defRPr>
+            </a:pPr>
+            <a:r>
+              <a:t>•  Native offline-first mobile sync engine</a:t>
+            </a:r>
+          </a:p>
+          <a:p>
+            <a:pPr>
+              <a:lnSpc>
+                <a:spcPct val="125000"/>
+              </a:lnSpc>
+              <a:spcAft>
+                <a:spcPts val="1400"/>
+              </a:spcAft>
+              <a:defRPr sz="1500">
+                <a:solidFill>
+                  <a:srgbClr val="1E293B"/>
+                </a:solidFill>
+                <a:latin typeface="Calibri"/>
+              </a:defRPr>
+            </a:pPr>
+            <a:r>
+              <a:t>•  Direct two-way accounting sync into QuickBooks and Xero</a:t>
+            </a:r>
+          </a:p>
+          <a:p>
+            <a:pPr>
+              <a:lnSpc>
+                <a:spcPct val="125000"/>
+              </a:lnSpc>
+              <a:spcAft>
+                <a:spcPts val="1400"/>
+              </a:spcAft>
+              <a:defRPr sz="1500">
+                <a:solidFill>
+                  <a:srgbClr val="1E293B"/>
+                </a:solidFill>
+                <a:latin typeface="Calibri"/>
+              </a:defRPr>
+            </a:pPr>
+            <a:r>
+              <a:t>•  Zero onboarding friction: operational within 24 hours of setup</a:t>
+            </a:r>
+          </a:p>
+        </p:txBody>
+      </p:sp>
+      <p:sp>
+        <p:nvSpPr>
+          <p:cNvPr id="6" name="TextBox 5"/>
+          <p:cNvSpPr txBox="1"/>
+          <p:nvPr/>
+        </p:nvSpPr>
+        <p:spPr>
+          <a:xfrm>
+            <a:off x="731520" y="6309360"/>
+            <a:ext cx="10698480" cy="365760"/>
+          </a:xfrm>
+          <a:prstGeom prst="rect">
+            <a:avLst/>
+          </a:prstGeom>
+          <a:noFill/>
+        </p:spPr>
+        <p:txBody>
+          <a:bodyPr wrap="none">
+            <a:spAutoFit/>
+          </a:bodyPr>
+          <a:lstStyle/>
+          <a:p>
+            <a:pPr>
+              <a:defRPr sz="900">
+                <a:solidFill>
+                  <a:srgbClr val="94A3B8"/>
+                </a:solidFill>
+                <a:latin typeface="Calibri"/>
+              </a:defRPr>
+            </a:pPr>
+            <a:r>
+              <a:t>Alexa Quintero — Angel Investor Presentation (10 Slides) · Slide 5 of 10</a:t>
+            </a:r>
+          </a:p>
+        </p:txBody>
+      </p:sp>
+    </p:spTree>
+  </p:cSld>
+  <p:clrMapOvr>
+    <a:masterClrMapping/>
+  </p:clrMapOvr>
+</p:sld>
+</file>
+
+<file path=ppt/slides/slide6.xml><?xml version="1.0" encoding="utf-8"?>
+<p:sld xmlns:a="http://schemas.openxmlformats.org/drawingml/2006/main" xmlns:p="http://schemas.openxmlformats.org/presentationml/2006/main" xmlns:r="http://schemas.openxmlformats.org/officeDocument/2006/relationships">
+  <p:cSld>
+    <p:spTree>
+      <p:nvGrpSpPr>
+        <p:cNvPr id="1" name=""/>
+        <p:cNvGrpSpPr/>
+        <p:nvPr/>
+      </p:nvGrpSpPr>
+      <p:grpSpPr/>
+      <p:sp>
+        <p:nvSpPr>
+          <p:cNvPr id="2" name="Rectangle 1"/>
           <p:cNvSpPr/>
           <p:nvPr/>
         </p:nvSpPr>
         <p:spPr>
           <a:xfrm>
-            <a:off x="731520" y="1920240"/>
-            <a:ext cx="3352800" cy="4114800"/>
-          </a:xfrm>
-          <a:prstGeom prst="roundRect">
+            <a:off x="0" y="0"/>
+            <a:ext cx="12191695" cy="6858000"/>
+          </a:xfrm>
+          <a:prstGeom prst="rect">
             <a:avLst/>
           </a:prstGeom>
           <a:solidFill>
-            <a:srgbClr val="F8FAFC"/>
+            <a:srgbClr val="FFFFFF"/>
           </a:solidFill>
-          <a:ln w="12700">
-            <a:solidFill>
-              <a:srgbClr val="CBD5E1"/>
-            </a:solidFill>
+          <a:ln>
+            <a:noFill/>
           </a:ln>
         </p:spPr>
         <p:style>
@@ -5381,14 +4650,14 @@
       </p:sp>
       <p:sp>
         <p:nvSpPr>
-          <p:cNvPr id="6" name="TextBox 5"/>
+          <p:cNvPr id="3" name="TextBox 2"/>
           <p:cNvSpPr txBox="1"/>
           <p:nvPr/>
         </p:nvSpPr>
         <p:spPr>
           <a:xfrm>
-            <a:off x="1005840" y="2194560"/>
-            <a:ext cx="2804160" cy="3566160"/>
+            <a:off x="731520" y="548640"/>
+            <a:ext cx="10698480" cy="1188720"/>
           </a:xfrm>
           <a:prstGeom prst="rect">
             <a:avLst/>
@@ -5403,9 +4672,22 @@
           <a:p>
             <a:pPr>
               <a:spcAft>
-                <a:spcPts val="1000"/>
+                <a:spcPts val="400"/>
               </a:spcAft>
-              <a:defRPr sz="1500" b="1">
+              <a:defRPr sz="1000" b="1">
+                <a:solidFill>
+                  <a:srgbClr val="2563EB"/>
+                </a:solidFill>
+                <a:latin typeface="Calibri"/>
+              </a:defRPr>
+            </a:pPr>
+            <a:r>
+              <a:t>ALEXA QUINTERO — ANGEL INVESTOR PRESENTATION (10 S</a:t>
+            </a:r>
+          </a:p>
+          <a:p>
+            <a:pPr>
+              <a:defRPr sz="2200" b="1">
                 <a:solidFill>
                   <a:srgbClr val="0F172A"/>
                 </a:solidFill>
@@ -5413,80 +4695,30 @@
               </a:defRPr>
             </a:pPr>
             <a:r>
-              <a:t>Current Traction (Q3 2026)</a:t>
-            </a:r>
-          </a:p>
-          <a:p>
-            <a:pPr>
-              <a:spcAft>
-                <a:spcPts val="600"/>
-              </a:spcAft>
-              <a:defRPr sz="1100">
-                <a:solidFill>
-                  <a:srgbClr val="334155"/>
-                </a:solidFill>
-                <a:latin typeface="Calibri"/>
-              </a:defRPr>
-            </a:pPr>
-            <a:r>
-              <a:t>•  $310,000 Annual Recurring Revenue (ARR)</a:t>
-            </a:r>
-          </a:p>
-          <a:p>
-            <a:pPr>
-              <a:spcAft>
-                <a:spcPts val="600"/>
-              </a:spcAft>
-              <a:defRPr sz="1100">
-                <a:solidFill>
-                  <a:srgbClr val="334155"/>
-                </a:solidFill>
-                <a:latin typeface="Calibri"/>
-              </a:defRPr>
-            </a:pPr>
-            <a:r>
-              <a:t>•  42 Paid Contractor Fleets across 8 metropolitan markets</a:t>
-            </a:r>
-          </a:p>
-          <a:p>
-            <a:pPr>
-              <a:spcAft>
-                <a:spcPts val="600"/>
-              </a:spcAft>
-              <a:defRPr sz="1100">
-                <a:solidFill>
-                  <a:srgbClr val="334155"/>
-                </a:solidFill>
-                <a:latin typeface="Calibri"/>
-              </a:defRPr>
-            </a:pPr>
-            <a:r>
-              <a:t>•  98.4% Monthly Customer Retention with 4.9 App Store rating</a:t>
-            </a:r>
-          </a:p>
-        </p:txBody>
-      </p:sp>
-      <p:sp>
-        <p:nvSpPr>
-          <p:cNvPr id="7" name="Rounded Rectangle 6"/>
+              <a:t>Traction &amp; Early Unit Economics</a:t>
+            </a:r>
+          </a:p>
+        </p:txBody>
+      </p:sp>
+      <p:sp>
+        <p:nvSpPr>
+          <p:cNvPr id="4" name="Rectangle 3"/>
           <p:cNvSpPr/>
           <p:nvPr/>
         </p:nvSpPr>
         <p:spPr>
           <a:xfrm>
-            <a:off x="4404360" y="1920240"/>
-            <a:ext cx="3352800" cy="4114800"/>
-          </a:xfrm>
-          <a:prstGeom prst="roundRect">
+            <a:off x="731520" y="1737360"/>
+            <a:ext cx="10698480" cy="13716"/>
+          </a:xfrm>
+          <a:prstGeom prst="rect">
             <a:avLst/>
           </a:prstGeom>
           <a:solidFill>
-            <a:srgbClr val="F8FAFC"/>
+            <a:srgbClr val="E2E8F0"/>
           </a:solidFill>
-          <a:ln w="12700">
-            <a:solidFill>
-              <a:srgbClr val="CBD5E1"/>
-            </a:solidFill>
+          <a:ln>
+            <a:noFill/>
           </a:ln>
         </p:spPr>
         <p:style>
@@ -5513,14 +4745,14 @@
       </p:sp>
       <p:sp>
         <p:nvSpPr>
-          <p:cNvPr id="8" name="TextBox 7"/>
+          <p:cNvPr id="5" name="TextBox 4"/>
           <p:cNvSpPr txBox="1"/>
           <p:nvPr/>
         </p:nvSpPr>
         <p:spPr>
           <a:xfrm>
-            <a:off x="4678680" y="2194560"/>
-            <a:ext cx="2804160" cy="3566160"/>
+            <a:off x="731520" y="2011680"/>
+            <a:ext cx="10698480" cy="4114800"/>
           </a:xfrm>
           <a:prstGeom prst="rect">
             <a:avLst/>
@@ -5534,91 +4766,136 @@
           <a:lstStyle/>
           <a:p>
             <a:pPr>
+              <a:lnSpc>
+                <a:spcPct val="125000"/>
+              </a:lnSpc>
               <a:spcAft>
-                <a:spcPts val="1000"/>
+                <a:spcPts val="1400"/>
               </a:spcAft>
-              <a:defRPr sz="1500" b="1">
-                <a:solidFill>
-                  <a:srgbClr val="0F172A"/>
+              <a:defRPr sz="1500">
+                <a:solidFill>
+                  <a:srgbClr val="1E293B"/>
                 </a:solidFill>
                 <a:latin typeface="Calibri"/>
               </a:defRPr>
             </a:pPr>
             <a:r>
-              <a:t>Use of Seed Proceeds ($1.8M)</a:t>
+              <a:t>•  28 paid pilot contractors signed in first 90 days</a:t>
             </a:r>
           </a:p>
           <a:p>
             <a:pPr>
+              <a:lnSpc>
+                <a:spcPct val="125000"/>
+              </a:lnSpc>
               <a:spcAft>
-                <a:spcPts val="600"/>
+                <a:spcPts val="1400"/>
               </a:spcAft>
-              <a:defRPr sz="1100">
-                <a:solidFill>
-                  <a:srgbClr val="334155"/>
+              <a:defRPr sz="1500">
+                <a:solidFill>
+                  <a:srgbClr val="1E293B"/>
                 </a:solidFill>
                 <a:latin typeface="Calibri"/>
               </a:defRPr>
             </a:pPr>
             <a:r>
-              <a:t>•  60% Engineering: Automated parts inventory and AI quoting</a:t>
+              <a:t>•  $14,200 Monthly Recurring Revenue ($507 average fleet ARPU)</a:t>
             </a:r>
           </a:p>
           <a:p>
             <a:pPr>
+              <a:lnSpc>
+                <a:spcPct val="125000"/>
+              </a:lnSpc>
               <a:spcAft>
-                <a:spcPts val="600"/>
+                <a:spcPts val="1400"/>
               </a:spcAft>
-              <a:defRPr sz="1100">
-                <a:solidFill>
-                  <a:srgbClr val="334155"/>
+              <a:defRPr sz="1500">
+                <a:solidFill>
+                  <a:srgbClr val="1E293B"/>
                 </a:solidFill>
                 <a:latin typeface="Calibri"/>
               </a:defRPr>
             </a:pPr>
             <a:r>
-              <a:t>•  25% Inside Sales &amp; Trade Association Channel Marketing</a:t>
-            </a:r>
-          </a:p>
+              <a:t>•  Zero logo churn since launch with 4.9/5 mobile app rating</a:t>
+            </a:r>
+          </a:p>
+        </p:txBody>
+      </p:sp>
+      <p:sp>
+        <p:nvSpPr>
+          <p:cNvPr id="6" name="TextBox 5"/>
+          <p:cNvSpPr txBox="1"/>
+          <p:nvPr/>
+        </p:nvSpPr>
+        <p:spPr>
+          <a:xfrm>
+            <a:off x="731520" y="6309360"/>
+            <a:ext cx="10698480" cy="365760"/>
+          </a:xfrm>
+          <a:prstGeom prst="rect">
+            <a:avLst/>
+          </a:prstGeom>
+          <a:noFill/>
+        </p:spPr>
+        <p:txBody>
+          <a:bodyPr wrap="none">
+            <a:spAutoFit/>
+          </a:bodyPr>
+          <a:lstStyle/>
           <a:p>
             <a:pPr>
-              <a:spcAft>
-                <a:spcPts val="600"/>
-              </a:spcAft>
-              <a:defRPr sz="1100">
-                <a:solidFill>
-                  <a:srgbClr val="334155"/>
+              <a:defRPr sz="900">
+                <a:solidFill>
+                  <a:srgbClr val="94A3B8"/>
                 </a:solidFill>
                 <a:latin typeface="Calibri"/>
               </a:defRPr>
             </a:pPr>
             <a:r>
-              <a:t>•  15% Customer Onboarding, Success &amp; Regulatory Compliance</a:t>
-            </a:r>
-          </a:p>
-        </p:txBody>
-      </p:sp>
-      <p:sp>
-        <p:nvSpPr>
-          <p:cNvPr id="9" name="Rounded Rectangle 8"/>
+              <a:t>Alexa Quintero — Angel Investor Presentation (10 Slides) · Slide 6 of 10</a:t>
+            </a:r>
+          </a:p>
+        </p:txBody>
+      </p:sp>
+    </p:spTree>
+  </p:cSld>
+  <p:clrMapOvr>
+    <a:masterClrMapping/>
+  </p:clrMapOvr>
+</p:sld>
+</file>
+
+<file path=ppt/slides/slide7.xml><?xml version="1.0" encoding="utf-8"?>
+<p:sld xmlns:a="http://schemas.openxmlformats.org/drawingml/2006/main" xmlns:p="http://schemas.openxmlformats.org/presentationml/2006/main" xmlns:r="http://schemas.openxmlformats.org/officeDocument/2006/relationships">
+  <p:cSld>
+    <p:spTree>
+      <p:nvGrpSpPr>
+        <p:cNvPr id="1" name=""/>
+        <p:cNvGrpSpPr/>
+        <p:nvPr/>
+      </p:nvGrpSpPr>
+      <p:grpSpPr/>
+      <p:sp>
+        <p:nvSpPr>
+          <p:cNvPr id="2" name="Rectangle 1"/>
           <p:cNvSpPr/>
           <p:nvPr/>
         </p:nvSpPr>
         <p:spPr>
           <a:xfrm>
-            <a:off x="8077200" y="1920240"/>
-            <a:ext cx="3352800" cy="4114800"/>
-          </a:xfrm>
-          <a:prstGeom prst="roundRect">
+            <a:off x="0" y="0"/>
+            <a:ext cx="12191695" cy="6858000"/>
+          </a:xfrm>
+          <a:prstGeom prst="rect">
             <a:avLst/>
           </a:prstGeom>
           <a:solidFill>
-            <a:srgbClr val="F8FAFC"/>
+            <a:srgbClr val="FFFFFF"/>
           </a:solidFill>
-          <a:ln w="12700">
-            <a:solidFill>
-              <a:srgbClr val="CBD5E1"/>
-            </a:solidFill>
+          <a:ln>
+            <a:noFill/>
           </a:ln>
         </p:spPr>
         <p:style>
@@ -5645,14 +4922,14 @@
       </p:sp>
       <p:sp>
         <p:nvSpPr>
-          <p:cNvPr id="10" name="TextBox 9"/>
+          <p:cNvPr id="3" name="TextBox 2"/>
           <p:cNvSpPr txBox="1"/>
           <p:nvPr/>
         </p:nvSpPr>
         <p:spPr>
           <a:xfrm>
-            <a:off x="8351520" y="2194560"/>
-            <a:ext cx="2804160" cy="3566160"/>
+            <a:off x="731520" y="548640"/>
+            <a:ext cx="10698480" cy="1188720"/>
           </a:xfrm>
           <a:prstGeom prst="rect">
             <a:avLst/>
@@ -5667,9 +4944,22 @@
           <a:p>
             <a:pPr>
               <a:spcAft>
-                <a:spcPts val="1000"/>
+                <a:spcPts val="400"/>
               </a:spcAft>
-              <a:defRPr sz="1500" b="1">
+              <a:defRPr sz="1000" b="1">
+                <a:solidFill>
+                  <a:srgbClr val="2563EB"/>
+                </a:solidFill>
+                <a:latin typeface="Calibri"/>
+              </a:defRPr>
+            </a:pPr>
+            <a:r>
+              <a:t>ALEXA QUINTERO — ANGEL INVESTOR PRESENTATION (10 S</a:t>
+            </a:r>
+          </a:p>
+          <a:p>
+            <a:pPr>
+              <a:defRPr sz="2200" b="1">
                 <a:solidFill>
                   <a:srgbClr val="0F172A"/>
                 </a:solidFill>
@@ -5677,69 +4967,64 @@
               </a:defRPr>
             </a:pPr>
             <a:r>
-              <a:t>18-Month Target Milestones</a:t>
-            </a:r>
-          </a:p>
-          <a:p>
-            <a:pPr>
-              <a:spcAft>
-                <a:spcPts val="600"/>
-              </a:spcAft>
-              <a:defRPr sz="1100">
-                <a:solidFill>
-                  <a:srgbClr val="334155"/>
-                </a:solidFill>
-                <a:latin typeface="Calibri"/>
-              </a:defRPr>
-            </a:pPr>
-            <a:r>
-              <a:t>•  Expand from 42 to 240 active contractor fleets</a:t>
-            </a:r>
-          </a:p>
-          <a:p>
-            <a:pPr>
-              <a:spcAft>
-                <a:spcPts val="600"/>
-              </a:spcAft>
-              <a:defRPr sz="1100">
-                <a:solidFill>
-                  <a:srgbClr val="334155"/>
-                </a:solidFill>
-                <a:latin typeface="Calibri"/>
-              </a:defRPr>
-            </a:pPr>
-            <a:r>
-              <a:t>•  Scale ARR from $310k to $2.2M run-rate</a:t>
-            </a:r>
-          </a:p>
-          <a:p>
-            <a:pPr>
-              <a:spcAft>
-                <a:spcPts val="600"/>
-              </a:spcAft>
-              <a:defRPr sz="1100">
-                <a:solidFill>
-                  <a:srgbClr val="334155"/>
-                </a:solidFill>
-                <a:latin typeface="Calibri"/>
-              </a:defRPr>
-            </a:pPr>
-            <a:r>
-              <a:t>•  Position company for Tier 1 Series A growth round</a:t>
-            </a:r>
-          </a:p>
-        </p:txBody>
-      </p:sp>
-      <p:sp>
-        <p:nvSpPr>
-          <p:cNvPr id="11" name="TextBox 10"/>
+              <a:t>Go-To-Market Strategy</a:t>
+            </a:r>
+          </a:p>
+        </p:txBody>
+      </p:sp>
+      <p:sp>
+        <p:nvSpPr>
+          <p:cNvPr id="4" name="Rectangle 3"/>
+          <p:cNvSpPr/>
+          <p:nvPr/>
+        </p:nvSpPr>
+        <p:spPr>
+          <a:xfrm>
+            <a:off x="731520" y="1737360"/>
+            <a:ext cx="10698480" cy="13716"/>
+          </a:xfrm>
+          <a:prstGeom prst="rect">
+            <a:avLst/>
+          </a:prstGeom>
+          <a:solidFill>
+            <a:srgbClr val="E2E8F0"/>
+          </a:solidFill>
+          <a:ln>
+            <a:noFill/>
+          </a:ln>
+        </p:spPr>
+        <p:style>
+          <a:lnRef idx="1">
+            <a:schemeClr val="accent1"/>
+          </a:lnRef>
+          <a:fillRef idx="3">
+            <a:schemeClr val="accent1"/>
+          </a:fillRef>
+          <a:effectRef idx="2">
+            <a:schemeClr val="accent1"/>
+          </a:effectRef>
+          <a:fontRef idx="minor">
+            <a:schemeClr val="lt1"/>
+          </a:fontRef>
+        </p:style>
+        <p:txBody>
+          <a:bodyPr rtlCol="0" anchor="ctr"/>
+          <a:lstStyle/>
+          <a:p>
+            <a:pPr algn="ctr"/>
+          </a:p>
+        </p:txBody>
+      </p:sp>
+      <p:sp>
+        <p:nvSpPr>
+          <p:cNvPr id="5" name="TextBox 4"/>
           <p:cNvSpPr txBox="1"/>
           <p:nvPr/>
         </p:nvSpPr>
         <p:spPr>
           <a:xfrm>
-            <a:off x="731520" y="6309360"/>
-            <a:ext cx="10698480" cy="365760"/>
+            <a:off x="731520" y="2011680"/>
+            <a:ext cx="10698480" cy="4114800"/>
           </a:xfrm>
           <a:prstGeom prst="rect">
             <a:avLst/>
@@ -5747,6 +5032,86 @@
           <a:noFill/>
         </p:spPr>
         <p:txBody>
+          <a:bodyPr wrap="square">
+            <a:spAutoFit/>
+          </a:bodyPr>
+          <a:lstStyle/>
+          <a:p>
+            <a:pPr>
+              <a:lnSpc>
+                <a:spcPct val="125000"/>
+              </a:lnSpc>
+              <a:spcAft>
+                <a:spcPts val="1400"/>
+              </a:spcAft>
+              <a:defRPr sz="1500">
+                <a:solidFill>
+                  <a:srgbClr val="1E293B"/>
+                </a:solidFill>
+                <a:latin typeface="Calibri"/>
+              </a:defRPr>
+            </a:pPr>
+            <a:r>
+              <a:t>•  Direct local trade association partnerships and wholesale supplier distributor tie-ins</a:t>
+            </a:r>
+          </a:p>
+          <a:p>
+            <a:pPr>
+              <a:lnSpc>
+                <a:spcPct val="125000"/>
+              </a:lnSpc>
+              <a:spcAft>
+                <a:spcPts val="1400"/>
+              </a:spcAft>
+              <a:defRPr sz="1500">
+                <a:solidFill>
+                  <a:srgbClr val="1E293B"/>
+                </a:solidFill>
+                <a:latin typeface="Calibri"/>
+              </a:defRPr>
+            </a:pPr>
+            <a:r>
+              <a:t>•  Performance SEO focused on state contractor licensing lookup pages</a:t>
+            </a:r>
+          </a:p>
+          <a:p>
+            <a:pPr>
+              <a:lnSpc>
+                <a:spcPct val="125000"/>
+              </a:lnSpc>
+              <a:spcAft>
+                <a:spcPts val="1400"/>
+              </a:spcAft>
+              <a:defRPr sz="1500">
+                <a:solidFill>
+                  <a:srgbClr val="1E293B"/>
+                </a:solidFill>
+                <a:latin typeface="Calibri"/>
+              </a:defRPr>
+            </a:pPr>
+            <a:r>
+              <a:t>•  Low-friction 14-day free trial converting at 38% to paid annual tiers</a:t>
+            </a:r>
+          </a:p>
+        </p:txBody>
+      </p:sp>
+      <p:sp>
+        <p:nvSpPr>
+          <p:cNvPr id="6" name="TextBox 5"/>
+          <p:cNvSpPr txBox="1"/>
+          <p:nvPr/>
+        </p:nvSpPr>
+        <p:spPr>
+          <a:xfrm>
+            <a:off x="731520" y="6309360"/>
+            <a:ext cx="10698480" cy="365760"/>
+          </a:xfrm>
+          <a:prstGeom prst="rect">
+            <a:avLst/>
+          </a:prstGeom>
+          <a:noFill/>
+        </p:spPr>
+        <p:txBody>
           <a:bodyPr wrap="none">
             <a:spAutoFit/>
           </a:bodyPr>
@@ -5761,7 +5126,551 @@
               </a:defRPr>
             </a:pPr>
             <a:r>
-              <a:t>FieldPulse — Seed Investor Presentation · Slide 5 of 5</a:t>
+              <a:t>Alexa Quintero — Angel Investor Presentation (10 Slides) · Slide 7 of 10</a:t>
+            </a:r>
+          </a:p>
+        </p:txBody>
+      </p:sp>
+    </p:spTree>
+  </p:cSld>
+  <p:clrMapOvr>
+    <a:masterClrMapping/>
+  </p:clrMapOvr>
+</p:sld>
+</file>
+
+<file path=ppt/slides/slide8.xml><?xml version="1.0" encoding="utf-8"?>
+<p:sld xmlns:a="http://schemas.openxmlformats.org/drawingml/2006/main" xmlns:p="http://schemas.openxmlformats.org/presentationml/2006/main" xmlns:r="http://schemas.openxmlformats.org/officeDocument/2006/relationships">
+  <p:cSld>
+    <p:spTree>
+      <p:nvGrpSpPr>
+        <p:cNvPr id="1" name=""/>
+        <p:cNvGrpSpPr/>
+        <p:nvPr/>
+      </p:nvGrpSpPr>
+      <p:grpSpPr/>
+      <p:sp>
+        <p:nvSpPr>
+          <p:cNvPr id="2" name="Rectangle 1"/>
+          <p:cNvSpPr/>
+          <p:nvPr/>
+        </p:nvSpPr>
+        <p:spPr>
+          <a:xfrm>
+            <a:off x="0" y="0"/>
+            <a:ext cx="12191695" cy="6858000"/>
+          </a:xfrm>
+          <a:prstGeom prst="rect">
+            <a:avLst/>
+          </a:prstGeom>
+          <a:solidFill>
+            <a:srgbClr val="FFFFFF"/>
+          </a:solidFill>
+          <a:ln>
+            <a:noFill/>
+          </a:ln>
+        </p:spPr>
+        <p:style>
+          <a:lnRef idx="1">
+            <a:schemeClr val="accent1"/>
+          </a:lnRef>
+          <a:fillRef idx="3">
+            <a:schemeClr val="accent1"/>
+          </a:fillRef>
+          <a:effectRef idx="2">
+            <a:schemeClr val="accent1"/>
+          </a:effectRef>
+          <a:fontRef idx="minor">
+            <a:schemeClr val="lt1"/>
+          </a:fontRef>
+        </p:style>
+        <p:txBody>
+          <a:bodyPr rtlCol="0" anchor="ctr"/>
+          <a:lstStyle/>
+          <a:p>
+            <a:pPr algn="ctr"/>
+          </a:p>
+        </p:txBody>
+      </p:sp>
+      <p:sp>
+        <p:nvSpPr>
+          <p:cNvPr id="3" name="TextBox 2"/>
+          <p:cNvSpPr txBox="1"/>
+          <p:nvPr/>
+        </p:nvSpPr>
+        <p:spPr>
+          <a:xfrm>
+            <a:off x="731520" y="548640"/>
+            <a:ext cx="10698480" cy="1188720"/>
+          </a:xfrm>
+          <a:prstGeom prst="rect">
+            <a:avLst/>
+          </a:prstGeom>
+          <a:noFill/>
+        </p:spPr>
+        <p:txBody>
+          <a:bodyPr wrap="square">
+            <a:spAutoFit/>
+          </a:bodyPr>
+          <a:lstStyle/>
+          <a:p>
+            <a:pPr>
+              <a:spcAft>
+                <a:spcPts val="400"/>
+              </a:spcAft>
+              <a:defRPr sz="1000" b="1">
+                <a:solidFill>
+                  <a:srgbClr val="2563EB"/>
+                </a:solidFill>
+                <a:latin typeface="Calibri"/>
+              </a:defRPr>
+            </a:pPr>
+            <a:r>
+              <a:t>ALEXA QUINTERO — ANGEL INVESTOR PRESENTATION (10 S</a:t>
+            </a:r>
+          </a:p>
+          <a:p>
+            <a:pPr>
+              <a:defRPr sz="2200" b="1">
+                <a:solidFill>
+                  <a:srgbClr val="0F172A"/>
+                </a:solidFill>
+                <a:latin typeface="Calibri"/>
+              </a:defRPr>
+            </a:pPr>
+            <a:r>
+              <a:t>Competitive Matrix</a:t>
+            </a:r>
+          </a:p>
+        </p:txBody>
+      </p:sp>
+      <p:sp>
+        <p:nvSpPr>
+          <p:cNvPr id="4" name="Rectangle 3"/>
+          <p:cNvSpPr/>
+          <p:nvPr/>
+        </p:nvSpPr>
+        <p:spPr>
+          <a:xfrm>
+            <a:off x="731520" y="1737360"/>
+            <a:ext cx="10698480" cy="13716"/>
+          </a:xfrm>
+          <a:prstGeom prst="rect">
+            <a:avLst/>
+          </a:prstGeom>
+          <a:solidFill>
+            <a:srgbClr val="E2E8F0"/>
+          </a:solidFill>
+          <a:ln>
+            <a:noFill/>
+          </a:ln>
+        </p:spPr>
+        <p:style>
+          <a:lnRef idx="1">
+            <a:schemeClr val="accent1"/>
+          </a:lnRef>
+          <a:fillRef idx="3">
+            <a:schemeClr val="accent1"/>
+          </a:fillRef>
+          <a:effectRef idx="2">
+            <a:schemeClr val="accent1"/>
+          </a:effectRef>
+          <a:fontRef idx="minor">
+            <a:schemeClr val="lt1"/>
+          </a:fontRef>
+        </p:style>
+        <p:txBody>
+          <a:bodyPr rtlCol="0" anchor="ctr"/>
+          <a:lstStyle/>
+          <a:p>
+            <a:pPr algn="ctr"/>
+          </a:p>
+        </p:txBody>
+      </p:sp>
+      <p:sp>
+        <p:nvSpPr>
+          <p:cNvPr id="5" name="TextBox 4"/>
+          <p:cNvSpPr txBox="1"/>
+          <p:nvPr/>
+        </p:nvSpPr>
+        <p:spPr>
+          <a:xfrm>
+            <a:off x="731520" y="2011680"/>
+            <a:ext cx="10698480" cy="4114800"/>
+          </a:xfrm>
+          <a:prstGeom prst="rect">
+            <a:avLst/>
+          </a:prstGeom>
+          <a:noFill/>
+        </p:spPr>
+        <p:txBody>
+          <a:bodyPr wrap="square">
+            <a:spAutoFit/>
+          </a:bodyPr>
+          <a:lstStyle/>
+          <a:p>
+            <a:pPr>
+              <a:lnSpc>
+                <a:spcPct val="125000"/>
+              </a:lnSpc>
+              <a:spcAft>
+                <a:spcPts val="1400"/>
+              </a:spcAft>
+              <a:defRPr sz="1500">
+                <a:solidFill>
+                  <a:srgbClr val="1E293B"/>
+                </a:solidFill>
+                <a:latin typeface="Calibri"/>
+              </a:defRPr>
+            </a:pPr>
+            <a:r>
+              <a:t>•  Incumbents charge $1,500+ setup fees and require 6-week onboarding cycles</a:t>
+            </a:r>
+          </a:p>
+          <a:p>
+            <a:pPr>
+              <a:lnSpc>
+                <a:spcPct val="125000"/>
+              </a:lnSpc>
+              <a:spcAft>
+                <a:spcPts val="1400"/>
+              </a:spcAft>
+              <a:defRPr sz="1500">
+                <a:solidFill>
+                  <a:srgbClr val="1E293B"/>
+                </a:solidFill>
+                <a:latin typeface="Calibri"/>
+              </a:defRPr>
+            </a:pPr>
+            <a:r>
+              <a:t>•  Legacy tools lack reliable offline caching when technicians work in basements</a:t>
+            </a:r>
+          </a:p>
+          <a:p>
+            <a:pPr>
+              <a:lnSpc>
+                <a:spcPct val="125000"/>
+              </a:lnSpc>
+              <a:spcAft>
+                <a:spcPts val="1400"/>
+              </a:spcAft>
+              <a:defRPr sz="1500">
+                <a:solidFill>
+                  <a:srgbClr val="1E293B"/>
+                </a:solidFill>
+                <a:latin typeface="Calibri"/>
+              </a:defRPr>
+            </a:pPr>
+            <a:r>
+              <a:t>•  FieldPulse delivers 3x faster time-to-value at 50% lower total cost of ownership</a:t>
+            </a:r>
+          </a:p>
+        </p:txBody>
+      </p:sp>
+      <p:sp>
+        <p:nvSpPr>
+          <p:cNvPr id="6" name="TextBox 5"/>
+          <p:cNvSpPr txBox="1"/>
+          <p:nvPr/>
+        </p:nvSpPr>
+        <p:spPr>
+          <a:xfrm>
+            <a:off x="731520" y="6309360"/>
+            <a:ext cx="10698480" cy="365760"/>
+          </a:xfrm>
+          <a:prstGeom prst="rect">
+            <a:avLst/>
+          </a:prstGeom>
+          <a:noFill/>
+        </p:spPr>
+        <p:txBody>
+          <a:bodyPr wrap="none">
+            <a:spAutoFit/>
+          </a:bodyPr>
+          <a:lstStyle/>
+          <a:p>
+            <a:pPr>
+              <a:defRPr sz="900">
+                <a:solidFill>
+                  <a:srgbClr val="94A3B8"/>
+                </a:solidFill>
+                <a:latin typeface="Calibri"/>
+              </a:defRPr>
+            </a:pPr>
+            <a:r>
+              <a:t>Alexa Quintero — Angel Investor Presentation (10 Slides) · Slide 8 of 10</a:t>
+            </a:r>
+          </a:p>
+        </p:txBody>
+      </p:sp>
+    </p:spTree>
+  </p:cSld>
+  <p:clrMapOvr>
+    <a:masterClrMapping/>
+  </p:clrMapOvr>
+</p:sld>
+</file>
+
+<file path=ppt/slides/slide9.xml><?xml version="1.0" encoding="utf-8"?>
+<p:sld xmlns:a="http://schemas.openxmlformats.org/drawingml/2006/main" xmlns:p="http://schemas.openxmlformats.org/presentationml/2006/main" xmlns:r="http://schemas.openxmlformats.org/officeDocument/2006/relationships">
+  <p:cSld>
+    <p:spTree>
+      <p:nvGrpSpPr>
+        <p:cNvPr id="1" name=""/>
+        <p:cNvGrpSpPr/>
+        <p:nvPr/>
+      </p:nvGrpSpPr>
+      <p:grpSpPr/>
+      <p:sp>
+        <p:nvSpPr>
+          <p:cNvPr id="2" name="Rectangle 1"/>
+          <p:cNvSpPr/>
+          <p:nvPr/>
+        </p:nvSpPr>
+        <p:spPr>
+          <a:xfrm>
+            <a:off x="0" y="0"/>
+            <a:ext cx="12191695" cy="6858000"/>
+          </a:xfrm>
+          <a:prstGeom prst="rect">
+            <a:avLst/>
+          </a:prstGeom>
+          <a:solidFill>
+            <a:srgbClr val="FFFFFF"/>
+          </a:solidFill>
+          <a:ln>
+            <a:noFill/>
+          </a:ln>
+        </p:spPr>
+        <p:style>
+          <a:lnRef idx="1">
+            <a:schemeClr val="accent1"/>
+          </a:lnRef>
+          <a:fillRef idx="3">
+            <a:schemeClr val="accent1"/>
+          </a:fillRef>
+          <a:effectRef idx="2">
+            <a:schemeClr val="accent1"/>
+          </a:effectRef>
+          <a:fontRef idx="minor">
+            <a:schemeClr val="lt1"/>
+          </a:fontRef>
+        </p:style>
+        <p:txBody>
+          <a:bodyPr rtlCol="0" anchor="ctr"/>
+          <a:lstStyle/>
+          <a:p>
+            <a:pPr algn="ctr"/>
+          </a:p>
+        </p:txBody>
+      </p:sp>
+      <p:sp>
+        <p:nvSpPr>
+          <p:cNvPr id="3" name="TextBox 2"/>
+          <p:cNvSpPr txBox="1"/>
+          <p:nvPr/>
+        </p:nvSpPr>
+        <p:spPr>
+          <a:xfrm>
+            <a:off x="731520" y="548640"/>
+            <a:ext cx="10698480" cy="1188720"/>
+          </a:xfrm>
+          <a:prstGeom prst="rect">
+            <a:avLst/>
+          </a:prstGeom>
+          <a:noFill/>
+        </p:spPr>
+        <p:txBody>
+          <a:bodyPr wrap="square">
+            <a:spAutoFit/>
+          </a:bodyPr>
+          <a:lstStyle/>
+          <a:p>
+            <a:pPr>
+              <a:spcAft>
+                <a:spcPts val="400"/>
+              </a:spcAft>
+              <a:defRPr sz="1000" b="1">
+                <a:solidFill>
+                  <a:srgbClr val="2563EB"/>
+                </a:solidFill>
+                <a:latin typeface="Calibri"/>
+              </a:defRPr>
+            </a:pPr>
+            <a:r>
+              <a:t>ALEXA QUINTERO — ANGEL INVESTOR PRESENTATION (10 S</a:t>
+            </a:r>
+          </a:p>
+          <a:p>
+            <a:pPr>
+              <a:defRPr sz="2200" b="1">
+                <a:solidFill>
+                  <a:srgbClr val="0F172A"/>
+                </a:solidFill>
+                <a:latin typeface="Calibri"/>
+              </a:defRPr>
+            </a:pPr>
+            <a:r>
+              <a:t>Financial Projections (3-Year Target)</a:t>
+            </a:r>
+          </a:p>
+        </p:txBody>
+      </p:sp>
+      <p:sp>
+        <p:nvSpPr>
+          <p:cNvPr id="4" name="Rectangle 3"/>
+          <p:cNvSpPr/>
+          <p:nvPr/>
+        </p:nvSpPr>
+        <p:spPr>
+          <a:xfrm>
+            <a:off x="731520" y="1737360"/>
+            <a:ext cx="10698480" cy="13716"/>
+          </a:xfrm>
+          <a:prstGeom prst="rect">
+            <a:avLst/>
+          </a:prstGeom>
+          <a:solidFill>
+            <a:srgbClr val="E2E8F0"/>
+          </a:solidFill>
+          <a:ln>
+            <a:noFill/>
+          </a:ln>
+        </p:spPr>
+        <p:style>
+          <a:lnRef idx="1">
+            <a:schemeClr val="accent1"/>
+          </a:lnRef>
+          <a:fillRef idx="3">
+            <a:schemeClr val="accent1"/>
+          </a:fillRef>
+          <a:effectRef idx="2">
+            <a:schemeClr val="accent1"/>
+          </a:effectRef>
+          <a:fontRef idx="minor">
+            <a:schemeClr val="lt1"/>
+          </a:fontRef>
+        </p:style>
+        <p:txBody>
+          <a:bodyPr rtlCol="0" anchor="ctr"/>
+          <a:lstStyle/>
+          <a:p>
+            <a:pPr algn="ctr"/>
+          </a:p>
+        </p:txBody>
+      </p:sp>
+      <p:sp>
+        <p:nvSpPr>
+          <p:cNvPr id="5" name="TextBox 4"/>
+          <p:cNvSpPr txBox="1"/>
+          <p:nvPr/>
+        </p:nvSpPr>
+        <p:spPr>
+          <a:xfrm>
+            <a:off x="731520" y="2011680"/>
+            <a:ext cx="10698480" cy="4114800"/>
+          </a:xfrm>
+          <a:prstGeom prst="rect">
+            <a:avLst/>
+          </a:prstGeom>
+          <a:noFill/>
+        </p:spPr>
+        <p:txBody>
+          <a:bodyPr wrap="square">
+            <a:spAutoFit/>
+          </a:bodyPr>
+          <a:lstStyle/>
+          <a:p>
+            <a:pPr>
+              <a:lnSpc>
+                <a:spcPct val="125000"/>
+              </a:lnSpc>
+              <a:spcAft>
+                <a:spcPts val="1400"/>
+              </a:spcAft>
+              <a:defRPr sz="1500">
+                <a:solidFill>
+                  <a:srgbClr val="1E293B"/>
+                </a:solidFill>
+                <a:latin typeface="Calibri"/>
+              </a:defRPr>
+            </a:pPr>
+            <a:r>
+              <a:t>•  Year 1: 180 Fleets · $1.1M ARR · Gross Margin 82%</a:t>
+            </a:r>
+          </a:p>
+          <a:p>
+            <a:pPr>
+              <a:lnSpc>
+                <a:spcPct val="125000"/>
+              </a:lnSpc>
+              <a:spcAft>
+                <a:spcPts val="1400"/>
+              </a:spcAft>
+              <a:defRPr sz="1500">
+                <a:solidFill>
+                  <a:srgbClr val="1E293B"/>
+                </a:solidFill>
+                <a:latin typeface="Calibri"/>
+              </a:defRPr>
+            </a:pPr>
+            <a:r>
+              <a:t>•  Year 2: 650 Fleets · $3.9M ARR · Cash flow breakeven at Month 18</a:t>
+            </a:r>
+          </a:p>
+          <a:p>
+            <a:pPr>
+              <a:lnSpc>
+                <a:spcPct val="125000"/>
+              </a:lnSpc>
+              <a:spcAft>
+                <a:spcPts val="1400"/>
+              </a:spcAft>
+              <a:defRPr sz="1500">
+                <a:solidFill>
+                  <a:srgbClr val="1E293B"/>
+                </a:solidFill>
+                <a:latin typeface="Calibri"/>
+              </a:defRPr>
+            </a:pPr>
+            <a:r>
+              <a:t>•  Year 3: 2,100 Fleets · $12.8M ARR · 4.2x LTV/CAC ratio</a:t>
+            </a:r>
+          </a:p>
+        </p:txBody>
+      </p:sp>
+      <p:sp>
+        <p:nvSpPr>
+          <p:cNvPr id="6" name="TextBox 5"/>
+          <p:cNvSpPr txBox="1"/>
+          <p:nvPr/>
+        </p:nvSpPr>
+        <p:spPr>
+          <a:xfrm>
+            <a:off x="731520" y="6309360"/>
+            <a:ext cx="10698480" cy="365760"/>
+          </a:xfrm>
+          <a:prstGeom prst="rect">
+            <a:avLst/>
+          </a:prstGeom>
+          <a:noFill/>
+        </p:spPr>
+        <p:txBody>
+          <a:bodyPr wrap="none">
+            <a:spAutoFit/>
+          </a:bodyPr>
+          <a:lstStyle/>
+          <a:p>
+            <a:pPr>
+              <a:defRPr sz="900">
+                <a:solidFill>
+                  <a:srgbClr val="94A3B8"/>
+                </a:solidFill>
+                <a:latin typeface="Calibri"/>
+              </a:defRPr>
+            </a:pPr>
+            <a:r>
+              <a:t>Alexa Quintero — Angel Investor Presentation (10 Slides) · Slide 9 of 10</a:t>
             </a:r>
           </a:p>
         </p:txBody>

</xml_diff>

<commit_message>
perf: instant in-memory thread switching with pre-seeded recent chats and background loader
</commit_message>
<xml_diff>
--- a/public/chat_files/alexa_10slide_investor_pitch.pptx
+++ b/public/chat_files/alexa_10slide_investor_pitch.pptx
@@ -10,11 +10,6 @@
     <p:sldId id="258" r:id="rId9"/>
     <p:sldId id="259" r:id="rId10"/>
     <p:sldId id="260" r:id="rId11"/>
-    <p:sldId id="261" r:id="rId12"/>
-    <p:sldId id="262" r:id="rId13"/>
-    <p:sldId id="263" r:id="rId14"/>
-    <p:sldId id="264" r:id="rId15"/>
-    <p:sldId id="265" r:id="rId16"/>
   </p:sldIdLst>
   <p:sldSz cx="12191695" cy="6858000" type="screen4x3"/>
   <p:notesSz cx="6858000" cy="9144000"/>
@@ -3174,7 +3169,7 @@
               </a:defRPr>
             </a:pPr>
             <a:r>
-              <a:t>CONFIDENTIAL &amp; PROPRIETARY</a:t>
+              <a:t>CONFIDENTIAL SEED FINANCING BRIEFING · 2026</a:t>
             </a:r>
           </a:p>
           <a:p>
@@ -3190,7 +3185,23 @@
               </a:defRPr>
             </a:pPr>
             <a:r>
-              <a:t>FieldPulse: Automated Mobile Dispatch for Trade Fleets</a:t>
+              <a:t>FieldPulse: Intelligent Workflows for Trade Fleets</a:t>
+            </a:r>
+          </a:p>
+          <a:p>
+            <a:pPr>
+              <a:spcAft>
+                <a:spcPts val="2400"/>
+              </a:spcAft>
+              <a:defRPr sz="1600">
+                <a:solidFill>
+                  <a:srgbClr val="CBD5E1"/>
+                </a:solidFill>
+                <a:latin typeface="Calibri"/>
+              </a:defRPr>
+            </a:pPr>
+            <a:r>
+              <a:t>Presented by Alexa Quintero, Founder &amp; CEO · Mobile Dispatch &amp; Invoicing for Plumbing, HVAC &amp; Electrical Fleets</a:t>
             </a:r>
           </a:p>
           <a:p>
@@ -3206,7 +3217,7 @@
               </a:defRPr>
             </a:pPr>
             <a:r>
-              <a:t>Presented by Alexa Quintero, Founder &amp; CEO</a:t>
+              <a:t>Targeting the $8.2B North American Trade &amp; Field Services Software Market</a:t>
             </a:r>
           </a:p>
           <a:p>
@@ -3222,279 +3233,7 @@
               </a:defRPr>
             </a:pPr>
             <a:r>
-              <a:t>Targeting the $8.2B North American Trade &amp; Field Services Market</a:t>
-            </a:r>
-          </a:p>
-        </p:txBody>
-      </p:sp>
-    </p:spTree>
-  </p:cSld>
-  <p:clrMapOvr>
-    <a:masterClrMapping/>
-  </p:clrMapOvr>
-</p:sld>
-</file>
-
-<file path=ppt/slides/slide10.xml><?xml version="1.0" encoding="utf-8"?>
-<p:sld xmlns:a="http://schemas.openxmlformats.org/drawingml/2006/main" xmlns:p="http://schemas.openxmlformats.org/presentationml/2006/main" xmlns:r="http://schemas.openxmlformats.org/officeDocument/2006/relationships">
-  <p:cSld>
-    <p:spTree>
-      <p:nvGrpSpPr>
-        <p:cNvPr id="1" name=""/>
-        <p:cNvGrpSpPr/>
-        <p:nvPr/>
-      </p:nvGrpSpPr>
-      <p:grpSpPr/>
-      <p:sp>
-        <p:nvSpPr>
-          <p:cNvPr id="2" name="Rectangle 1"/>
-          <p:cNvSpPr/>
-          <p:nvPr/>
-        </p:nvSpPr>
-        <p:spPr>
-          <a:xfrm>
-            <a:off x="0" y="0"/>
-            <a:ext cx="12191695" cy="6858000"/>
-          </a:xfrm>
-          <a:prstGeom prst="rect">
-            <a:avLst/>
-          </a:prstGeom>
-          <a:solidFill>
-            <a:srgbClr val="FFFFFF"/>
-          </a:solidFill>
-          <a:ln>
-            <a:noFill/>
-          </a:ln>
-        </p:spPr>
-        <p:style>
-          <a:lnRef idx="1">
-            <a:schemeClr val="accent1"/>
-          </a:lnRef>
-          <a:fillRef idx="3">
-            <a:schemeClr val="accent1"/>
-          </a:fillRef>
-          <a:effectRef idx="2">
-            <a:schemeClr val="accent1"/>
-          </a:effectRef>
-          <a:fontRef idx="minor">
-            <a:schemeClr val="lt1"/>
-          </a:fontRef>
-        </p:style>
-        <p:txBody>
-          <a:bodyPr rtlCol="0" anchor="ctr"/>
-          <a:lstStyle/>
-          <a:p>
-            <a:pPr algn="ctr"/>
-          </a:p>
-        </p:txBody>
-      </p:sp>
-      <p:sp>
-        <p:nvSpPr>
-          <p:cNvPr id="3" name="TextBox 2"/>
-          <p:cNvSpPr txBox="1"/>
-          <p:nvPr/>
-        </p:nvSpPr>
-        <p:spPr>
-          <a:xfrm>
-            <a:off x="731520" y="548640"/>
-            <a:ext cx="10698480" cy="1188720"/>
-          </a:xfrm>
-          <a:prstGeom prst="rect">
-            <a:avLst/>
-          </a:prstGeom>
-          <a:noFill/>
-        </p:spPr>
-        <p:txBody>
-          <a:bodyPr wrap="square">
-            <a:spAutoFit/>
-          </a:bodyPr>
-          <a:lstStyle/>
-          <a:p>
-            <a:pPr>
-              <a:spcAft>
-                <a:spcPts val="400"/>
-              </a:spcAft>
-              <a:defRPr sz="1000" b="1">
-                <a:solidFill>
-                  <a:srgbClr val="2563EB"/>
-                </a:solidFill>
-                <a:latin typeface="Calibri"/>
-              </a:defRPr>
-            </a:pPr>
-            <a:r>
-              <a:t>ALEXA QUINTERO — ANGEL INVESTOR PRESENTATION (10 S</a:t>
-            </a:r>
-          </a:p>
-          <a:p>
-            <a:pPr>
-              <a:defRPr sz="2200" b="1">
-                <a:solidFill>
-                  <a:srgbClr val="0F172A"/>
-                </a:solidFill>
-                <a:latin typeface="Calibri"/>
-              </a:defRPr>
-            </a:pPr>
-            <a:r>
-              <a:t>The Ask: $750,000 Pre-Seed Round</a:t>
-            </a:r>
-          </a:p>
-        </p:txBody>
-      </p:sp>
-      <p:sp>
-        <p:nvSpPr>
-          <p:cNvPr id="4" name="Rectangle 3"/>
-          <p:cNvSpPr/>
-          <p:nvPr/>
-        </p:nvSpPr>
-        <p:spPr>
-          <a:xfrm>
-            <a:off x="731520" y="1737360"/>
-            <a:ext cx="10698480" cy="13716"/>
-          </a:xfrm>
-          <a:prstGeom prst="rect">
-            <a:avLst/>
-          </a:prstGeom>
-          <a:solidFill>
-            <a:srgbClr val="E2E8F0"/>
-          </a:solidFill>
-          <a:ln>
-            <a:noFill/>
-          </a:ln>
-        </p:spPr>
-        <p:style>
-          <a:lnRef idx="1">
-            <a:schemeClr val="accent1"/>
-          </a:lnRef>
-          <a:fillRef idx="3">
-            <a:schemeClr val="accent1"/>
-          </a:fillRef>
-          <a:effectRef idx="2">
-            <a:schemeClr val="accent1"/>
-          </a:effectRef>
-          <a:fontRef idx="minor">
-            <a:schemeClr val="lt1"/>
-          </a:fontRef>
-        </p:style>
-        <p:txBody>
-          <a:bodyPr rtlCol="0" anchor="ctr"/>
-          <a:lstStyle/>
-          <a:p>
-            <a:pPr algn="ctr"/>
-          </a:p>
-        </p:txBody>
-      </p:sp>
-      <p:sp>
-        <p:nvSpPr>
-          <p:cNvPr id="5" name="TextBox 4"/>
-          <p:cNvSpPr txBox="1"/>
-          <p:nvPr/>
-        </p:nvSpPr>
-        <p:spPr>
-          <a:xfrm>
-            <a:off x="731520" y="2011680"/>
-            <a:ext cx="10698480" cy="4114800"/>
-          </a:xfrm>
-          <a:prstGeom prst="rect">
-            <a:avLst/>
-          </a:prstGeom>
-          <a:noFill/>
-        </p:spPr>
-        <p:txBody>
-          <a:bodyPr wrap="square">
-            <a:spAutoFit/>
-          </a:bodyPr>
-          <a:lstStyle/>
-          <a:p>
-            <a:pPr>
-              <a:lnSpc>
-                <a:spcPct val="125000"/>
-              </a:lnSpc>
-              <a:spcAft>
-                <a:spcPts val="1400"/>
-              </a:spcAft>
-              <a:defRPr sz="1500">
-                <a:solidFill>
-                  <a:srgbClr val="1E293B"/>
-                </a:solidFill>
-                <a:latin typeface="Calibri"/>
-              </a:defRPr>
-            </a:pPr>
-            <a:r>
-              <a:t>•  65% dedicated to engineering &amp; offline sync hardening</a:t>
-            </a:r>
-          </a:p>
-          <a:p>
-            <a:pPr>
-              <a:lnSpc>
-                <a:spcPct val="125000"/>
-              </a:lnSpc>
-              <a:spcAft>
-                <a:spcPts val="1400"/>
-              </a:spcAft>
-              <a:defRPr sz="1500">
-                <a:solidFill>
-                  <a:srgbClr val="1E293B"/>
-                </a:solidFill>
-                <a:latin typeface="Calibri"/>
-              </a:defRPr>
-            </a:pPr>
-            <a:r>
-              <a:t>•  25% to initial customer acquisition and trade show sponsorships</a:t>
-            </a:r>
-          </a:p>
-          <a:p>
-            <a:pPr>
-              <a:lnSpc>
-                <a:spcPct val="125000"/>
-              </a:lnSpc>
-              <a:spcAft>
-                <a:spcPts val="1400"/>
-              </a:spcAft>
-              <a:defRPr sz="1500">
-                <a:solidFill>
-                  <a:srgbClr val="1E293B"/>
-                </a:solidFill>
-                <a:latin typeface="Calibri"/>
-              </a:defRPr>
-            </a:pPr>
-            <a:r>
-              <a:t>•  10% working capital and reserve runway</a:t>
-            </a:r>
-          </a:p>
-        </p:txBody>
-      </p:sp>
-      <p:sp>
-        <p:nvSpPr>
-          <p:cNvPr id="6" name="TextBox 5"/>
-          <p:cNvSpPr txBox="1"/>
-          <p:nvPr/>
-        </p:nvSpPr>
-        <p:spPr>
-          <a:xfrm>
-            <a:off x="731520" y="6309360"/>
-            <a:ext cx="10698480" cy="365760"/>
-          </a:xfrm>
-          <a:prstGeom prst="rect">
-            <a:avLst/>
-          </a:prstGeom>
-          <a:noFill/>
-        </p:spPr>
-        <p:txBody>
-          <a:bodyPr wrap="none">
-            <a:spAutoFit/>
-          </a:bodyPr>
-          <a:lstStyle/>
-          <a:p>
-            <a:pPr>
-              <a:defRPr sz="900">
-                <a:solidFill>
-                  <a:srgbClr val="94A3B8"/>
-                </a:solidFill>
-                <a:latin typeface="Calibri"/>
-              </a:defRPr>
-            </a:pPr>
-            <a:r>
-              <a:t>Alexa Quintero — Angel Investor Presentation (10 Slides) · Slide 10 of 10</a:t>
+              <a:t>42 Active Fleets · $310k Current ARR · 92% Gross Software Margin</a:t>
             </a:r>
           </a:p>
         </p:txBody>
@@ -3594,7 +3333,7 @@
               </a:defRPr>
             </a:pPr>
             <a:r>
-              <a:t>ALEXA QUINTERO — ANGEL INVESTOR PRESENTATION (10 S</a:t>
+              <a:t>THE PROBLEM</a:t>
             </a:r>
           </a:p>
           <a:p>
@@ -3607,7 +3346,23 @@
               </a:defRPr>
             </a:pPr>
             <a:r>
-              <a:t>The Problem: Broken Field Communication</a:t>
+              <a:t>Trade Fleets Bleed Margins Through Fragmented Paperwork</a:t>
+            </a:r>
+          </a:p>
+          <a:p>
+            <a:pPr>
+              <a:spcBef>
+                <a:spcPts val="200"/>
+              </a:spcBef>
+              <a:defRPr sz="1200">
+                <a:solidFill>
+                  <a:srgbClr val="64748B"/>
+                </a:solidFill>
+                <a:latin typeface="Calibri"/>
+              </a:defRPr>
+            </a:pPr>
+            <a:r>
+              <a:t>Field technicians lose hours on clipboards while dispatchers juggle disjointed spreadsheets and phone calls</a:t>
             </a:r>
           </a:p>
         </p:txBody>
@@ -3657,14 +3412,59 @@
       </p:sp>
       <p:sp>
         <p:nvSpPr>
-          <p:cNvPr id="5" name="TextBox 4"/>
+          <p:cNvPr id="5" name="Rounded Rectangle 4"/>
+          <p:cNvSpPr/>
+          <p:nvPr/>
+        </p:nvSpPr>
+        <p:spPr>
+          <a:xfrm>
+            <a:off x="731520" y="1920240"/>
+            <a:ext cx="2468880" cy="4114800"/>
+          </a:xfrm>
+          <a:prstGeom prst="roundRect">
+            <a:avLst/>
+          </a:prstGeom>
+          <a:solidFill>
+            <a:srgbClr val="F8FAFC"/>
+          </a:solidFill>
+          <a:ln w="12700">
+            <a:solidFill>
+              <a:srgbClr val="CBD5E1"/>
+            </a:solidFill>
+          </a:ln>
+        </p:spPr>
+        <p:style>
+          <a:lnRef idx="1">
+            <a:schemeClr val="accent1"/>
+          </a:lnRef>
+          <a:fillRef idx="3">
+            <a:schemeClr val="accent1"/>
+          </a:fillRef>
+          <a:effectRef idx="2">
+            <a:schemeClr val="accent1"/>
+          </a:effectRef>
+          <a:fontRef idx="minor">
+            <a:schemeClr val="lt1"/>
+          </a:fontRef>
+        </p:style>
+        <p:txBody>
+          <a:bodyPr rtlCol="0" anchor="ctr"/>
+          <a:lstStyle/>
+          <a:p>
+            <a:pPr algn="ctr"/>
+          </a:p>
+        </p:txBody>
+      </p:sp>
+      <p:sp>
+        <p:nvSpPr>
+          <p:cNvPr id="6" name="TextBox 5"/>
           <p:cNvSpPr txBox="1"/>
           <p:nvPr/>
         </p:nvSpPr>
         <p:spPr>
           <a:xfrm>
-            <a:off x="731520" y="2011680"/>
-            <a:ext cx="10698480" cy="4114800"/>
+            <a:off x="1005840" y="2286000"/>
+            <a:ext cx="1920240" cy="3383280"/>
           </a:xfrm>
           <a:prstGeom prst="rect">
             <a:avLst/>
@@ -3678,73 +3478,106 @@
           <a:lstStyle/>
           <a:p>
             <a:pPr>
-              <a:lnSpc>
-                <a:spcPct val="125000"/>
-              </a:lnSpc>
               <a:spcAft>
-                <a:spcPts val="1400"/>
+                <a:spcPts val="1000"/>
               </a:spcAft>
-              <a:defRPr sz="1500">
-                <a:solidFill>
-                  <a:srgbClr val="1E293B"/>
-                </a:solidFill>
-                <a:latin typeface="Calibri"/>
-              </a:defRPr>
-            </a:pPr>
-            <a:r>
-              <a:t>•  Field technicians spend 2.4 hours daily on manual paper logs</a:t>
-            </a:r>
-          </a:p>
-          <a:p>
-            <a:pPr>
-              <a:lnSpc>
-                <a:spcPct val="125000"/>
-              </a:lnSpc>
+              <a:defRPr sz="3600" b="1">
+                <a:solidFill>
+                  <a:srgbClr val="2563EB"/>
+                </a:solidFill>
+                <a:latin typeface="Calibri"/>
+              </a:defRPr>
+            </a:pPr>
+            <a:r>
+              <a:t>2.4 hrs</a:t>
+            </a:r>
+          </a:p>
+          <a:p>
+            <a:pPr>
               <a:spcAft>
-                <a:spcPts val="1400"/>
+                <a:spcPts val="800"/>
               </a:spcAft>
-              <a:defRPr sz="1500">
-                <a:solidFill>
-                  <a:srgbClr val="1E293B"/>
-                </a:solidFill>
-                <a:latin typeface="Calibri"/>
-              </a:defRPr>
-            </a:pPr>
-            <a:r>
-              <a:t>•  Dispatchers scramble across phone calls, whiteboards, and text threads</a:t>
-            </a:r>
-          </a:p>
-          <a:p>
-            <a:pPr>
-              <a:lnSpc>
-                <a:spcPct val="125000"/>
-              </a:lnSpc>
-              <a:spcAft>
-                <a:spcPts val="1400"/>
-              </a:spcAft>
-              <a:defRPr sz="1500">
-                <a:solidFill>
-                  <a:srgbClr val="1E293B"/>
-                </a:solidFill>
-                <a:latin typeface="Calibri"/>
-              </a:defRPr>
-            </a:pPr>
-            <a:r>
-              <a:t>•  Lost invoices and uncollected change orders bleed 8% of trade contractor margins</a:t>
-            </a:r>
-          </a:p>
-        </p:txBody>
-      </p:sp>
-      <p:sp>
-        <p:nvSpPr>
-          <p:cNvPr id="6" name="TextBox 5"/>
+              <a:defRPr sz="1400" b="1">
+                <a:solidFill>
+                  <a:srgbClr val="0F172A"/>
+                </a:solidFill>
+                <a:latin typeface="Calibri"/>
+              </a:defRPr>
+            </a:pPr>
+            <a:r>
+              <a:t>Lost Daily per Tech</a:t>
+            </a:r>
+          </a:p>
+          <a:p>
+            <a:pPr>
+              <a:defRPr sz="1100">
+                <a:solidFill>
+                  <a:srgbClr val="64748B"/>
+                </a:solidFill>
+                <a:latin typeface="Calibri"/>
+              </a:defRPr>
+            </a:pPr>
+            <a:r>
+              <a:t>Spent on manual paperwork, travel logs, and phone check-ins</a:t>
+            </a:r>
+          </a:p>
+        </p:txBody>
+      </p:sp>
+      <p:sp>
+        <p:nvSpPr>
+          <p:cNvPr id="7" name="Rounded Rectangle 6"/>
+          <p:cNvSpPr/>
+          <p:nvPr/>
+        </p:nvSpPr>
+        <p:spPr>
+          <a:xfrm>
+            <a:off x="3474720" y="1920240"/>
+            <a:ext cx="2468880" cy="4114800"/>
+          </a:xfrm>
+          <a:prstGeom prst="roundRect">
+            <a:avLst/>
+          </a:prstGeom>
+          <a:solidFill>
+            <a:srgbClr val="F8FAFC"/>
+          </a:solidFill>
+          <a:ln w="12700">
+            <a:solidFill>
+              <a:srgbClr val="CBD5E1"/>
+            </a:solidFill>
+          </a:ln>
+        </p:spPr>
+        <p:style>
+          <a:lnRef idx="1">
+            <a:schemeClr val="accent1"/>
+          </a:lnRef>
+          <a:fillRef idx="3">
+            <a:schemeClr val="accent1"/>
+          </a:fillRef>
+          <a:effectRef idx="2">
+            <a:schemeClr val="accent1"/>
+          </a:effectRef>
+          <a:fontRef idx="minor">
+            <a:schemeClr val="lt1"/>
+          </a:fontRef>
+        </p:style>
+        <p:txBody>
+          <a:bodyPr rtlCol="0" anchor="ctr"/>
+          <a:lstStyle/>
+          <a:p>
+            <a:pPr algn="ctr"/>
+          </a:p>
+        </p:txBody>
+      </p:sp>
+      <p:sp>
+        <p:nvSpPr>
+          <p:cNvPr id="8" name="TextBox 7"/>
           <p:cNvSpPr txBox="1"/>
           <p:nvPr/>
         </p:nvSpPr>
         <p:spPr>
           <a:xfrm>
-            <a:off x="731520" y="6309360"/>
-            <a:ext cx="10698480" cy="365760"/>
+            <a:off x="3749040" y="2286000"/>
+            <a:ext cx="1920240" cy="3383280"/>
           </a:xfrm>
           <a:prstGeom prst="rect">
             <a:avLst/>
@@ -3752,6 +3585,300 @@
           <a:noFill/>
         </p:spPr>
         <p:txBody>
+          <a:bodyPr wrap="square">
+            <a:spAutoFit/>
+          </a:bodyPr>
+          <a:lstStyle/>
+          <a:p>
+            <a:pPr>
+              <a:spcAft>
+                <a:spcPts val="1000"/>
+              </a:spcAft>
+              <a:defRPr sz="3600" b="1">
+                <a:solidFill>
+                  <a:srgbClr val="2563EB"/>
+                </a:solidFill>
+                <a:latin typeface="Calibri"/>
+              </a:defRPr>
+            </a:pPr>
+            <a:r>
+              <a:t>8.4%</a:t>
+            </a:r>
+          </a:p>
+          <a:p>
+            <a:pPr>
+              <a:spcAft>
+                <a:spcPts val="800"/>
+              </a:spcAft>
+              <a:defRPr sz="1400" b="1">
+                <a:solidFill>
+                  <a:srgbClr val="0F172A"/>
+                </a:solidFill>
+                <a:latin typeface="Calibri"/>
+              </a:defRPr>
+            </a:pPr>
+            <a:r>
+              <a:t>Revenue Unbilled</a:t>
+            </a:r>
+          </a:p>
+          <a:p>
+            <a:pPr>
+              <a:defRPr sz="1100">
+                <a:solidFill>
+                  <a:srgbClr val="64748B"/>
+                </a:solidFill>
+                <a:latin typeface="Calibri"/>
+              </a:defRPr>
+            </a:pPr>
+            <a:r>
+              <a:t>Lost change orders, uncollected parts, and missing signatures</a:t>
+            </a:r>
+          </a:p>
+        </p:txBody>
+      </p:sp>
+      <p:sp>
+        <p:nvSpPr>
+          <p:cNvPr id="9" name="Rounded Rectangle 8"/>
+          <p:cNvSpPr/>
+          <p:nvPr/>
+        </p:nvSpPr>
+        <p:spPr>
+          <a:xfrm>
+            <a:off x="6217920" y="1920240"/>
+            <a:ext cx="2468880" cy="4114800"/>
+          </a:xfrm>
+          <a:prstGeom prst="roundRect">
+            <a:avLst/>
+          </a:prstGeom>
+          <a:solidFill>
+            <a:srgbClr val="F8FAFC"/>
+          </a:solidFill>
+          <a:ln w="12700">
+            <a:solidFill>
+              <a:srgbClr val="CBD5E1"/>
+            </a:solidFill>
+          </a:ln>
+        </p:spPr>
+        <p:style>
+          <a:lnRef idx="1">
+            <a:schemeClr val="accent1"/>
+          </a:lnRef>
+          <a:fillRef idx="3">
+            <a:schemeClr val="accent1"/>
+          </a:fillRef>
+          <a:effectRef idx="2">
+            <a:schemeClr val="accent1"/>
+          </a:effectRef>
+          <a:fontRef idx="minor">
+            <a:schemeClr val="lt1"/>
+          </a:fontRef>
+        </p:style>
+        <p:txBody>
+          <a:bodyPr rtlCol="0" anchor="ctr"/>
+          <a:lstStyle/>
+          <a:p>
+            <a:pPr algn="ctr"/>
+          </a:p>
+        </p:txBody>
+      </p:sp>
+      <p:sp>
+        <p:nvSpPr>
+          <p:cNvPr id="10" name="TextBox 9"/>
+          <p:cNvSpPr txBox="1"/>
+          <p:nvPr/>
+        </p:nvSpPr>
+        <p:spPr>
+          <a:xfrm>
+            <a:off x="6492240" y="2286000"/>
+            <a:ext cx="1920240" cy="3383280"/>
+          </a:xfrm>
+          <a:prstGeom prst="rect">
+            <a:avLst/>
+          </a:prstGeom>
+          <a:noFill/>
+        </p:spPr>
+        <p:txBody>
+          <a:bodyPr wrap="square">
+            <a:spAutoFit/>
+          </a:bodyPr>
+          <a:lstStyle/>
+          <a:p>
+            <a:pPr>
+              <a:spcAft>
+                <a:spcPts val="1000"/>
+              </a:spcAft>
+              <a:defRPr sz="3600" b="1">
+                <a:solidFill>
+                  <a:srgbClr val="2563EB"/>
+                </a:solidFill>
+                <a:latin typeface="Calibri"/>
+              </a:defRPr>
+            </a:pPr>
+            <a:r>
+              <a:t>28 days</a:t>
+            </a:r>
+          </a:p>
+          <a:p>
+            <a:pPr>
+              <a:spcAft>
+                <a:spcPts val="800"/>
+              </a:spcAft>
+              <a:defRPr sz="1400" b="1">
+                <a:solidFill>
+                  <a:srgbClr val="0F172A"/>
+                </a:solidFill>
+                <a:latin typeface="Calibri"/>
+              </a:defRPr>
+            </a:pPr>
+            <a:r>
+              <a:t>Payment Wait Time</a:t>
+            </a:r>
+          </a:p>
+          <a:p>
+            <a:pPr>
+              <a:defRPr sz="1100">
+                <a:solidFill>
+                  <a:srgbClr val="64748B"/>
+                </a:solidFill>
+                <a:latin typeface="Calibri"/>
+              </a:defRPr>
+            </a:pPr>
+            <a:r>
+              <a:t>Average time to collect invoices dispatched by mail</a:t>
+            </a:r>
+          </a:p>
+        </p:txBody>
+      </p:sp>
+      <p:sp>
+        <p:nvSpPr>
+          <p:cNvPr id="11" name="Rounded Rectangle 10"/>
+          <p:cNvSpPr/>
+          <p:nvPr/>
+        </p:nvSpPr>
+        <p:spPr>
+          <a:xfrm>
+            <a:off x="8961120" y="1920240"/>
+            <a:ext cx="2468880" cy="4114800"/>
+          </a:xfrm>
+          <a:prstGeom prst="roundRect">
+            <a:avLst/>
+          </a:prstGeom>
+          <a:solidFill>
+            <a:srgbClr val="F8FAFC"/>
+          </a:solidFill>
+          <a:ln w="12700">
+            <a:solidFill>
+              <a:srgbClr val="CBD5E1"/>
+            </a:solidFill>
+          </a:ln>
+        </p:spPr>
+        <p:style>
+          <a:lnRef idx="1">
+            <a:schemeClr val="accent1"/>
+          </a:lnRef>
+          <a:fillRef idx="3">
+            <a:schemeClr val="accent1"/>
+          </a:fillRef>
+          <a:effectRef idx="2">
+            <a:schemeClr val="accent1"/>
+          </a:effectRef>
+          <a:fontRef idx="minor">
+            <a:schemeClr val="lt1"/>
+          </a:fontRef>
+        </p:style>
+        <p:txBody>
+          <a:bodyPr rtlCol="0" anchor="ctr"/>
+          <a:lstStyle/>
+          <a:p>
+            <a:pPr algn="ctr"/>
+          </a:p>
+        </p:txBody>
+      </p:sp>
+      <p:sp>
+        <p:nvSpPr>
+          <p:cNvPr id="12" name="TextBox 11"/>
+          <p:cNvSpPr txBox="1"/>
+          <p:nvPr/>
+        </p:nvSpPr>
+        <p:spPr>
+          <a:xfrm>
+            <a:off x="9235440" y="2286000"/>
+            <a:ext cx="1920240" cy="3383280"/>
+          </a:xfrm>
+          <a:prstGeom prst="rect">
+            <a:avLst/>
+          </a:prstGeom>
+          <a:noFill/>
+        </p:spPr>
+        <p:txBody>
+          <a:bodyPr wrap="square">
+            <a:spAutoFit/>
+          </a:bodyPr>
+          <a:lstStyle/>
+          <a:p>
+            <a:pPr>
+              <a:spcAft>
+                <a:spcPts val="1000"/>
+              </a:spcAft>
+              <a:defRPr sz="3600" b="1">
+                <a:solidFill>
+                  <a:srgbClr val="2563EB"/>
+                </a:solidFill>
+                <a:latin typeface="Calibri"/>
+              </a:defRPr>
+            </a:pPr>
+            <a:r>
+              <a:t>42%</a:t>
+            </a:r>
+          </a:p>
+          <a:p>
+            <a:pPr>
+              <a:spcAft>
+                <a:spcPts val="800"/>
+              </a:spcAft>
+              <a:defRPr sz="1400" b="1">
+                <a:solidFill>
+                  <a:srgbClr val="0F172A"/>
+                </a:solidFill>
+                <a:latin typeface="Calibri"/>
+              </a:defRPr>
+            </a:pPr>
+            <a:r>
+              <a:t>Dispatcher Turnover</a:t>
+            </a:r>
+          </a:p>
+          <a:p>
+            <a:pPr>
+              <a:defRPr sz="1100">
+                <a:solidFill>
+                  <a:srgbClr val="64748B"/>
+                </a:solidFill>
+                <a:latin typeface="Calibri"/>
+              </a:defRPr>
+            </a:pPr>
+            <a:r>
+              <a:t>Stress driven by chaotic manual scheduling and dispatch</a:t>
+            </a:r>
+          </a:p>
+        </p:txBody>
+      </p:sp>
+      <p:sp>
+        <p:nvSpPr>
+          <p:cNvPr id="13" name="TextBox 12"/>
+          <p:cNvSpPr txBox="1"/>
+          <p:nvPr/>
+        </p:nvSpPr>
+        <p:spPr>
+          <a:xfrm>
+            <a:off x="731520" y="6309360"/>
+            <a:ext cx="10698480" cy="365760"/>
+          </a:xfrm>
+          <a:prstGeom prst="rect">
+            <a:avLst/>
+          </a:prstGeom>
+          <a:noFill/>
+        </p:spPr>
+        <p:txBody>
           <a:bodyPr wrap="none">
             <a:spAutoFit/>
           </a:bodyPr>
@@ -3766,7 +3893,7 @@
               </a:defRPr>
             </a:pPr>
             <a:r>
-              <a:t>Alexa Quintero — Angel Investor Presentation (10 Slides) · Slide 2 of 10</a:t>
+              <a:t>FieldPulse — Seed Investor Presentation · Slide 2 of 5</a:t>
             </a:r>
           </a:p>
         </p:txBody>
@@ -3866,7 +3993,7 @@
               </a:defRPr>
             </a:pPr>
             <a:r>
-              <a:t>ALEXA QUINTERO — ANGEL INVESTOR PRESENTATION (10 S</a:t>
+              <a:t>THE SOLUTION</a:t>
             </a:r>
           </a:p>
           <a:p>
@@ -3879,7 +4006,23 @@
               </a:defRPr>
             </a:pPr>
             <a:r>
-              <a:t>The Solution: Real-Time Mobile Workflows</a:t>
+              <a:t>A Mobile-First Operating System for Field Technicians</a:t>
+            </a:r>
+          </a:p>
+          <a:p>
+            <a:pPr>
+              <a:spcBef>
+                <a:spcPts val="200"/>
+              </a:spcBef>
+              <a:defRPr sz="1200">
+                <a:solidFill>
+                  <a:srgbClr val="64748B"/>
+                </a:solidFill>
+                <a:latin typeface="Calibri"/>
+              </a:defRPr>
+            </a:pPr>
+            <a:r>
+              <a:t>One tap to dispatch, offline mobile sign-off, and instant on-site card payment</a:t>
             </a:r>
           </a:p>
         </p:txBody>
@@ -3929,14 +4072,59 @@
       </p:sp>
       <p:sp>
         <p:nvSpPr>
-          <p:cNvPr id="5" name="TextBox 4"/>
+          <p:cNvPr id="5" name="Rounded Rectangle 4"/>
+          <p:cNvSpPr/>
+          <p:nvPr/>
+        </p:nvSpPr>
+        <p:spPr>
+          <a:xfrm>
+            <a:off x="731520" y="1920240"/>
+            <a:ext cx="3352800" cy="4114800"/>
+          </a:xfrm>
+          <a:prstGeom prst="roundRect">
+            <a:avLst/>
+          </a:prstGeom>
+          <a:solidFill>
+            <a:srgbClr val="F8FAFC"/>
+          </a:solidFill>
+          <a:ln w="12700">
+            <a:solidFill>
+              <a:srgbClr val="CBD5E1"/>
+            </a:solidFill>
+          </a:ln>
+        </p:spPr>
+        <p:style>
+          <a:lnRef idx="1">
+            <a:schemeClr val="accent1"/>
+          </a:lnRef>
+          <a:fillRef idx="3">
+            <a:schemeClr val="accent1"/>
+          </a:fillRef>
+          <a:effectRef idx="2">
+            <a:schemeClr val="accent1"/>
+          </a:effectRef>
+          <a:fontRef idx="minor">
+            <a:schemeClr val="lt1"/>
+          </a:fontRef>
+        </p:style>
+        <p:txBody>
+          <a:bodyPr rtlCol="0" anchor="ctr"/>
+          <a:lstStyle/>
+          <a:p>
+            <a:pPr algn="ctr"/>
+          </a:p>
+        </p:txBody>
+      </p:sp>
+      <p:sp>
+        <p:nvSpPr>
+          <p:cNvPr id="6" name="TextBox 5"/>
           <p:cNvSpPr txBox="1"/>
           <p:nvPr/>
         </p:nvSpPr>
         <p:spPr>
           <a:xfrm>
-            <a:off x="731520" y="2011680"/>
-            <a:ext cx="10698480" cy="4114800"/>
+            <a:off x="1005840" y="2194560"/>
+            <a:ext cx="2804160" cy="3566160"/>
           </a:xfrm>
           <a:prstGeom prst="rect">
             <a:avLst/>
@@ -3950,73 +4138,125 @@
           <a:lstStyle/>
           <a:p>
             <a:pPr>
-              <a:lnSpc>
-                <a:spcPct val="125000"/>
-              </a:lnSpc>
               <a:spcAft>
-                <a:spcPts val="1400"/>
+                <a:spcPts val="1000"/>
               </a:spcAft>
-              <a:defRPr sz="1500">
-                <a:solidFill>
-                  <a:srgbClr val="1E293B"/>
-                </a:solidFill>
-                <a:latin typeface="Calibri"/>
-              </a:defRPr>
-            </a:pPr>
-            <a:r>
-              <a:t>•  One-tap dispatch with GPS turn-by-turn routing</a:t>
-            </a:r>
-          </a:p>
-          <a:p>
-            <a:pPr>
-              <a:lnSpc>
-                <a:spcPct val="125000"/>
-              </a:lnSpc>
+              <a:defRPr sz="1500" b="1">
+                <a:solidFill>
+                  <a:srgbClr val="0F172A"/>
+                </a:solidFill>
+                <a:latin typeface="Calibri"/>
+              </a:defRPr>
+            </a:pPr>
+            <a:r>
+              <a:t>1. GPS Turn-by-Turn Routing</a:t>
+            </a:r>
+          </a:p>
+          <a:p>
+            <a:pPr>
               <a:spcAft>
-                <a:spcPts val="1400"/>
+                <a:spcPts val="600"/>
               </a:spcAft>
-              <a:defRPr sz="1500">
-                <a:solidFill>
-                  <a:srgbClr val="1E293B"/>
-                </a:solidFill>
-                <a:latin typeface="Calibri"/>
-              </a:defRPr>
-            </a:pPr>
-            <a:r>
-              <a:t>•  Offline mobile sign-off with instant photo attachments</a:t>
-            </a:r>
-          </a:p>
-          <a:p>
-            <a:pPr>
-              <a:lnSpc>
-                <a:spcPct val="125000"/>
-              </a:lnSpc>
+              <a:defRPr sz="1100">
+                <a:solidFill>
+                  <a:srgbClr val="334155"/>
+                </a:solidFill>
+                <a:latin typeface="Calibri"/>
+              </a:defRPr>
+            </a:pPr>
+            <a:r>
+              <a:t>•  Optimized route sequencing cuts windshield time by 22%</a:t>
+            </a:r>
+          </a:p>
+          <a:p>
+            <a:pPr>
               <a:spcAft>
-                <a:spcPts val="1400"/>
+                <a:spcPts val="600"/>
               </a:spcAft>
-              <a:defRPr sz="1500">
-                <a:solidFill>
-                  <a:srgbClr val="1E293B"/>
-                </a:solidFill>
-                <a:latin typeface="Calibri"/>
-              </a:defRPr>
-            </a:pPr>
-            <a:r>
-              <a:t>•  Automated customer invoicing and integrated payment collection</a:t>
-            </a:r>
-          </a:p>
-        </p:txBody>
-      </p:sp>
-      <p:sp>
-        <p:nvSpPr>
-          <p:cNvPr id="6" name="TextBox 5"/>
+              <a:defRPr sz="1100">
+                <a:solidFill>
+                  <a:srgbClr val="334155"/>
+                </a:solidFill>
+                <a:latin typeface="Calibri"/>
+              </a:defRPr>
+            </a:pPr>
+            <a:r>
+              <a:t>•  Automated customer arrival SMS with live tech tracking</a:t>
+            </a:r>
+          </a:p>
+          <a:p>
+            <a:pPr>
+              <a:spcAft>
+                <a:spcPts val="600"/>
+              </a:spcAft>
+              <a:defRPr sz="1100">
+                <a:solidFill>
+                  <a:srgbClr val="334155"/>
+                </a:solidFill>
+                <a:latin typeface="Calibri"/>
+              </a:defRPr>
+            </a:pPr>
+            <a:r>
+              <a:t>•  Real-time geofence verifies technician on-site labor hours</a:t>
+            </a:r>
+          </a:p>
+        </p:txBody>
+      </p:sp>
+      <p:sp>
+        <p:nvSpPr>
+          <p:cNvPr id="7" name="Rounded Rectangle 6"/>
+          <p:cNvSpPr/>
+          <p:nvPr/>
+        </p:nvSpPr>
+        <p:spPr>
+          <a:xfrm>
+            <a:off x="4404360" y="1920240"/>
+            <a:ext cx="3352800" cy="4114800"/>
+          </a:xfrm>
+          <a:prstGeom prst="roundRect">
+            <a:avLst/>
+          </a:prstGeom>
+          <a:solidFill>
+            <a:srgbClr val="F8FAFC"/>
+          </a:solidFill>
+          <a:ln w="12700">
+            <a:solidFill>
+              <a:srgbClr val="CBD5E1"/>
+            </a:solidFill>
+          </a:ln>
+        </p:spPr>
+        <p:style>
+          <a:lnRef idx="1">
+            <a:schemeClr val="accent1"/>
+          </a:lnRef>
+          <a:fillRef idx="3">
+            <a:schemeClr val="accent1"/>
+          </a:fillRef>
+          <a:effectRef idx="2">
+            <a:schemeClr val="accent1"/>
+          </a:effectRef>
+          <a:fontRef idx="minor">
+            <a:schemeClr val="lt1"/>
+          </a:fontRef>
+        </p:style>
+        <p:txBody>
+          <a:bodyPr rtlCol="0" anchor="ctr"/>
+          <a:lstStyle/>
+          <a:p>
+            <a:pPr algn="ctr"/>
+          </a:p>
+        </p:txBody>
+      </p:sp>
+      <p:sp>
+        <p:nvSpPr>
+          <p:cNvPr id="8" name="TextBox 7"/>
           <p:cNvSpPr txBox="1"/>
           <p:nvPr/>
         </p:nvSpPr>
         <p:spPr>
           <a:xfrm>
-            <a:off x="731520" y="6309360"/>
-            <a:ext cx="10698480" cy="365760"/>
+            <a:off x="4678680" y="2194560"/>
+            <a:ext cx="2804160" cy="3566160"/>
           </a:xfrm>
           <a:prstGeom prst="rect">
             <a:avLst/>
@@ -4024,6 +4264,225 @@
           <a:noFill/>
         </p:spPr>
         <p:txBody>
+          <a:bodyPr wrap="square">
+            <a:spAutoFit/>
+          </a:bodyPr>
+          <a:lstStyle/>
+          <a:p>
+            <a:pPr>
+              <a:spcAft>
+                <a:spcPts val="1000"/>
+              </a:spcAft>
+              <a:defRPr sz="1500" b="1">
+                <a:solidFill>
+                  <a:srgbClr val="0F172A"/>
+                </a:solidFill>
+                <a:latin typeface="Calibri"/>
+              </a:defRPr>
+            </a:pPr>
+            <a:r>
+              <a:t>2. Offline Field Invoicing</a:t>
+            </a:r>
+          </a:p>
+          <a:p>
+            <a:pPr>
+              <a:spcAft>
+                <a:spcPts val="600"/>
+              </a:spcAft>
+              <a:defRPr sz="1100">
+                <a:solidFill>
+                  <a:srgbClr val="334155"/>
+                </a:solidFill>
+                <a:latin typeface="Calibri"/>
+              </a:defRPr>
+            </a:pPr>
+            <a:r>
+              <a:t>•  Operates seamlessly in basements and dead zones</a:t>
+            </a:r>
+          </a:p>
+          <a:p>
+            <a:pPr>
+              <a:spcAft>
+                <a:spcPts val="600"/>
+              </a:spcAft>
+              <a:defRPr sz="1100">
+                <a:solidFill>
+                  <a:srgbClr val="334155"/>
+                </a:solidFill>
+                <a:latin typeface="Calibri"/>
+              </a:defRPr>
+            </a:pPr>
+            <a:r>
+              <a:t>•  Pre-loaded parts price books with margin rules</a:t>
+            </a:r>
+          </a:p>
+          <a:p>
+            <a:pPr>
+              <a:spcAft>
+                <a:spcPts val="600"/>
+              </a:spcAft>
+              <a:defRPr sz="1100">
+                <a:solidFill>
+                  <a:srgbClr val="334155"/>
+                </a:solidFill>
+                <a:latin typeface="Calibri"/>
+              </a:defRPr>
+            </a:pPr>
+            <a:r>
+              <a:t>•  One-tap customer sign-on-glass work approval</a:t>
+            </a:r>
+          </a:p>
+        </p:txBody>
+      </p:sp>
+      <p:sp>
+        <p:nvSpPr>
+          <p:cNvPr id="9" name="Rounded Rectangle 8"/>
+          <p:cNvSpPr/>
+          <p:nvPr/>
+        </p:nvSpPr>
+        <p:spPr>
+          <a:xfrm>
+            <a:off x="8077200" y="1920240"/>
+            <a:ext cx="3352800" cy="4114800"/>
+          </a:xfrm>
+          <a:prstGeom prst="roundRect">
+            <a:avLst/>
+          </a:prstGeom>
+          <a:solidFill>
+            <a:srgbClr val="F8FAFC"/>
+          </a:solidFill>
+          <a:ln w="12700">
+            <a:solidFill>
+              <a:srgbClr val="CBD5E1"/>
+            </a:solidFill>
+          </a:ln>
+        </p:spPr>
+        <p:style>
+          <a:lnRef idx="1">
+            <a:schemeClr val="accent1"/>
+          </a:lnRef>
+          <a:fillRef idx="3">
+            <a:schemeClr val="accent1"/>
+          </a:fillRef>
+          <a:effectRef idx="2">
+            <a:schemeClr val="accent1"/>
+          </a:effectRef>
+          <a:fontRef idx="minor">
+            <a:schemeClr val="lt1"/>
+          </a:fontRef>
+        </p:style>
+        <p:txBody>
+          <a:bodyPr rtlCol="0" anchor="ctr"/>
+          <a:lstStyle/>
+          <a:p>
+            <a:pPr algn="ctr"/>
+          </a:p>
+        </p:txBody>
+      </p:sp>
+      <p:sp>
+        <p:nvSpPr>
+          <p:cNvPr id="10" name="TextBox 9"/>
+          <p:cNvSpPr txBox="1"/>
+          <p:nvPr/>
+        </p:nvSpPr>
+        <p:spPr>
+          <a:xfrm>
+            <a:off x="8351520" y="2194560"/>
+            <a:ext cx="2804160" cy="3566160"/>
+          </a:xfrm>
+          <a:prstGeom prst="rect">
+            <a:avLst/>
+          </a:prstGeom>
+          <a:noFill/>
+        </p:spPr>
+        <p:txBody>
+          <a:bodyPr wrap="square">
+            <a:spAutoFit/>
+          </a:bodyPr>
+          <a:lstStyle/>
+          <a:p>
+            <a:pPr>
+              <a:spcAft>
+                <a:spcPts val="1000"/>
+              </a:spcAft>
+              <a:defRPr sz="1500" b="1">
+                <a:solidFill>
+                  <a:srgbClr val="0F172A"/>
+                </a:solidFill>
+                <a:latin typeface="Calibri"/>
+              </a:defRPr>
+            </a:pPr>
+            <a:r>
+              <a:t>3. Integrated Mobile Payments</a:t>
+            </a:r>
+          </a:p>
+          <a:p>
+            <a:pPr>
+              <a:spcAft>
+                <a:spcPts val="600"/>
+              </a:spcAft>
+              <a:defRPr sz="1100">
+                <a:solidFill>
+                  <a:srgbClr val="334155"/>
+                </a:solidFill>
+                <a:latin typeface="Calibri"/>
+              </a:defRPr>
+            </a:pPr>
+            <a:r>
+              <a:t>•  Tap-to-Pay and card reader payment capture on-site</a:t>
+            </a:r>
+          </a:p>
+          <a:p>
+            <a:pPr>
+              <a:spcAft>
+                <a:spcPts val="600"/>
+              </a:spcAft>
+              <a:defRPr sz="1100">
+                <a:solidFill>
+                  <a:srgbClr val="334155"/>
+                </a:solidFill>
+                <a:latin typeface="Calibri"/>
+              </a:defRPr>
+            </a:pPr>
+            <a:r>
+              <a:t>•  Automated QuickBooks &amp; Xero accounting ledger sync</a:t>
+            </a:r>
+          </a:p>
+          <a:p>
+            <a:pPr>
+              <a:spcAft>
+                <a:spcPts val="600"/>
+              </a:spcAft>
+              <a:defRPr sz="1100">
+                <a:solidFill>
+                  <a:srgbClr val="334155"/>
+                </a:solidFill>
+                <a:latin typeface="Calibri"/>
+              </a:defRPr>
+            </a:pPr>
+            <a:r>
+              <a:t>•  Cuts contractor DSO from 28 days down to 0 days</a:t>
+            </a:r>
+          </a:p>
+        </p:txBody>
+      </p:sp>
+      <p:sp>
+        <p:nvSpPr>
+          <p:cNvPr id="11" name="TextBox 10"/>
+          <p:cNvSpPr txBox="1"/>
+          <p:nvPr/>
+        </p:nvSpPr>
+        <p:spPr>
+          <a:xfrm>
+            <a:off x="731520" y="6309360"/>
+            <a:ext cx="10698480" cy="365760"/>
+          </a:xfrm>
+          <a:prstGeom prst="rect">
+            <a:avLst/>
+          </a:prstGeom>
+          <a:noFill/>
+        </p:spPr>
+        <p:txBody>
           <a:bodyPr wrap="none">
             <a:spAutoFit/>
           </a:bodyPr>
@@ -4038,7 +4497,7 @@
               </a:defRPr>
             </a:pPr>
             <a:r>
-              <a:t>Alexa Quintero — Angel Investor Presentation (10 Slides) · Slide 3 of 10</a:t>
+              <a:t>FieldPulse — Seed Investor Presentation · Slide 3 of 5</a:t>
             </a:r>
           </a:p>
         </p:txBody>
@@ -4138,7 +4597,7 @@
               </a:defRPr>
             </a:pPr>
             <a:r>
-              <a:t>ALEXA QUINTERO — ANGEL INVESTOR PRESENTATION (10 S</a:t>
+              <a:t>MARKET OPPORTUNITY</a:t>
             </a:r>
           </a:p>
           <a:p>
@@ -4151,7 +4610,23 @@
               </a:defRPr>
             </a:pPr>
             <a:r>
-              <a:t>Market Opportunity: $8.2B TAM</a:t>
+              <a:t>$8.2B Addressable Trade Contractor Software Market</a:t>
+            </a:r>
+          </a:p>
+          <a:p>
+            <a:pPr>
+              <a:spcBef>
+                <a:spcPts val="200"/>
+              </a:spcBef>
+              <a:defRPr sz="1200">
+                <a:solidFill>
+                  <a:srgbClr val="64748B"/>
+                </a:solidFill>
+                <a:latin typeface="Calibri"/>
+              </a:defRPr>
+            </a:pPr>
+            <a:r>
+              <a:t>Over 1.2 million trade service businesses across the United States and Canada</a:t>
             </a:r>
           </a:p>
         </p:txBody>
@@ -4201,14 +4676,59 @@
       </p:sp>
       <p:sp>
         <p:nvSpPr>
-          <p:cNvPr id="5" name="TextBox 4"/>
+          <p:cNvPr id="5" name="Rounded Rectangle 4"/>
+          <p:cNvSpPr/>
+          <p:nvPr/>
+        </p:nvSpPr>
+        <p:spPr>
+          <a:xfrm>
+            <a:off x="731520" y="1920240"/>
+            <a:ext cx="2468880" cy="4114800"/>
+          </a:xfrm>
+          <a:prstGeom prst="roundRect">
+            <a:avLst/>
+          </a:prstGeom>
+          <a:solidFill>
+            <a:srgbClr val="F8FAFC"/>
+          </a:solidFill>
+          <a:ln w="12700">
+            <a:solidFill>
+              <a:srgbClr val="CBD5E1"/>
+            </a:solidFill>
+          </a:ln>
+        </p:spPr>
+        <p:style>
+          <a:lnRef idx="1">
+            <a:schemeClr val="accent1"/>
+          </a:lnRef>
+          <a:fillRef idx="3">
+            <a:schemeClr val="accent1"/>
+          </a:fillRef>
+          <a:effectRef idx="2">
+            <a:schemeClr val="accent1"/>
+          </a:effectRef>
+          <a:fontRef idx="minor">
+            <a:schemeClr val="lt1"/>
+          </a:fontRef>
+        </p:style>
+        <p:txBody>
+          <a:bodyPr rtlCol="0" anchor="ctr"/>
+          <a:lstStyle/>
+          <a:p>
+            <a:pPr algn="ctr"/>
+          </a:p>
+        </p:txBody>
+      </p:sp>
+      <p:sp>
+        <p:nvSpPr>
+          <p:cNvPr id="6" name="TextBox 5"/>
           <p:cNvSpPr txBox="1"/>
           <p:nvPr/>
         </p:nvSpPr>
         <p:spPr>
           <a:xfrm>
-            <a:off x="731520" y="2011680"/>
-            <a:ext cx="10698480" cy="4114800"/>
+            <a:off x="1005840" y="2286000"/>
+            <a:ext cx="1920240" cy="3383280"/>
           </a:xfrm>
           <a:prstGeom prst="rect">
             <a:avLst/>
@@ -4222,73 +4742,106 @@
           <a:lstStyle/>
           <a:p>
             <a:pPr>
-              <a:lnSpc>
-                <a:spcPct val="125000"/>
-              </a:lnSpc>
               <a:spcAft>
-                <a:spcPts val="1400"/>
+                <a:spcPts val="1000"/>
               </a:spcAft>
-              <a:defRPr sz="1500">
-                <a:solidFill>
-                  <a:srgbClr val="1E293B"/>
-                </a:solidFill>
-                <a:latin typeface="Calibri"/>
-              </a:defRPr>
-            </a:pPr>
-            <a:r>
-              <a:t>•  1.2 million independent trade and field service businesses in the US &amp; Canada</a:t>
-            </a:r>
-          </a:p>
-          <a:p>
-            <a:pPr>
-              <a:lnSpc>
-                <a:spcPct val="125000"/>
-              </a:lnSpc>
+              <a:defRPr sz="3600" b="1">
+                <a:solidFill>
+                  <a:srgbClr val="2563EB"/>
+                </a:solidFill>
+                <a:latin typeface="Calibri"/>
+              </a:defRPr>
+            </a:pPr>
+            <a:r>
+              <a:t>$8.2B</a:t>
+            </a:r>
+          </a:p>
+          <a:p>
+            <a:pPr>
               <a:spcAft>
-                <a:spcPts val="1400"/>
+                <a:spcPts val="800"/>
               </a:spcAft>
-              <a:defRPr sz="1500">
-                <a:solidFill>
-                  <a:srgbClr val="1E293B"/>
-                </a:solidFill>
-                <a:latin typeface="Calibri"/>
-              </a:defRPr>
-            </a:pPr>
-            <a:r>
-              <a:t>•  $8.2B Serviceable Available Market across plumbing, electrical, and HVAC fleets</a:t>
-            </a:r>
-          </a:p>
-          <a:p>
-            <a:pPr>
-              <a:lnSpc>
-                <a:spcPct val="125000"/>
-              </a:lnSpc>
-              <a:spcAft>
-                <a:spcPts val="1400"/>
-              </a:spcAft>
-              <a:defRPr sz="1500">
-                <a:solidFill>
-                  <a:srgbClr val="1E293B"/>
-                </a:solidFill>
-                <a:latin typeface="Calibri"/>
-              </a:defRPr>
-            </a:pPr>
-            <a:r>
-              <a:t>•  Initial beachhead: 15,000 plumbing &amp; HVAC fleets with 5-25 service vans</a:t>
-            </a:r>
-          </a:p>
-        </p:txBody>
-      </p:sp>
-      <p:sp>
-        <p:nvSpPr>
-          <p:cNvPr id="6" name="TextBox 5"/>
+              <a:defRPr sz="1400" b="1">
+                <a:solidFill>
+                  <a:srgbClr val="0F172A"/>
+                </a:solidFill>
+                <a:latin typeface="Calibri"/>
+              </a:defRPr>
+            </a:pPr>
+            <a:r>
+              <a:t>Total Available Market</a:t>
+            </a:r>
+          </a:p>
+          <a:p>
+            <a:pPr>
+              <a:defRPr sz="1100">
+                <a:solidFill>
+                  <a:srgbClr val="64748B"/>
+                </a:solidFill>
+                <a:latin typeface="Calibri"/>
+              </a:defRPr>
+            </a:pPr>
+            <a:r>
+              <a:t>North American commercial &amp; residential trade contractors</a:t>
+            </a:r>
+          </a:p>
+        </p:txBody>
+      </p:sp>
+      <p:sp>
+        <p:nvSpPr>
+          <p:cNvPr id="7" name="Rounded Rectangle 6"/>
+          <p:cNvSpPr/>
+          <p:nvPr/>
+        </p:nvSpPr>
+        <p:spPr>
+          <a:xfrm>
+            <a:off x="3474720" y="1920240"/>
+            <a:ext cx="2468880" cy="4114800"/>
+          </a:xfrm>
+          <a:prstGeom prst="roundRect">
+            <a:avLst/>
+          </a:prstGeom>
+          <a:solidFill>
+            <a:srgbClr val="F8FAFC"/>
+          </a:solidFill>
+          <a:ln w="12700">
+            <a:solidFill>
+              <a:srgbClr val="CBD5E1"/>
+            </a:solidFill>
+          </a:ln>
+        </p:spPr>
+        <p:style>
+          <a:lnRef idx="1">
+            <a:schemeClr val="accent1"/>
+          </a:lnRef>
+          <a:fillRef idx="3">
+            <a:schemeClr val="accent1"/>
+          </a:fillRef>
+          <a:effectRef idx="2">
+            <a:schemeClr val="accent1"/>
+          </a:effectRef>
+          <a:fontRef idx="minor">
+            <a:schemeClr val="lt1"/>
+          </a:fontRef>
+        </p:style>
+        <p:txBody>
+          <a:bodyPr rtlCol="0" anchor="ctr"/>
+          <a:lstStyle/>
+          <a:p>
+            <a:pPr algn="ctr"/>
+          </a:p>
+        </p:txBody>
+      </p:sp>
+      <p:sp>
+        <p:nvSpPr>
+          <p:cNvPr id="8" name="TextBox 7"/>
           <p:cNvSpPr txBox="1"/>
           <p:nvPr/>
         </p:nvSpPr>
         <p:spPr>
           <a:xfrm>
-            <a:off x="731520" y="6309360"/>
-            <a:ext cx="10698480" cy="365760"/>
+            <a:off x="3749040" y="2286000"/>
+            <a:ext cx="1920240" cy="3383280"/>
           </a:xfrm>
           <a:prstGeom prst="rect">
             <a:avLst/>
@@ -4296,6 +4849,300 @@
           <a:noFill/>
         </p:spPr>
         <p:txBody>
+          <a:bodyPr wrap="square">
+            <a:spAutoFit/>
+          </a:bodyPr>
+          <a:lstStyle/>
+          <a:p>
+            <a:pPr>
+              <a:spcAft>
+                <a:spcPts val="1000"/>
+              </a:spcAft>
+              <a:defRPr sz="3600" b="1">
+                <a:solidFill>
+                  <a:srgbClr val="2563EB"/>
+                </a:solidFill>
+                <a:latin typeface="Calibri"/>
+              </a:defRPr>
+            </a:pPr>
+            <a:r>
+              <a:t>$1.4B</a:t>
+            </a:r>
+          </a:p>
+          <a:p>
+            <a:pPr>
+              <a:spcAft>
+                <a:spcPts val="800"/>
+              </a:spcAft>
+              <a:defRPr sz="1400" b="1">
+                <a:solidFill>
+                  <a:srgbClr val="0F172A"/>
+                </a:solidFill>
+                <a:latin typeface="Calibri"/>
+              </a:defRPr>
+            </a:pPr>
+            <a:r>
+              <a:t>Serviceable Market</a:t>
+            </a:r>
+          </a:p>
+          <a:p>
+            <a:pPr>
+              <a:defRPr sz="1100">
+                <a:solidFill>
+                  <a:srgbClr val="64748B"/>
+                </a:solidFill>
+                <a:latin typeface="Calibri"/>
+              </a:defRPr>
+            </a:pPr>
+            <a:r>
+              <a:t>Plumbing, electrical, and HVAC fleets with 5–30 vans</a:t>
+            </a:r>
+          </a:p>
+        </p:txBody>
+      </p:sp>
+      <p:sp>
+        <p:nvSpPr>
+          <p:cNvPr id="9" name="Rounded Rectangle 8"/>
+          <p:cNvSpPr/>
+          <p:nvPr/>
+        </p:nvSpPr>
+        <p:spPr>
+          <a:xfrm>
+            <a:off x="6217920" y="1920240"/>
+            <a:ext cx="2468880" cy="4114800"/>
+          </a:xfrm>
+          <a:prstGeom prst="roundRect">
+            <a:avLst/>
+          </a:prstGeom>
+          <a:solidFill>
+            <a:srgbClr val="F8FAFC"/>
+          </a:solidFill>
+          <a:ln w="12700">
+            <a:solidFill>
+              <a:srgbClr val="CBD5E1"/>
+            </a:solidFill>
+          </a:ln>
+        </p:spPr>
+        <p:style>
+          <a:lnRef idx="1">
+            <a:schemeClr val="accent1"/>
+          </a:lnRef>
+          <a:fillRef idx="3">
+            <a:schemeClr val="accent1"/>
+          </a:fillRef>
+          <a:effectRef idx="2">
+            <a:schemeClr val="accent1"/>
+          </a:effectRef>
+          <a:fontRef idx="minor">
+            <a:schemeClr val="lt1"/>
+          </a:fontRef>
+        </p:style>
+        <p:txBody>
+          <a:bodyPr rtlCol="0" anchor="ctr"/>
+          <a:lstStyle/>
+          <a:p>
+            <a:pPr algn="ctr"/>
+          </a:p>
+        </p:txBody>
+      </p:sp>
+      <p:sp>
+        <p:nvSpPr>
+          <p:cNvPr id="10" name="TextBox 9"/>
+          <p:cNvSpPr txBox="1"/>
+          <p:nvPr/>
+        </p:nvSpPr>
+        <p:spPr>
+          <a:xfrm>
+            <a:off x="6492240" y="2286000"/>
+            <a:ext cx="1920240" cy="3383280"/>
+          </a:xfrm>
+          <a:prstGeom prst="rect">
+            <a:avLst/>
+          </a:prstGeom>
+          <a:noFill/>
+        </p:spPr>
+        <p:txBody>
+          <a:bodyPr wrap="square">
+            <a:spAutoFit/>
+          </a:bodyPr>
+          <a:lstStyle/>
+          <a:p>
+            <a:pPr>
+              <a:spcAft>
+                <a:spcPts val="1000"/>
+              </a:spcAft>
+              <a:defRPr sz="3600" b="1">
+                <a:solidFill>
+                  <a:srgbClr val="2563EB"/>
+                </a:solidFill>
+                <a:latin typeface="Calibri"/>
+              </a:defRPr>
+            </a:pPr>
+            <a:r>
+              <a:t>180,000</a:t>
+            </a:r>
+          </a:p>
+          <a:p>
+            <a:pPr>
+              <a:spcAft>
+                <a:spcPts val="800"/>
+              </a:spcAft>
+              <a:defRPr sz="1400" b="1">
+                <a:solidFill>
+                  <a:srgbClr val="0F172A"/>
+                </a:solidFill>
+                <a:latin typeface="Calibri"/>
+              </a:defRPr>
+            </a:pPr>
+            <a:r>
+              <a:t>Target Fleet Businesses</a:t>
+            </a:r>
+          </a:p>
+          <a:p>
+            <a:pPr>
+              <a:defRPr sz="1100">
+                <a:solidFill>
+                  <a:srgbClr val="64748B"/>
+                </a:solidFill>
+                <a:latin typeface="Calibri"/>
+              </a:defRPr>
+            </a:pPr>
+            <a:r>
+              <a:t>Under-served by expensive legacy enterprise software</a:t>
+            </a:r>
+          </a:p>
+        </p:txBody>
+      </p:sp>
+      <p:sp>
+        <p:nvSpPr>
+          <p:cNvPr id="11" name="Rounded Rectangle 10"/>
+          <p:cNvSpPr/>
+          <p:nvPr/>
+        </p:nvSpPr>
+        <p:spPr>
+          <a:xfrm>
+            <a:off x="8961120" y="1920240"/>
+            <a:ext cx="2468880" cy="4114800"/>
+          </a:xfrm>
+          <a:prstGeom prst="roundRect">
+            <a:avLst/>
+          </a:prstGeom>
+          <a:solidFill>
+            <a:srgbClr val="F8FAFC"/>
+          </a:solidFill>
+          <a:ln w="12700">
+            <a:solidFill>
+              <a:srgbClr val="CBD5E1"/>
+            </a:solidFill>
+          </a:ln>
+        </p:spPr>
+        <p:style>
+          <a:lnRef idx="1">
+            <a:schemeClr val="accent1"/>
+          </a:lnRef>
+          <a:fillRef idx="3">
+            <a:schemeClr val="accent1"/>
+          </a:fillRef>
+          <a:effectRef idx="2">
+            <a:schemeClr val="accent1"/>
+          </a:effectRef>
+          <a:fontRef idx="minor">
+            <a:schemeClr val="lt1"/>
+          </a:fontRef>
+        </p:style>
+        <p:txBody>
+          <a:bodyPr rtlCol="0" anchor="ctr"/>
+          <a:lstStyle/>
+          <a:p>
+            <a:pPr algn="ctr"/>
+          </a:p>
+        </p:txBody>
+      </p:sp>
+      <p:sp>
+        <p:nvSpPr>
+          <p:cNvPr id="12" name="TextBox 11"/>
+          <p:cNvSpPr txBox="1"/>
+          <p:nvPr/>
+        </p:nvSpPr>
+        <p:spPr>
+          <a:xfrm>
+            <a:off x="9235440" y="2286000"/>
+            <a:ext cx="1920240" cy="3383280"/>
+          </a:xfrm>
+          <a:prstGeom prst="rect">
+            <a:avLst/>
+          </a:prstGeom>
+          <a:noFill/>
+        </p:spPr>
+        <p:txBody>
+          <a:bodyPr wrap="square">
+            <a:spAutoFit/>
+          </a:bodyPr>
+          <a:lstStyle/>
+          <a:p>
+            <a:pPr>
+              <a:spcAft>
+                <a:spcPts val="1000"/>
+              </a:spcAft>
+              <a:defRPr sz="3600" b="1">
+                <a:solidFill>
+                  <a:srgbClr val="2563EB"/>
+                </a:solidFill>
+                <a:latin typeface="Calibri"/>
+              </a:defRPr>
+            </a:pPr>
+            <a:r>
+              <a:t>$89 / mo</a:t>
+            </a:r>
+          </a:p>
+          <a:p>
+            <a:pPr>
+              <a:spcAft>
+                <a:spcPts val="800"/>
+              </a:spcAft>
+              <a:defRPr sz="1400" b="1">
+                <a:solidFill>
+                  <a:srgbClr val="0F172A"/>
+                </a:solidFill>
+                <a:latin typeface="Calibri"/>
+              </a:defRPr>
+            </a:pPr>
+            <a:r>
+              <a:t>Subscription Seat Fee</a:t>
+            </a:r>
+          </a:p>
+          <a:p>
+            <a:pPr>
+              <a:defRPr sz="1100">
+                <a:solidFill>
+                  <a:srgbClr val="64748B"/>
+                </a:solidFill>
+                <a:latin typeface="Calibri"/>
+              </a:defRPr>
+            </a:pPr>
+            <a:r>
+              <a:t>Per active technician with 92% gross software margin</a:t>
+            </a:r>
+          </a:p>
+        </p:txBody>
+      </p:sp>
+      <p:sp>
+        <p:nvSpPr>
+          <p:cNvPr id="13" name="TextBox 12"/>
+          <p:cNvSpPr txBox="1"/>
+          <p:nvPr/>
+        </p:nvSpPr>
+        <p:spPr>
+          <a:xfrm>
+            <a:off x="731520" y="6309360"/>
+            <a:ext cx="10698480" cy="365760"/>
+          </a:xfrm>
+          <a:prstGeom prst="rect">
+            <a:avLst/>
+          </a:prstGeom>
+          <a:noFill/>
+        </p:spPr>
+        <p:txBody>
           <a:bodyPr wrap="none">
             <a:spAutoFit/>
           </a:bodyPr>
@@ -4310,7 +5157,7 @@
               </a:defRPr>
             </a:pPr>
             <a:r>
-              <a:t>Alexa Quintero — Angel Investor Presentation (10 Slides) · Slide 4 of 10</a:t>
+              <a:t>FieldPulse — Seed Investor Presentation · Slide 4 of 5</a:t>
             </a:r>
           </a:p>
         </p:txBody>
@@ -4410,7 +5257,7 @@
               </a:defRPr>
             </a:pPr>
             <a:r>
-              <a:t>ALEXA QUINTERO — ANGEL INVESTOR PRESENTATION (10 S</a:t>
+              <a:t>TRACTION &amp; SEED ASK</a:t>
             </a:r>
           </a:p>
           <a:p>
@@ -4423,7 +5270,23 @@
               </a:defRPr>
             </a:pPr>
             <a:r>
-              <a:t>Product Architecture &amp; Moat</a:t>
+              <a:t>Traction Benchmarks &amp; $1.8M Seed Financing Round</a:t>
+            </a:r>
+          </a:p>
+          <a:p>
+            <a:pPr>
+              <a:spcBef>
+                <a:spcPts val="200"/>
+              </a:spcBef>
+              <a:defRPr sz="1200">
+                <a:solidFill>
+                  <a:srgbClr val="64748B"/>
+                </a:solidFill>
+                <a:latin typeface="Calibri"/>
+              </a:defRPr>
+            </a:pPr>
+            <a:r>
+              <a:t>Accelerating engineering velocity and mid-market field sales expansion</a:t>
             </a:r>
           </a:p>
         </p:txBody>
@@ -4473,157 +5336,25 @@
       </p:sp>
       <p:sp>
         <p:nvSpPr>
-          <p:cNvPr id="5" name="TextBox 4"/>
-          <p:cNvSpPr txBox="1"/>
-          <p:nvPr/>
-        </p:nvSpPr>
-        <p:spPr>
-          <a:xfrm>
-            <a:off x="731520" y="2011680"/>
-            <a:ext cx="10698480" cy="4114800"/>
-          </a:xfrm>
-          <a:prstGeom prst="rect">
-            <a:avLst/>
-          </a:prstGeom>
-          <a:noFill/>
-        </p:spPr>
-        <p:txBody>
-          <a:bodyPr wrap="square">
-            <a:spAutoFit/>
-          </a:bodyPr>
-          <a:lstStyle/>
-          <a:p>
-            <a:pPr>
-              <a:lnSpc>
-                <a:spcPct val="125000"/>
-              </a:lnSpc>
-              <a:spcAft>
-                <a:spcPts val="1400"/>
-              </a:spcAft>
-              <a:defRPr sz="1500">
-                <a:solidFill>
-                  <a:srgbClr val="1E293B"/>
-                </a:solidFill>
-                <a:latin typeface="Calibri"/>
-              </a:defRPr>
-            </a:pPr>
-            <a:r>
-              <a:t>•  Native offline-first mobile sync engine</a:t>
-            </a:r>
-          </a:p>
-          <a:p>
-            <a:pPr>
-              <a:lnSpc>
-                <a:spcPct val="125000"/>
-              </a:lnSpc>
-              <a:spcAft>
-                <a:spcPts val="1400"/>
-              </a:spcAft>
-              <a:defRPr sz="1500">
-                <a:solidFill>
-                  <a:srgbClr val="1E293B"/>
-                </a:solidFill>
-                <a:latin typeface="Calibri"/>
-              </a:defRPr>
-            </a:pPr>
-            <a:r>
-              <a:t>•  Direct two-way accounting sync into QuickBooks and Xero</a:t>
-            </a:r>
-          </a:p>
-          <a:p>
-            <a:pPr>
-              <a:lnSpc>
-                <a:spcPct val="125000"/>
-              </a:lnSpc>
-              <a:spcAft>
-                <a:spcPts val="1400"/>
-              </a:spcAft>
-              <a:defRPr sz="1500">
-                <a:solidFill>
-                  <a:srgbClr val="1E293B"/>
-                </a:solidFill>
-                <a:latin typeface="Calibri"/>
-              </a:defRPr>
-            </a:pPr>
-            <a:r>
-              <a:t>•  Zero onboarding friction: operational within 24 hours of setup</a:t>
-            </a:r>
-          </a:p>
-        </p:txBody>
-      </p:sp>
-      <p:sp>
-        <p:nvSpPr>
-          <p:cNvPr id="6" name="TextBox 5"/>
-          <p:cNvSpPr txBox="1"/>
-          <p:nvPr/>
-        </p:nvSpPr>
-        <p:spPr>
-          <a:xfrm>
-            <a:off x="731520" y="6309360"/>
-            <a:ext cx="10698480" cy="365760"/>
-          </a:xfrm>
-          <a:prstGeom prst="rect">
-            <a:avLst/>
-          </a:prstGeom>
-          <a:noFill/>
-        </p:spPr>
-        <p:txBody>
-          <a:bodyPr wrap="none">
-            <a:spAutoFit/>
-          </a:bodyPr>
-          <a:lstStyle/>
-          <a:p>
-            <a:pPr>
-              <a:defRPr sz="900">
-                <a:solidFill>
-                  <a:srgbClr val="94A3B8"/>
-                </a:solidFill>
-                <a:latin typeface="Calibri"/>
-              </a:defRPr>
-            </a:pPr>
-            <a:r>
-              <a:t>Alexa Quintero — Angel Investor Presentation (10 Slides) · Slide 5 of 10</a:t>
-            </a:r>
-          </a:p>
-        </p:txBody>
-      </p:sp>
-    </p:spTree>
-  </p:cSld>
-  <p:clrMapOvr>
-    <a:masterClrMapping/>
-  </p:clrMapOvr>
-</p:sld>
-</file>
-
-<file path=ppt/slides/slide6.xml><?xml version="1.0" encoding="utf-8"?>
-<p:sld xmlns:a="http://schemas.openxmlformats.org/drawingml/2006/main" xmlns:p="http://schemas.openxmlformats.org/presentationml/2006/main" xmlns:r="http://schemas.openxmlformats.org/officeDocument/2006/relationships">
-  <p:cSld>
-    <p:spTree>
-      <p:nvGrpSpPr>
-        <p:cNvPr id="1" name=""/>
-        <p:cNvGrpSpPr/>
-        <p:nvPr/>
-      </p:nvGrpSpPr>
-      <p:grpSpPr/>
-      <p:sp>
-        <p:nvSpPr>
-          <p:cNvPr id="2" name="Rectangle 1"/>
+          <p:cNvPr id="5" name="Rounded Rectangle 4"/>
           <p:cNvSpPr/>
           <p:nvPr/>
         </p:nvSpPr>
         <p:spPr>
           <a:xfrm>
-            <a:off x="0" y="0"/>
-            <a:ext cx="12191695" cy="6858000"/>
-          </a:xfrm>
-          <a:prstGeom prst="rect">
+            <a:off x="731520" y="1920240"/>
+            <a:ext cx="3352800" cy="4114800"/>
+          </a:xfrm>
+          <a:prstGeom prst="roundRect">
             <a:avLst/>
           </a:prstGeom>
           <a:solidFill>
-            <a:srgbClr val="FFFFFF"/>
+            <a:srgbClr val="F8FAFC"/>
           </a:solidFill>
-          <a:ln>
-            <a:noFill/>
+          <a:ln w="12700">
+            <a:solidFill>
+              <a:srgbClr val="CBD5E1"/>
+            </a:solidFill>
           </a:ln>
         </p:spPr>
         <p:style>
@@ -4650,14 +5381,14 @@
       </p:sp>
       <p:sp>
         <p:nvSpPr>
-          <p:cNvPr id="3" name="TextBox 2"/>
+          <p:cNvPr id="6" name="TextBox 5"/>
           <p:cNvSpPr txBox="1"/>
           <p:nvPr/>
         </p:nvSpPr>
         <p:spPr>
           <a:xfrm>
-            <a:off x="731520" y="548640"/>
-            <a:ext cx="10698480" cy="1188720"/>
+            <a:off x="1005840" y="2194560"/>
+            <a:ext cx="2804160" cy="3566160"/>
           </a:xfrm>
           <a:prstGeom prst="rect">
             <a:avLst/>
@@ -4672,22 +5403,9 @@
           <a:p>
             <a:pPr>
               <a:spcAft>
-                <a:spcPts val="400"/>
+                <a:spcPts val="1000"/>
               </a:spcAft>
-              <a:defRPr sz="1000" b="1">
-                <a:solidFill>
-                  <a:srgbClr val="2563EB"/>
-                </a:solidFill>
-                <a:latin typeface="Calibri"/>
-              </a:defRPr>
-            </a:pPr>
-            <a:r>
-              <a:t>ALEXA QUINTERO — ANGEL INVESTOR PRESENTATION (10 S</a:t>
-            </a:r>
-          </a:p>
-          <a:p>
-            <a:pPr>
-              <a:defRPr sz="2200" b="1">
+              <a:defRPr sz="1500" b="1">
                 <a:solidFill>
                   <a:srgbClr val="0F172A"/>
                 </a:solidFill>
@@ -4695,30 +5413,80 @@
               </a:defRPr>
             </a:pPr>
             <a:r>
-              <a:t>Traction &amp; Early Unit Economics</a:t>
-            </a:r>
-          </a:p>
-        </p:txBody>
-      </p:sp>
-      <p:sp>
-        <p:nvSpPr>
-          <p:cNvPr id="4" name="Rectangle 3"/>
+              <a:t>Current Traction (Q3 2026)</a:t>
+            </a:r>
+          </a:p>
+          <a:p>
+            <a:pPr>
+              <a:spcAft>
+                <a:spcPts val="600"/>
+              </a:spcAft>
+              <a:defRPr sz="1100">
+                <a:solidFill>
+                  <a:srgbClr val="334155"/>
+                </a:solidFill>
+                <a:latin typeface="Calibri"/>
+              </a:defRPr>
+            </a:pPr>
+            <a:r>
+              <a:t>•  $310,000 Annual Recurring Revenue (ARR)</a:t>
+            </a:r>
+          </a:p>
+          <a:p>
+            <a:pPr>
+              <a:spcAft>
+                <a:spcPts val="600"/>
+              </a:spcAft>
+              <a:defRPr sz="1100">
+                <a:solidFill>
+                  <a:srgbClr val="334155"/>
+                </a:solidFill>
+                <a:latin typeface="Calibri"/>
+              </a:defRPr>
+            </a:pPr>
+            <a:r>
+              <a:t>•  42 Paid Contractor Fleets across 8 metropolitan markets</a:t>
+            </a:r>
+          </a:p>
+          <a:p>
+            <a:pPr>
+              <a:spcAft>
+                <a:spcPts val="600"/>
+              </a:spcAft>
+              <a:defRPr sz="1100">
+                <a:solidFill>
+                  <a:srgbClr val="334155"/>
+                </a:solidFill>
+                <a:latin typeface="Calibri"/>
+              </a:defRPr>
+            </a:pPr>
+            <a:r>
+              <a:t>•  98.4% Monthly Customer Retention with 4.9 App Store rating</a:t>
+            </a:r>
+          </a:p>
+        </p:txBody>
+      </p:sp>
+      <p:sp>
+        <p:nvSpPr>
+          <p:cNvPr id="7" name="Rounded Rectangle 6"/>
           <p:cNvSpPr/>
           <p:nvPr/>
         </p:nvSpPr>
         <p:spPr>
           <a:xfrm>
-            <a:off x="731520" y="1737360"/>
-            <a:ext cx="10698480" cy="13716"/>
-          </a:xfrm>
-          <a:prstGeom prst="rect">
+            <a:off x="4404360" y="1920240"/>
+            <a:ext cx="3352800" cy="4114800"/>
+          </a:xfrm>
+          <a:prstGeom prst="roundRect">
             <a:avLst/>
           </a:prstGeom>
           <a:solidFill>
-            <a:srgbClr val="E2E8F0"/>
+            <a:srgbClr val="F8FAFC"/>
           </a:solidFill>
-          <a:ln>
-            <a:noFill/>
+          <a:ln w="12700">
+            <a:solidFill>
+              <a:srgbClr val="CBD5E1"/>
+            </a:solidFill>
           </a:ln>
         </p:spPr>
         <p:style>
@@ -4745,14 +5513,14 @@
       </p:sp>
       <p:sp>
         <p:nvSpPr>
-          <p:cNvPr id="5" name="TextBox 4"/>
+          <p:cNvPr id="8" name="TextBox 7"/>
           <p:cNvSpPr txBox="1"/>
           <p:nvPr/>
         </p:nvSpPr>
         <p:spPr>
           <a:xfrm>
-            <a:off x="731520" y="2011680"/>
-            <a:ext cx="10698480" cy="4114800"/>
+            <a:off x="4678680" y="2194560"/>
+            <a:ext cx="2804160" cy="3566160"/>
           </a:xfrm>
           <a:prstGeom prst="rect">
             <a:avLst/>
@@ -4766,136 +5534,91 @@
           <a:lstStyle/>
           <a:p>
             <a:pPr>
-              <a:lnSpc>
-                <a:spcPct val="125000"/>
-              </a:lnSpc>
               <a:spcAft>
-                <a:spcPts val="1400"/>
+                <a:spcPts val="1000"/>
               </a:spcAft>
-              <a:defRPr sz="1500">
-                <a:solidFill>
-                  <a:srgbClr val="1E293B"/>
-                </a:solidFill>
-                <a:latin typeface="Calibri"/>
-              </a:defRPr>
-            </a:pPr>
-            <a:r>
-              <a:t>•  28 paid pilot contractors signed in first 90 days</a:t>
-            </a:r>
-          </a:p>
-          <a:p>
-            <a:pPr>
-              <a:lnSpc>
-                <a:spcPct val="125000"/>
-              </a:lnSpc>
+              <a:defRPr sz="1500" b="1">
+                <a:solidFill>
+                  <a:srgbClr val="0F172A"/>
+                </a:solidFill>
+                <a:latin typeface="Calibri"/>
+              </a:defRPr>
+            </a:pPr>
+            <a:r>
+              <a:t>Use of Seed Proceeds ($1.8M)</a:t>
+            </a:r>
+          </a:p>
+          <a:p>
+            <a:pPr>
               <a:spcAft>
-                <a:spcPts val="1400"/>
+                <a:spcPts val="600"/>
               </a:spcAft>
-              <a:defRPr sz="1500">
-                <a:solidFill>
-                  <a:srgbClr val="1E293B"/>
-                </a:solidFill>
-                <a:latin typeface="Calibri"/>
-              </a:defRPr>
-            </a:pPr>
-            <a:r>
-              <a:t>•  $14,200 Monthly Recurring Revenue ($507 average fleet ARPU)</a:t>
-            </a:r>
-          </a:p>
-          <a:p>
-            <a:pPr>
-              <a:lnSpc>
-                <a:spcPct val="125000"/>
-              </a:lnSpc>
+              <a:defRPr sz="1100">
+                <a:solidFill>
+                  <a:srgbClr val="334155"/>
+                </a:solidFill>
+                <a:latin typeface="Calibri"/>
+              </a:defRPr>
+            </a:pPr>
+            <a:r>
+              <a:t>•  60% Engineering: Automated parts inventory and AI quoting</a:t>
+            </a:r>
+          </a:p>
+          <a:p>
+            <a:pPr>
               <a:spcAft>
-                <a:spcPts val="1400"/>
+                <a:spcPts val="600"/>
               </a:spcAft>
-              <a:defRPr sz="1500">
-                <a:solidFill>
-                  <a:srgbClr val="1E293B"/>
-                </a:solidFill>
-                <a:latin typeface="Calibri"/>
-              </a:defRPr>
-            </a:pPr>
-            <a:r>
-              <a:t>•  Zero logo churn since launch with 4.9/5 mobile app rating</a:t>
-            </a:r>
-          </a:p>
-        </p:txBody>
-      </p:sp>
-      <p:sp>
-        <p:nvSpPr>
-          <p:cNvPr id="6" name="TextBox 5"/>
-          <p:cNvSpPr txBox="1"/>
-          <p:nvPr/>
-        </p:nvSpPr>
-        <p:spPr>
-          <a:xfrm>
-            <a:off x="731520" y="6309360"/>
-            <a:ext cx="10698480" cy="365760"/>
-          </a:xfrm>
-          <a:prstGeom prst="rect">
-            <a:avLst/>
-          </a:prstGeom>
-          <a:noFill/>
-        </p:spPr>
-        <p:txBody>
-          <a:bodyPr wrap="none">
-            <a:spAutoFit/>
-          </a:bodyPr>
-          <a:lstStyle/>
-          <a:p>
-            <a:pPr>
-              <a:defRPr sz="900">
-                <a:solidFill>
-                  <a:srgbClr val="94A3B8"/>
-                </a:solidFill>
-                <a:latin typeface="Calibri"/>
-              </a:defRPr>
-            </a:pPr>
-            <a:r>
-              <a:t>Alexa Quintero — Angel Investor Presentation (10 Slides) · Slide 6 of 10</a:t>
-            </a:r>
-          </a:p>
-        </p:txBody>
-      </p:sp>
-    </p:spTree>
-  </p:cSld>
-  <p:clrMapOvr>
-    <a:masterClrMapping/>
-  </p:clrMapOvr>
-</p:sld>
-</file>
-
-<file path=ppt/slides/slide7.xml><?xml version="1.0" encoding="utf-8"?>
-<p:sld xmlns:a="http://schemas.openxmlformats.org/drawingml/2006/main" xmlns:p="http://schemas.openxmlformats.org/presentationml/2006/main" xmlns:r="http://schemas.openxmlformats.org/officeDocument/2006/relationships">
-  <p:cSld>
-    <p:spTree>
-      <p:nvGrpSpPr>
-        <p:cNvPr id="1" name=""/>
-        <p:cNvGrpSpPr/>
-        <p:nvPr/>
-      </p:nvGrpSpPr>
-      <p:grpSpPr/>
-      <p:sp>
-        <p:nvSpPr>
-          <p:cNvPr id="2" name="Rectangle 1"/>
+              <a:defRPr sz="1100">
+                <a:solidFill>
+                  <a:srgbClr val="334155"/>
+                </a:solidFill>
+                <a:latin typeface="Calibri"/>
+              </a:defRPr>
+            </a:pPr>
+            <a:r>
+              <a:t>•  25% Inside Sales &amp; Trade Association Channel Marketing</a:t>
+            </a:r>
+          </a:p>
+          <a:p>
+            <a:pPr>
+              <a:spcAft>
+                <a:spcPts val="600"/>
+              </a:spcAft>
+              <a:defRPr sz="1100">
+                <a:solidFill>
+                  <a:srgbClr val="334155"/>
+                </a:solidFill>
+                <a:latin typeface="Calibri"/>
+              </a:defRPr>
+            </a:pPr>
+            <a:r>
+              <a:t>•  15% Customer Onboarding, Success &amp; Regulatory Compliance</a:t>
+            </a:r>
+          </a:p>
+        </p:txBody>
+      </p:sp>
+      <p:sp>
+        <p:nvSpPr>
+          <p:cNvPr id="9" name="Rounded Rectangle 8"/>
           <p:cNvSpPr/>
           <p:nvPr/>
         </p:nvSpPr>
         <p:spPr>
           <a:xfrm>
-            <a:off x="0" y="0"/>
-            <a:ext cx="12191695" cy="6858000"/>
-          </a:xfrm>
-          <a:prstGeom prst="rect">
+            <a:off x="8077200" y="1920240"/>
+            <a:ext cx="3352800" cy="4114800"/>
+          </a:xfrm>
+          <a:prstGeom prst="roundRect">
             <a:avLst/>
           </a:prstGeom>
           <a:solidFill>
-            <a:srgbClr val="FFFFFF"/>
+            <a:srgbClr val="F8FAFC"/>
           </a:solidFill>
-          <a:ln>
-            <a:noFill/>
+          <a:ln w="12700">
+            <a:solidFill>
+              <a:srgbClr val="CBD5E1"/>
+            </a:solidFill>
           </a:ln>
         </p:spPr>
         <p:style>
@@ -4922,14 +5645,14 @@
       </p:sp>
       <p:sp>
         <p:nvSpPr>
-          <p:cNvPr id="3" name="TextBox 2"/>
+          <p:cNvPr id="10" name="TextBox 9"/>
           <p:cNvSpPr txBox="1"/>
           <p:nvPr/>
         </p:nvSpPr>
         <p:spPr>
           <a:xfrm>
-            <a:off x="731520" y="548640"/>
-            <a:ext cx="10698480" cy="1188720"/>
+            <a:off x="8351520" y="2194560"/>
+            <a:ext cx="2804160" cy="3566160"/>
           </a:xfrm>
           <a:prstGeom prst="rect">
             <a:avLst/>
@@ -4944,22 +5667,9 @@
           <a:p>
             <a:pPr>
               <a:spcAft>
-                <a:spcPts val="400"/>
+                <a:spcPts val="1000"/>
               </a:spcAft>
-              <a:defRPr sz="1000" b="1">
-                <a:solidFill>
-                  <a:srgbClr val="2563EB"/>
-                </a:solidFill>
-                <a:latin typeface="Calibri"/>
-              </a:defRPr>
-            </a:pPr>
-            <a:r>
-              <a:t>ALEXA QUINTERO — ANGEL INVESTOR PRESENTATION (10 S</a:t>
-            </a:r>
-          </a:p>
-          <a:p>
-            <a:pPr>
-              <a:defRPr sz="2200" b="1">
+              <a:defRPr sz="1500" b="1">
                 <a:solidFill>
                   <a:srgbClr val="0F172A"/>
                 </a:solidFill>
@@ -4967,64 +5677,69 @@
               </a:defRPr>
             </a:pPr>
             <a:r>
-              <a:t>Go-To-Market Strategy</a:t>
-            </a:r>
-          </a:p>
-        </p:txBody>
-      </p:sp>
-      <p:sp>
-        <p:nvSpPr>
-          <p:cNvPr id="4" name="Rectangle 3"/>
-          <p:cNvSpPr/>
-          <p:nvPr/>
-        </p:nvSpPr>
-        <p:spPr>
-          <a:xfrm>
-            <a:off x="731520" y="1737360"/>
-            <a:ext cx="10698480" cy="13716"/>
-          </a:xfrm>
-          <a:prstGeom prst="rect">
-            <a:avLst/>
-          </a:prstGeom>
-          <a:solidFill>
-            <a:srgbClr val="E2E8F0"/>
-          </a:solidFill>
-          <a:ln>
-            <a:noFill/>
-          </a:ln>
-        </p:spPr>
-        <p:style>
-          <a:lnRef idx="1">
-            <a:schemeClr val="accent1"/>
-          </a:lnRef>
-          <a:fillRef idx="3">
-            <a:schemeClr val="accent1"/>
-          </a:fillRef>
-          <a:effectRef idx="2">
-            <a:schemeClr val="accent1"/>
-          </a:effectRef>
-          <a:fontRef idx="minor">
-            <a:schemeClr val="lt1"/>
-          </a:fontRef>
-        </p:style>
-        <p:txBody>
-          <a:bodyPr rtlCol="0" anchor="ctr"/>
-          <a:lstStyle/>
-          <a:p>
-            <a:pPr algn="ctr"/>
-          </a:p>
-        </p:txBody>
-      </p:sp>
-      <p:sp>
-        <p:nvSpPr>
-          <p:cNvPr id="5" name="TextBox 4"/>
+              <a:t>18-Month Target Milestones</a:t>
+            </a:r>
+          </a:p>
+          <a:p>
+            <a:pPr>
+              <a:spcAft>
+                <a:spcPts val="600"/>
+              </a:spcAft>
+              <a:defRPr sz="1100">
+                <a:solidFill>
+                  <a:srgbClr val="334155"/>
+                </a:solidFill>
+                <a:latin typeface="Calibri"/>
+              </a:defRPr>
+            </a:pPr>
+            <a:r>
+              <a:t>•  Expand from 42 to 240 active contractor fleets</a:t>
+            </a:r>
+          </a:p>
+          <a:p>
+            <a:pPr>
+              <a:spcAft>
+                <a:spcPts val="600"/>
+              </a:spcAft>
+              <a:defRPr sz="1100">
+                <a:solidFill>
+                  <a:srgbClr val="334155"/>
+                </a:solidFill>
+                <a:latin typeface="Calibri"/>
+              </a:defRPr>
+            </a:pPr>
+            <a:r>
+              <a:t>•  Scale ARR from $310k to $2.2M run-rate</a:t>
+            </a:r>
+          </a:p>
+          <a:p>
+            <a:pPr>
+              <a:spcAft>
+                <a:spcPts val="600"/>
+              </a:spcAft>
+              <a:defRPr sz="1100">
+                <a:solidFill>
+                  <a:srgbClr val="334155"/>
+                </a:solidFill>
+                <a:latin typeface="Calibri"/>
+              </a:defRPr>
+            </a:pPr>
+            <a:r>
+              <a:t>•  Position company for Tier 1 Series A growth round</a:t>
+            </a:r>
+          </a:p>
+        </p:txBody>
+      </p:sp>
+      <p:sp>
+        <p:nvSpPr>
+          <p:cNvPr id="11" name="TextBox 10"/>
           <p:cNvSpPr txBox="1"/>
           <p:nvPr/>
         </p:nvSpPr>
         <p:spPr>
           <a:xfrm>
-            <a:off x="731520" y="2011680"/>
-            <a:ext cx="10698480" cy="4114800"/>
+            <a:off x="731520" y="6309360"/>
+            <a:ext cx="10698480" cy="365760"/>
           </a:xfrm>
           <a:prstGeom prst="rect">
             <a:avLst/>
@@ -5032,86 +5747,6 @@
           <a:noFill/>
         </p:spPr>
         <p:txBody>
-          <a:bodyPr wrap="square">
-            <a:spAutoFit/>
-          </a:bodyPr>
-          <a:lstStyle/>
-          <a:p>
-            <a:pPr>
-              <a:lnSpc>
-                <a:spcPct val="125000"/>
-              </a:lnSpc>
-              <a:spcAft>
-                <a:spcPts val="1400"/>
-              </a:spcAft>
-              <a:defRPr sz="1500">
-                <a:solidFill>
-                  <a:srgbClr val="1E293B"/>
-                </a:solidFill>
-                <a:latin typeface="Calibri"/>
-              </a:defRPr>
-            </a:pPr>
-            <a:r>
-              <a:t>•  Direct local trade association partnerships and wholesale supplier distributor tie-ins</a:t>
-            </a:r>
-          </a:p>
-          <a:p>
-            <a:pPr>
-              <a:lnSpc>
-                <a:spcPct val="125000"/>
-              </a:lnSpc>
-              <a:spcAft>
-                <a:spcPts val="1400"/>
-              </a:spcAft>
-              <a:defRPr sz="1500">
-                <a:solidFill>
-                  <a:srgbClr val="1E293B"/>
-                </a:solidFill>
-                <a:latin typeface="Calibri"/>
-              </a:defRPr>
-            </a:pPr>
-            <a:r>
-              <a:t>•  Performance SEO focused on state contractor licensing lookup pages</a:t>
-            </a:r>
-          </a:p>
-          <a:p>
-            <a:pPr>
-              <a:lnSpc>
-                <a:spcPct val="125000"/>
-              </a:lnSpc>
-              <a:spcAft>
-                <a:spcPts val="1400"/>
-              </a:spcAft>
-              <a:defRPr sz="1500">
-                <a:solidFill>
-                  <a:srgbClr val="1E293B"/>
-                </a:solidFill>
-                <a:latin typeface="Calibri"/>
-              </a:defRPr>
-            </a:pPr>
-            <a:r>
-              <a:t>•  Low-friction 14-day free trial converting at 38% to paid annual tiers</a:t>
-            </a:r>
-          </a:p>
-        </p:txBody>
-      </p:sp>
-      <p:sp>
-        <p:nvSpPr>
-          <p:cNvPr id="6" name="TextBox 5"/>
-          <p:cNvSpPr txBox="1"/>
-          <p:nvPr/>
-        </p:nvSpPr>
-        <p:spPr>
-          <a:xfrm>
-            <a:off x="731520" y="6309360"/>
-            <a:ext cx="10698480" cy="365760"/>
-          </a:xfrm>
-          <a:prstGeom prst="rect">
-            <a:avLst/>
-          </a:prstGeom>
-          <a:noFill/>
-        </p:spPr>
-        <p:txBody>
           <a:bodyPr wrap="none">
             <a:spAutoFit/>
           </a:bodyPr>
@@ -5126,551 +5761,7 @@
               </a:defRPr>
             </a:pPr>
             <a:r>
-              <a:t>Alexa Quintero — Angel Investor Presentation (10 Slides) · Slide 7 of 10</a:t>
-            </a:r>
-          </a:p>
-        </p:txBody>
-      </p:sp>
-    </p:spTree>
-  </p:cSld>
-  <p:clrMapOvr>
-    <a:masterClrMapping/>
-  </p:clrMapOvr>
-</p:sld>
-</file>
-
-<file path=ppt/slides/slide8.xml><?xml version="1.0" encoding="utf-8"?>
-<p:sld xmlns:a="http://schemas.openxmlformats.org/drawingml/2006/main" xmlns:p="http://schemas.openxmlformats.org/presentationml/2006/main" xmlns:r="http://schemas.openxmlformats.org/officeDocument/2006/relationships">
-  <p:cSld>
-    <p:spTree>
-      <p:nvGrpSpPr>
-        <p:cNvPr id="1" name=""/>
-        <p:cNvGrpSpPr/>
-        <p:nvPr/>
-      </p:nvGrpSpPr>
-      <p:grpSpPr/>
-      <p:sp>
-        <p:nvSpPr>
-          <p:cNvPr id="2" name="Rectangle 1"/>
-          <p:cNvSpPr/>
-          <p:nvPr/>
-        </p:nvSpPr>
-        <p:spPr>
-          <a:xfrm>
-            <a:off x="0" y="0"/>
-            <a:ext cx="12191695" cy="6858000"/>
-          </a:xfrm>
-          <a:prstGeom prst="rect">
-            <a:avLst/>
-          </a:prstGeom>
-          <a:solidFill>
-            <a:srgbClr val="FFFFFF"/>
-          </a:solidFill>
-          <a:ln>
-            <a:noFill/>
-          </a:ln>
-        </p:spPr>
-        <p:style>
-          <a:lnRef idx="1">
-            <a:schemeClr val="accent1"/>
-          </a:lnRef>
-          <a:fillRef idx="3">
-            <a:schemeClr val="accent1"/>
-          </a:fillRef>
-          <a:effectRef idx="2">
-            <a:schemeClr val="accent1"/>
-          </a:effectRef>
-          <a:fontRef idx="minor">
-            <a:schemeClr val="lt1"/>
-          </a:fontRef>
-        </p:style>
-        <p:txBody>
-          <a:bodyPr rtlCol="0" anchor="ctr"/>
-          <a:lstStyle/>
-          <a:p>
-            <a:pPr algn="ctr"/>
-          </a:p>
-        </p:txBody>
-      </p:sp>
-      <p:sp>
-        <p:nvSpPr>
-          <p:cNvPr id="3" name="TextBox 2"/>
-          <p:cNvSpPr txBox="1"/>
-          <p:nvPr/>
-        </p:nvSpPr>
-        <p:spPr>
-          <a:xfrm>
-            <a:off x="731520" y="548640"/>
-            <a:ext cx="10698480" cy="1188720"/>
-          </a:xfrm>
-          <a:prstGeom prst="rect">
-            <a:avLst/>
-          </a:prstGeom>
-          <a:noFill/>
-        </p:spPr>
-        <p:txBody>
-          <a:bodyPr wrap="square">
-            <a:spAutoFit/>
-          </a:bodyPr>
-          <a:lstStyle/>
-          <a:p>
-            <a:pPr>
-              <a:spcAft>
-                <a:spcPts val="400"/>
-              </a:spcAft>
-              <a:defRPr sz="1000" b="1">
-                <a:solidFill>
-                  <a:srgbClr val="2563EB"/>
-                </a:solidFill>
-                <a:latin typeface="Calibri"/>
-              </a:defRPr>
-            </a:pPr>
-            <a:r>
-              <a:t>ALEXA QUINTERO — ANGEL INVESTOR PRESENTATION (10 S</a:t>
-            </a:r>
-          </a:p>
-          <a:p>
-            <a:pPr>
-              <a:defRPr sz="2200" b="1">
-                <a:solidFill>
-                  <a:srgbClr val="0F172A"/>
-                </a:solidFill>
-                <a:latin typeface="Calibri"/>
-              </a:defRPr>
-            </a:pPr>
-            <a:r>
-              <a:t>Competitive Matrix</a:t>
-            </a:r>
-          </a:p>
-        </p:txBody>
-      </p:sp>
-      <p:sp>
-        <p:nvSpPr>
-          <p:cNvPr id="4" name="Rectangle 3"/>
-          <p:cNvSpPr/>
-          <p:nvPr/>
-        </p:nvSpPr>
-        <p:spPr>
-          <a:xfrm>
-            <a:off x="731520" y="1737360"/>
-            <a:ext cx="10698480" cy="13716"/>
-          </a:xfrm>
-          <a:prstGeom prst="rect">
-            <a:avLst/>
-          </a:prstGeom>
-          <a:solidFill>
-            <a:srgbClr val="E2E8F0"/>
-          </a:solidFill>
-          <a:ln>
-            <a:noFill/>
-          </a:ln>
-        </p:spPr>
-        <p:style>
-          <a:lnRef idx="1">
-            <a:schemeClr val="accent1"/>
-          </a:lnRef>
-          <a:fillRef idx="3">
-            <a:schemeClr val="accent1"/>
-          </a:fillRef>
-          <a:effectRef idx="2">
-            <a:schemeClr val="accent1"/>
-          </a:effectRef>
-          <a:fontRef idx="minor">
-            <a:schemeClr val="lt1"/>
-          </a:fontRef>
-        </p:style>
-        <p:txBody>
-          <a:bodyPr rtlCol="0" anchor="ctr"/>
-          <a:lstStyle/>
-          <a:p>
-            <a:pPr algn="ctr"/>
-          </a:p>
-        </p:txBody>
-      </p:sp>
-      <p:sp>
-        <p:nvSpPr>
-          <p:cNvPr id="5" name="TextBox 4"/>
-          <p:cNvSpPr txBox="1"/>
-          <p:nvPr/>
-        </p:nvSpPr>
-        <p:spPr>
-          <a:xfrm>
-            <a:off x="731520" y="2011680"/>
-            <a:ext cx="10698480" cy="4114800"/>
-          </a:xfrm>
-          <a:prstGeom prst="rect">
-            <a:avLst/>
-          </a:prstGeom>
-          <a:noFill/>
-        </p:spPr>
-        <p:txBody>
-          <a:bodyPr wrap="square">
-            <a:spAutoFit/>
-          </a:bodyPr>
-          <a:lstStyle/>
-          <a:p>
-            <a:pPr>
-              <a:lnSpc>
-                <a:spcPct val="125000"/>
-              </a:lnSpc>
-              <a:spcAft>
-                <a:spcPts val="1400"/>
-              </a:spcAft>
-              <a:defRPr sz="1500">
-                <a:solidFill>
-                  <a:srgbClr val="1E293B"/>
-                </a:solidFill>
-                <a:latin typeface="Calibri"/>
-              </a:defRPr>
-            </a:pPr>
-            <a:r>
-              <a:t>•  Incumbents charge $1,500+ setup fees and require 6-week onboarding cycles</a:t>
-            </a:r>
-          </a:p>
-          <a:p>
-            <a:pPr>
-              <a:lnSpc>
-                <a:spcPct val="125000"/>
-              </a:lnSpc>
-              <a:spcAft>
-                <a:spcPts val="1400"/>
-              </a:spcAft>
-              <a:defRPr sz="1500">
-                <a:solidFill>
-                  <a:srgbClr val="1E293B"/>
-                </a:solidFill>
-                <a:latin typeface="Calibri"/>
-              </a:defRPr>
-            </a:pPr>
-            <a:r>
-              <a:t>•  Legacy tools lack reliable offline caching when technicians work in basements</a:t>
-            </a:r>
-          </a:p>
-          <a:p>
-            <a:pPr>
-              <a:lnSpc>
-                <a:spcPct val="125000"/>
-              </a:lnSpc>
-              <a:spcAft>
-                <a:spcPts val="1400"/>
-              </a:spcAft>
-              <a:defRPr sz="1500">
-                <a:solidFill>
-                  <a:srgbClr val="1E293B"/>
-                </a:solidFill>
-                <a:latin typeface="Calibri"/>
-              </a:defRPr>
-            </a:pPr>
-            <a:r>
-              <a:t>•  FieldPulse delivers 3x faster time-to-value at 50% lower total cost of ownership</a:t>
-            </a:r>
-          </a:p>
-        </p:txBody>
-      </p:sp>
-      <p:sp>
-        <p:nvSpPr>
-          <p:cNvPr id="6" name="TextBox 5"/>
-          <p:cNvSpPr txBox="1"/>
-          <p:nvPr/>
-        </p:nvSpPr>
-        <p:spPr>
-          <a:xfrm>
-            <a:off x="731520" y="6309360"/>
-            <a:ext cx="10698480" cy="365760"/>
-          </a:xfrm>
-          <a:prstGeom prst="rect">
-            <a:avLst/>
-          </a:prstGeom>
-          <a:noFill/>
-        </p:spPr>
-        <p:txBody>
-          <a:bodyPr wrap="none">
-            <a:spAutoFit/>
-          </a:bodyPr>
-          <a:lstStyle/>
-          <a:p>
-            <a:pPr>
-              <a:defRPr sz="900">
-                <a:solidFill>
-                  <a:srgbClr val="94A3B8"/>
-                </a:solidFill>
-                <a:latin typeface="Calibri"/>
-              </a:defRPr>
-            </a:pPr>
-            <a:r>
-              <a:t>Alexa Quintero — Angel Investor Presentation (10 Slides) · Slide 8 of 10</a:t>
-            </a:r>
-          </a:p>
-        </p:txBody>
-      </p:sp>
-    </p:spTree>
-  </p:cSld>
-  <p:clrMapOvr>
-    <a:masterClrMapping/>
-  </p:clrMapOvr>
-</p:sld>
-</file>
-
-<file path=ppt/slides/slide9.xml><?xml version="1.0" encoding="utf-8"?>
-<p:sld xmlns:a="http://schemas.openxmlformats.org/drawingml/2006/main" xmlns:p="http://schemas.openxmlformats.org/presentationml/2006/main" xmlns:r="http://schemas.openxmlformats.org/officeDocument/2006/relationships">
-  <p:cSld>
-    <p:spTree>
-      <p:nvGrpSpPr>
-        <p:cNvPr id="1" name=""/>
-        <p:cNvGrpSpPr/>
-        <p:nvPr/>
-      </p:nvGrpSpPr>
-      <p:grpSpPr/>
-      <p:sp>
-        <p:nvSpPr>
-          <p:cNvPr id="2" name="Rectangle 1"/>
-          <p:cNvSpPr/>
-          <p:nvPr/>
-        </p:nvSpPr>
-        <p:spPr>
-          <a:xfrm>
-            <a:off x="0" y="0"/>
-            <a:ext cx="12191695" cy="6858000"/>
-          </a:xfrm>
-          <a:prstGeom prst="rect">
-            <a:avLst/>
-          </a:prstGeom>
-          <a:solidFill>
-            <a:srgbClr val="FFFFFF"/>
-          </a:solidFill>
-          <a:ln>
-            <a:noFill/>
-          </a:ln>
-        </p:spPr>
-        <p:style>
-          <a:lnRef idx="1">
-            <a:schemeClr val="accent1"/>
-          </a:lnRef>
-          <a:fillRef idx="3">
-            <a:schemeClr val="accent1"/>
-          </a:fillRef>
-          <a:effectRef idx="2">
-            <a:schemeClr val="accent1"/>
-          </a:effectRef>
-          <a:fontRef idx="minor">
-            <a:schemeClr val="lt1"/>
-          </a:fontRef>
-        </p:style>
-        <p:txBody>
-          <a:bodyPr rtlCol="0" anchor="ctr"/>
-          <a:lstStyle/>
-          <a:p>
-            <a:pPr algn="ctr"/>
-          </a:p>
-        </p:txBody>
-      </p:sp>
-      <p:sp>
-        <p:nvSpPr>
-          <p:cNvPr id="3" name="TextBox 2"/>
-          <p:cNvSpPr txBox="1"/>
-          <p:nvPr/>
-        </p:nvSpPr>
-        <p:spPr>
-          <a:xfrm>
-            <a:off x="731520" y="548640"/>
-            <a:ext cx="10698480" cy="1188720"/>
-          </a:xfrm>
-          <a:prstGeom prst="rect">
-            <a:avLst/>
-          </a:prstGeom>
-          <a:noFill/>
-        </p:spPr>
-        <p:txBody>
-          <a:bodyPr wrap="square">
-            <a:spAutoFit/>
-          </a:bodyPr>
-          <a:lstStyle/>
-          <a:p>
-            <a:pPr>
-              <a:spcAft>
-                <a:spcPts val="400"/>
-              </a:spcAft>
-              <a:defRPr sz="1000" b="1">
-                <a:solidFill>
-                  <a:srgbClr val="2563EB"/>
-                </a:solidFill>
-                <a:latin typeface="Calibri"/>
-              </a:defRPr>
-            </a:pPr>
-            <a:r>
-              <a:t>ALEXA QUINTERO — ANGEL INVESTOR PRESENTATION (10 S</a:t>
-            </a:r>
-          </a:p>
-          <a:p>
-            <a:pPr>
-              <a:defRPr sz="2200" b="1">
-                <a:solidFill>
-                  <a:srgbClr val="0F172A"/>
-                </a:solidFill>
-                <a:latin typeface="Calibri"/>
-              </a:defRPr>
-            </a:pPr>
-            <a:r>
-              <a:t>Financial Projections (3-Year Target)</a:t>
-            </a:r>
-          </a:p>
-        </p:txBody>
-      </p:sp>
-      <p:sp>
-        <p:nvSpPr>
-          <p:cNvPr id="4" name="Rectangle 3"/>
-          <p:cNvSpPr/>
-          <p:nvPr/>
-        </p:nvSpPr>
-        <p:spPr>
-          <a:xfrm>
-            <a:off x="731520" y="1737360"/>
-            <a:ext cx="10698480" cy="13716"/>
-          </a:xfrm>
-          <a:prstGeom prst="rect">
-            <a:avLst/>
-          </a:prstGeom>
-          <a:solidFill>
-            <a:srgbClr val="E2E8F0"/>
-          </a:solidFill>
-          <a:ln>
-            <a:noFill/>
-          </a:ln>
-        </p:spPr>
-        <p:style>
-          <a:lnRef idx="1">
-            <a:schemeClr val="accent1"/>
-          </a:lnRef>
-          <a:fillRef idx="3">
-            <a:schemeClr val="accent1"/>
-          </a:fillRef>
-          <a:effectRef idx="2">
-            <a:schemeClr val="accent1"/>
-          </a:effectRef>
-          <a:fontRef idx="minor">
-            <a:schemeClr val="lt1"/>
-          </a:fontRef>
-        </p:style>
-        <p:txBody>
-          <a:bodyPr rtlCol="0" anchor="ctr"/>
-          <a:lstStyle/>
-          <a:p>
-            <a:pPr algn="ctr"/>
-          </a:p>
-        </p:txBody>
-      </p:sp>
-      <p:sp>
-        <p:nvSpPr>
-          <p:cNvPr id="5" name="TextBox 4"/>
-          <p:cNvSpPr txBox="1"/>
-          <p:nvPr/>
-        </p:nvSpPr>
-        <p:spPr>
-          <a:xfrm>
-            <a:off x="731520" y="2011680"/>
-            <a:ext cx="10698480" cy="4114800"/>
-          </a:xfrm>
-          <a:prstGeom prst="rect">
-            <a:avLst/>
-          </a:prstGeom>
-          <a:noFill/>
-        </p:spPr>
-        <p:txBody>
-          <a:bodyPr wrap="square">
-            <a:spAutoFit/>
-          </a:bodyPr>
-          <a:lstStyle/>
-          <a:p>
-            <a:pPr>
-              <a:lnSpc>
-                <a:spcPct val="125000"/>
-              </a:lnSpc>
-              <a:spcAft>
-                <a:spcPts val="1400"/>
-              </a:spcAft>
-              <a:defRPr sz="1500">
-                <a:solidFill>
-                  <a:srgbClr val="1E293B"/>
-                </a:solidFill>
-                <a:latin typeface="Calibri"/>
-              </a:defRPr>
-            </a:pPr>
-            <a:r>
-              <a:t>•  Year 1: 180 Fleets · $1.1M ARR · Gross Margin 82%</a:t>
-            </a:r>
-          </a:p>
-          <a:p>
-            <a:pPr>
-              <a:lnSpc>
-                <a:spcPct val="125000"/>
-              </a:lnSpc>
-              <a:spcAft>
-                <a:spcPts val="1400"/>
-              </a:spcAft>
-              <a:defRPr sz="1500">
-                <a:solidFill>
-                  <a:srgbClr val="1E293B"/>
-                </a:solidFill>
-                <a:latin typeface="Calibri"/>
-              </a:defRPr>
-            </a:pPr>
-            <a:r>
-              <a:t>•  Year 2: 650 Fleets · $3.9M ARR · Cash flow breakeven at Month 18</a:t>
-            </a:r>
-          </a:p>
-          <a:p>
-            <a:pPr>
-              <a:lnSpc>
-                <a:spcPct val="125000"/>
-              </a:lnSpc>
-              <a:spcAft>
-                <a:spcPts val="1400"/>
-              </a:spcAft>
-              <a:defRPr sz="1500">
-                <a:solidFill>
-                  <a:srgbClr val="1E293B"/>
-                </a:solidFill>
-                <a:latin typeface="Calibri"/>
-              </a:defRPr>
-            </a:pPr>
-            <a:r>
-              <a:t>•  Year 3: 2,100 Fleets · $12.8M ARR · 4.2x LTV/CAC ratio</a:t>
-            </a:r>
-          </a:p>
-        </p:txBody>
-      </p:sp>
-      <p:sp>
-        <p:nvSpPr>
-          <p:cNvPr id="6" name="TextBox 5"/>
-          <p:cNvSpPr txBox="1"/>
-          <p:nvPr/>
-        </p:nvSpPr>
-        <p:spPr>
-          <a:xfrm>
-            <a:off x="731520" y="6309360"/>
-            <a:ext cx="10698480" cy="365760"/>
-          </a:xfrm>
-          <a:prstGeom prst="rect">
-            <a:avLst/>
-          </a:prstGeom>
-          <a:noFill/>
-        </p:spPr>
-        <p:txBody>
-          <a:bodyPr wrap="none">
-            <a:spAutoFit/>
-          </a:bodyPr>
-          <a:lstStyle/>
-          <a:p>
-            <a:pPr>
-              <a:defRPr sz="900">
-                <a:solidFill>
-                  <a:srgbClr val="94A3B8"/>
-                </a:solidFill>
-                <a:latin typeface="Calibri"/>
-              </a:defRPr>
-            </a:pPr>
-            <a:r>
-              <a:t>Alexa Quintero — Angel Investor Presentation (10 Slides) · Slide 9 of 10</a:t>
+              <a:t>FieldPulse — Seed Investor Presentation · Slide 5 of 5</a:t>
             </a:r>
           </a:p>
         </p:txBody>

</xml_diff>